<commit_message>
feat(bni-v10): add s1 cover, s2 promise, s11 self-audit, s12 close
Task 2/5. 4-corner anchor:
- s1: "회사의 일하는 구조" 84pt + SSOD · 김지명
- s2: "오늘 가져가실 2가지" + ① SSOD ② 우리 회사
- s11: "우리 회사는?" + ☐ SoR ☐ SoE ☐ SoI (자기진단 cliff hanger)
- s12: 검정 + 우하 SSOD · 김지명만

Co-Authored-By: Claude Opus 4.7 (1M context) <noreply@anthropic.com>
</commit_message>
<xml_diff>
--- a/lectures/03_sor_framework/BNI_SoR_v10.pptx
+++ b/lectures/03_sor_framework/BNI_SoR_v10.pptx
@@ -3142,6 +3142,76 @@
           </a:p>
         </p:txBody>
       </p:sp>
+      <p:sp>
+        <p:nvSpPr>
+          <p:cNvPr id="3" name="TextBox 2"/>
+          <p:cNvSpPr txBox="1"/>
+          <p:nvPr/>
+        </p:nvSpPr>
+        <p:spPr>
+          <a:xfrm>
+            <a:off x="0" y="2651760"/>
+            <a:ext cx="12191695" cy="1371600"/>
+          </a:xfrm>
+          <a:prstGeom prst="rect">
+            <a:avLst/>
+          </a:prstGeom>
+          <a:noFill/>
+        </p:spPr>
+        <p:txBody>
+          <a:bodyPr wrap="none" lIns="0" rIns="0" tIns="0" bIns="0" anchor="ctr">
+            <a:spAutoFit/>
+          </a:bodyPr>
+          <a:lstStyle/>
+          <a:p>
+            <a:pPr algn="ctr"/>
+            <a:r>
+              <a:rPr sz="8400">
+                <a:solidFill>
+                  <a:srgbClr val="FFFFFF"/>
+                </a:solidFill>
+                <a:latin typeface="Pretendard Black"/>
+              </a:rPr>
+              <a:t>회사의 일하는 구조</a:t>
+            </a:r>
+          </a:p>
+        </p:txBody>
+      </p:sp>
+      <p:sp>
+        <p:nvSpPr>
+          <p:cNvPr id="4" name="TextBox 3"/>
+          <p:cNvSpPr txBox="1"/>
+          <p:nvPr/>
+        </p:nvSpPr>
+        <p:spPr>
+          <a:xfrm>
+            <a:off x="0" y="4206240"/>
+            <a:ext cx="12191695" cy="457200"/>
+          </a:xfrm>
+          <a:prstGeom prst="rect">
+            <a:avLst/>
+          </a:prstGeom>
+          <a:noFill/>
+        </p:spPr>
+        <p:txBody>
+          <a:bodyPr wrap="none">
+            <a:spAutoFit/>
+          </a:bodyPr>
+          <a:lstStyle/>
+          <a:p>
+            <a:pPr algn="ctr"/>
+            <a:r>
+              <a:rPr sz="2000">
+                <a:solidFill>
+                  <a:srgbClr val="FFFFFF"/>
+                </a:solidFill>
+                <a:latin typeface="Pretendard Light"/>
+              </a:rPr>
+              <a:t>SSOD · 김지명</a:t>
+            </a:r>
+          </a:p>
+        </p:txBody>
+      </p:sp>
     </p:spTree>
   </p:cSld>
   <p:clrMapOvr>
@@ -3334,6 +3404,112 @@
           </a:p>
         </p:txBody>
       </p:sp>
+      <p:sp>
+        <p:nvSpPr>
+          <p:cNvPr id="3" name="TextBox 2"/>
+          <p:cNvSpPr txBox="1"/>
+          <p:nvPr/>
+        </p:nvSpPr>
+        <p:spPr>
+          <a:xfrm>
+            <a:off x="0" y="1371600"/>
+            <a:ext cx="12191695" cy="1188720"/>
+          </a:xfrm>
+          <a:prstGeom prst="rect">
+            <a:avLst/>
+          </a:prstGeom>
+          <a:noFill/>
+        </p:spPr>
+        <p:txBody>
+          <a:bodyPr wrap="none" lIns="0" rIns="0" tIns="0" bIns="0" anchor="ctr">
+            <a:spAutoFit/>
+          </a:bodyPr>
+          <a:lstStyle/>
+          <a:p>
+            <a:pPr algn="ctr"/>
+            <a:r>
+              <a:rPr sz="9600">
+                <a:solidFill>
+                  <a:srgbClr val="FFFFFF"/>
+                </a:solidFill>
+                <a:latin typeface="Pretendard Black"/>
+              </a:rPr>
+              <a:t>우리 회사는?</a:t>
+            </a:r>
+          </a:p>
+        </p:txBody>
+      </p:sp>
+      <p:sp>
+        <p:nvSpPr>
+          <p:cNvPr id="4" name="TextBox 3"/>
+          <p:cNvSpPr txBox="1"/>
+          <p:nvPr/>
+        </p:nvSpPr>
+        <p:spPr>
+          <a:xfrm>
+            <a:off x="0" y="3383280"/>
+            <a:ext cx="12191695" cy="2743200"/>
+          </a:xfrm>
+          <a:prstGeom prst="rect">
+            <a:avLst/>
+          </a:prstGeom>
+          <a:noFill/>
+        </p:spPr>
+        <p:txBody>
+          <a:bodyPr wrap="none" anchor="t">
+            <a:spAutoFit/>
+          </a:bodyPr>
+          <a:lstStyle/>
+          <a:p>
+            <a:pPr algn="ctr">
+              <a:spcAft>
+                <a:spcPts val="1600"/>
+              </a:spcAft>
+            </a:pPr>
+            <a:r>
+              <a:rPr sz="3600">
+                <a:solidFill>
+                  <a:srgbClr val="666666"/>
+                </a:solidFill>
+                <a:latin typeface="Pretendard Light"/>
+              </a:rPr>
+              <a:t>☐  SoR — 데이터</a:t>
+            </a:r>
+          </a:p>
+          <a:p>
+            <a:pPr algn="ctr">
+              <a:spcAft>
+                <a:spcPts val="1600"/>
+              </a:spcAft>
+            </a:pPr>
+            <a:r>
+              <a:rPr sz="3600">
+                <a:solidFill>
+                  <a:srgbClr val="666666"/>
+                </a:solidFill>
+                <a:latin typeface="Pretendard Light"/>
+              </a:rPr>
+              <a:t>☐  SoE — 일</a:t>
+            </a:r>
+          </a:p>
+          <a:p>
+            <a:pPr algn="ctr">
+              <a:spcAft>
+                <a:spcPts val="1600"/>
+              </a:spcAft>
+            </a:pPr>
+            <a:r>
+              <a:rPr sz="3600">
+                <a:solidFill>
+                  <a:srgbClr val="666666"/>
+                </a:solidFill>
+                <a:latin typeface="Pretendard Light"/>
+              </a:rPr>
+              <a:t>☐  SoI — 판단</a:t>
+            </a:r>
+          </a:p>
+        </p:txBody>
+      </p:sp>
     </p:spTree>
   </p:cSld>
   <p:clrMapOvr>
@@ -3395,6 +3571,41 @@
           </a:p>
         </p:txBody>
       </p:sp>
+      <p:sp>
+        <p:nvSpPr>
+          <p:cNvPr id="3" name="TextBox 2"/>
+          <p:cNvSpPr txBox="1"/>
+          <p:nvPr/>
+        </p:nvSpPr>
+        <p:spPr>
+          <a:xfrm>
+            <a:off x="9601200" y="6263640"/>
+            <a:ext cx="2286000" cy="365760"/>
+          </a:xfrm>
+          <a:prstGeom prst="rect">
+            <a:avLst/>
+          </a:prstGeom>
+          <a:noFill/>
+        </p:spPr>
+        <p:txBody>
+          <a:bodyPr wrap="none">
+            <a:spAutoFit/>
+          </a:bodyPr>
+          <a:lstStyle/>
+          <a:p>
+            <a:pPr algn="r"/>
+            <a:r>
+              <a:rPr sz="1400">
+                <a:solidFill>
+                  <a:srgbClr val="FFFFFF"/>
+                </a:solidFill>
+                <a:latin typeface="Pretendard Light"/>
+              </a:rPr>
+              <a:t>SSOD · 김지명</a:t>
+            </a:r>
+          </a:p>
+        </p:txBody>
+      </p:sp>
     </p:spTree>
   </p:cSld>
   <p:clrMapOvr>
@@ -3522,6 +3733,96 @@
                 <a:latin typeface="Pretendard Black"/>
               </a:rPr>
               <a:t>SSOD</a:t>
+            </a:r>
+          </a:p>
+        </p:txBody>
+      </p:sp>
+      <p:sp>
+        <p:nvSpPr>
+          <p:cNvPr id="5" name="TextBox 4"/>
+          <p:cNvSpPr txBox="1"/>
+          <p:nvPr/>
+        </p:nvSpPr>
+        <p:spPr>
+          <a:xfrm>
+            <a:off x="0" y="1463040"/>
+            <a:ext cx="12191695" cy="822960"/>
+          </a:xfrm>
+          <a:prstGeom prst="rect">
+            <a:avLst/>
+          </a:prstGeom>
+          <a:noFill/>
+        </p:spPr>
+        <p:txBody>
+          <a:bodyPr wrap="none" lIns="0" rIns="0" tIns="0" bIns="0" anchor="ctr">
+            <a:spAutoFit/>
+          </a:bodyPr>
+          <a:lstStyle/>
+          <a:p>
+            <a:pPr algn="ctr"/>
+            <a:r>
+              <a:rPr sz="5600">
+                <a:solidFill>
+                  <a:srgbClr val="FFFFFF"/>
+                </a:solidFill>
+                <a:latin typeface="Pretendard Black"/>
+              </a:rPr>
+              <a:t>오늘 가져가실 2가지</a:t>
+            </a:r>
+          </a:p>
+        </p:txBody>
+      </p:sp>
+      <p:sp>
+        <p:nvSpPr>
+          <p:cNvPr id="6" name="TextBox 5"/>
+          <p:cNvSpPr txBox="1"/>
+          <p:nvPr/>
+        </p:nvSpPr>
+        <p:spPr>
+          <a:xfrm>
+            <a:off x="0" y="3017520"/>
+            <a:ext cx="12191695" cy="2743200"/>
+          </a:xfrm>
+          <a:prstGeom prst="rect">
+            <a:avLst/>
+          </a:prstGeom>
+          <a:noFill/>
+        </p:spPr>
+        <p:txBody>
+          <a:bodyPr wrap="none" lIns="0" rIns="0" anchor="t">
+            <a:spAutoFit/>
+          </a:bodyPr>
+          <a:lstStyle/>
+          <a:p>
+            <a:pPr algn="ctr">
+              <a:spcAft>
+                <a:spcPts val="2800"/>
+              </a:spcAft>
+            </a:pPr>
+            <a:r>
+              <a:rPr sz="4000">
+                <a:solidFill>
+                  <a:srgbClr val="FFFFFF"/>
+                </a:solidFill>
+                <a:latin typeface="Pretendard Light"/>
+              </a:rPr>
+              <a:t>①  SSOD는 무엇을 하는가?</a:t>
+            </a:r>
+          </a:p>
+          <a:p>
+            <a:pPr algn="ctr">
+              <a:spcAft>
+                <a:spcPts val="2800"/>
+              </a:spcAft>
+            </a:pPr>
+            <a:r>
+              <a:rPr sz="4000">
+                <a:solidFill>
+                  <a:srgbClr val="FFFFFF"/>
+                </a:solidFill>
+                <a:latin typeface="Pretendard Light"/>
+              </a:rPr>
+              <a:t>②  우리 회사는?</a:t>
             </a:r>
           </a:p>
         </p:txBody>

</xml_diff>

<commit_message>
feat(bni-v10): add s3-s6 credential punch (7년, 둘 다, 3→상장사, DX·AX)
Task 3/5. 자격 punch 4장:
- s3: "7년" 240pt 메가 + "B2B 컨설팅"
- s4: "둘 다" 160pt + Notion·n8n 배지 원색 (이중 앰버서더)
- s5: "3" 160pt → "상장사" 140pt (회색 화살표)
- s6: "DX · AX" 200pt + Digital · AI Transformation

Co-Authored-By: Claude Opus 4.7 (1M context) <noreply@anthropic.com>
</commit_message>
<xml_diff>
--- a/lectures/03_sor_framework/BNI_SoR_v10.pptx
+++ b/lectures/03_sor_framework/BNI_SoR_v10.pptx
@@ -3172,7 +3172,7 @@
                 </a:solidFill>
                 <a:latin typeface="Pretendard Black"/>
               </a:rPr>
-              <a:t>회사의 일하는 구조</a:t>
+              <a:t>AI 시대 일하는 구조</a:t>
             </a:r>
           </a:p>
         </p:txBody>
@@ -3958,6 +3958,76 @@
           </a:p>
         </p:txBody>
       </p:sp>
+      <p:sp>
+        <p:nvSpPr>
+          <p:cNvPr id="5" name="TextBox 4"/>
+          <p:cNvSpPr txBox="1"/>
+          <p:nvPr/>
+        </p:nvSpPr>
+        <p:spPr>
+          <a:xfrm>
+            <a:off x="0" y="1645920"/>
+            <a:ext cx="12191695" cy="3200400"/>
+          </a:xfrm>
+          <a:prstGeom prst="rect">
+            <a:avLst/>
+          </a:prstGeom>
+          <a:noFill/>
+        </p:spPr>
+        <p:txBody>
+          <a:bodyPr wrap="none" lIns="0" rIns="0" tIns="0" bIns="0" anchor="ctr">
+            <a:spAutoFit/>
+          </a:bodyPr>
+          <a:lstStyle/>
+          <a:p>
+            <a:pPr algn="ctr"/>
+            <a:r>
+              <a:rPr sz="24000">
+                <a:solidFill>
+                  <a:srgbClr val="FFFFFF"/>
+                </a:solidFill>
+                <a:latin typeface="Pretendard Black"/>
+              </a:rPr>
+              <a:t>7년</a:t>
+            </a:r>
+          </a:p>
+        </p:txBody>
+      </p:sp>
+      <p:sp>
+        <p:nvSpPr>
+          <p:cNvPr id="6" name="TextBox 5"/>
+          <p:cNvSpPr txBox="1"/>
+          <p:nvPr/>
+        </p:nvSpPr>
+        <p:spPr>
+          <a:xfrm>
+            <a:off x="0" y="4937760"/>
+            <a:ext cx="12191695" cy="457200"/>
+          </a:xfrm>
+          <a:prstGeom prst="rect">
+            <a:avLst/>
+          </a:prstGeom>
+          <a:noFill/>
+        </p:spPr>
+        <p:txBody>
+          <a:bodyPr wrap="none">
+            <a:spAutoFit/>
+          </a:bodyPr>
+          <a:lstStyle/>
+          <a:p>
+            <a:pPr algn="ctr"/>
+            <a:r>
+              <a:rPr sz="2400">
+                <a:solidFill>
+                  <a:srgbClr val="666666"/>
+                </a:solidFill>
+                <a:latin typeface="Pretendard Light"/>
+              </a:rPr>
+              <a:t>B2B 컨설팅</a:t>
+            </a:r>
+          </a:p>
+        </p:txBody>
+      </p:sp>
     </p:spTree>
   </p:cSld>
   <p:clrMapOvr>
@@ -4089,6 +4159,124 @@
           </a:p>
         </p:txBody>
       </p:sp>
+      <p:sp>
+        <p:nvSpPr>
+          <p:cNvPr id="5" name="TextBox 4"/>
+          <p:cNvSpPr txBox="1"/>
+          <p:nvPr/>
+        </p:nvSpPr>
+        <p:spPr>
+          <a:xfrm>
+            <a:off x="0" y="1280160"/>
+            <a:ext cx="12191695" cy="2011680"/>
+          </a:xfrm>
+          <a:prstGeom prst="rect">
+            <a:avLst/>
+          </a:prstGeom>
+          <a:noFill/>
+        </p:spPr>
+        <p:txBody>
+          <a:bodyPr wrap="none" lIns="0" rIns="0" tIns="0" bIns="0" anchor="ctr">
+            <a:spAutoFit/>
+          </a:bodyPr>
+          <a:lstStyle/>
+          <a:p>
+            <a:pPr algn="ctr"/>
+            <a:r>
+              <a:rPr sz="16000">
+                <a:solidFill>
+                  <a:srgbClr val="FFFFFF"/>
+                </a:solidFill>
+                <a:latin typeface="Pretendard Black"/>
+              </a:rPr>
+              <a:t>둘 다</a:t>
+            </a:r>
+          </a:p>
+        </p:txBody>
+      </p:sp>
+      <p:pic>
+        <p:nvPicPr>
+          <p:cNvPr id="6" name="Picture 5" descr="notion-ambassador-badge.png"/>
+          <p:cNvPicPr>
+            <a:picLocks noChangeAspect="1"/>
+          </p:cNvPicPr>
+          <p:nvPr/>
+        </p:nvPicPr>
+        <p:blipFill>
+          <a:blip r:embed="rId2"/>
+          <a:stretch>
+            <a:fillRect/>
+          </a:stretch>
+        </p:blipFill>
+        <p:spPr>
+          <a:xfrm>
+            <a:off x="3931920" y="4023360"/>
+            <a:ext cx="4163122" cy="1280160"/>
+          </a:xfrm>
+          <a:prstGeom prst="rect">
+            <a:avLst/>
+          </a:prstGeom>
+        </p:spPr>
+      </p:pic>
+      <p:pic>
+        <p:nvPicPr>
+          <p:cNvPr id="7" name="Picture 6" descr="n8n-amber-ssod-black.png"/>
+          <p:cNvPicPr>
+            <a:picLocks noChangeAspect="1"/>
+          </p:cNvPicPr>
+          <p:nvPr/>
+        </p:nvPicPr>
+        <p:blipFill>
+          <a:blip r:embed="rId3"/>
+          <a:stretch>
+            <a:fillRect/>
+          </a:stretch>
+        </p:blipFill>
+        <p:spPr>
+          <a:xfrm>
+            <a:off x="6675120" y="4023360"/>
+            <a:ext cx="4550387" cy="1280160"/>
+          </a:xfrm>
+          <a:prstGeom prst="rect">
+            <a:avLst/>
+          </a:prstGeom>
+        </p:spPr>
+      </p:pic>
+      <p:sp>
+        <p:nvSpPr>
+          <p:cNvPr id="8" name="TextBox 7"/>
+          <p:cNvSpPr txBox="1"/>
+          <p:nvPr/>
+        </p:nvSpPr>
+        <p:spPr>
+          <a:xfrm>
+            <a:off x="0" y="5669280"/>
+            <a:ext cx="12191695" cy="457200"/>
+          </a:xfrm>
+          <a:prstGeom prst="rect">
+            <a:avLst/>
+          </a:prstGeom>
+          <a:noFill/>
+        </p:spPr>
+        <p:txBody>
+          <a:bodyPr wrap="none">
+            <a:spAutoFit/>
+          </a:bodyPr>
+          <a:lstStyle/>
+          <a:p>
+            <a:pPr algn="ctr"/>
+            <a:r>
+              <a:rPr sz="2000">
+                <a:solidFill>
+                  <a:srgbClr val="666666"/>
+                </a:solidFill>
+                <a:latin typeface="Pretendard Light"/>
+              </a:rPr>
+              <a:t>글로벌 공식 앰버서더 — 한국에 쏘드뿐</a:t>
+            </a:r>
+          </a:p>
+        </p:txBody>
+      </p:sp>
     </p:spTree>
   </p:cSld>
   <p:clrMapOvr>
@@ -4220,6 +4408,94 @@
           </a:p>
         </p:txBody>
       </p:sp>
+      <p:sp>
+        <p:nvSpPr>
+          <p:cNvPr id="5" name="TextBox 4"/>
+          <p:cNvSpPr txBox="1"/>
+          <p:nvPr/>
+        </p:nvSpPr>
+        <p:spPr>
+          <a:xfrm>
+            <a:off x="0" y="2560320"/>
+            <a:ext cx="12191695" cy="1828800"/>
+          </a:xfrm>
+          <a:prstGeom prst="rect">
+            <a:avLst/>
+          </a:prstGeom>
+          <a:noFill/>
+        </p:spPr>
+        <p:txBody>
+          <a:bodyPr wrap="none" lIns="0" rIns="0" anchor="ctr">
+            <a:spAutoFit/>
+          </a:bodyPr>
+          <a:lstStyle/>
+          <a:p>
+            <a:pPr algn="ctr"/>
+            <a:r>
+              <a:rPr sz="16000">
+                <a:solidFill>
+                  <a:srgbClr val="FFFFFF"/>
+                </a:solidFill>
+                <a:latin typeface="Pretendard Black"/>
+              </a:rPr>
+              <a:t>3</a:t>
+            </a:r>
+            <a:r>
+              <a:rPr sz="12000">
+                <a:solidFill>
+                  <a:srgbClr val="666666"/>
+                </a:solidFill>
+                <a:latin typeface="Pretendard Black"/>
+              </a:rPr>
+              <a:t>   →   </a:t>
+            </a:r>
+            <a:r>
+              <a:rPr sz="14000">
+                <a:solidFill>
+                  <a:srgbClr val="FFFFFF"/>
+                </a:solidFill>
+                <a:latin typeface="Pretendard Black"/>
+              </a:rPr>
+              <a:t>상장사</a:t>
+            </a:r>
+          </a:p>
+        </p:txBody>
+      </p:sp>
+      <p:sp>
+        <p:nvSpPr>
+          <p:cNvPr id="6" name="TextBox 5"/>
+          <p:cNvSpPr txBox="1"/>
+          <p:nvPr/>
+        </p:nvSpPr>
+        <p:spPr>
+          <a:xfrm>
+            <a:off x="0" y="5120640"/>
+            <a:ext cx="12191695" cy="457200"/>
+          </a:xfrm>
+          <a:prstGeom prst="rect">
+            <a:avLst/>
+          </a:prstGeom>
+          <a:noFill/>
+        </p:spPr>
+        <p:txBody>
+          <a:bodyPr wrap="none">
+            <a:spAutoFit/>
+          </a:bodyPr>
+          <a:lstStyle/>
+          <a:p>
+            <a:pPr algn="ctr"/>
+            <a:r>
+              <a:rPr sz="2000">
+                <a:solidFill>
+                  <a:srgbClr val="666666"/>
+                </a:solidFill>
+                <a:latin typeface="Pretendard Light"/>
+              </a:rPr>
+              <a:t>직원 3명 사무실부터 상장사까지</a:t>
+            </a:r>
+          </a:p>
+        </p:txBody>
+      </p:sp>
     </p:spTree>
   </p:cSld>
   <p:clrMapOvr>
@@ -4347,6 +4623,76 @@
                 <a:latin typeface="Pretendard Black"/>
               </a:rPr>
               <a:t>SSOD</a:t>
+            </a:r>
+          </a:p>
+        </p:txBody>
+      </p:sp>
+      <p:sp>
+        <p:nvSpPr>
+          <p:cNvPr id="5" name="TextBox 4"/>
+          <p:cNvSpPr txBox="1"/>
+          <p:nvPr/>
+        </p:nvSpPr>
+        <p:spPr>
+          <a:xfrm>
+            <a:off x="0" y="2011680"/>
+            <a:ext cx="12191695" cy="2560320"/>
+          </a:xfrm>
+          <a:prstGeom prst="rect">
+            <a:avLst/>
+          </a:prstGeom>
+          <a:noFill/>
+        </p:spPr>
+        <p:txBody>
+          <a:bodyPr wrap="none" lIns="0" rIns="0" tIns="0" bIns="0" anchor="ctr">
+            <a:spAutoFit/>
+          </a:bodyPr>
+          <a:lstStyle/>
+          <a:p>
+            <a:pPr algn="ctr"/>
+            <a:r>
+              <a:rPr sz="20000">
+                <a:solidFill>
+                  <a:srgbClr val="FFFFFF"/>
+                </a:solidFill>
+                <a:latin typeface="Pretendard Black"/>
+              </a:rPr>
+              <a:t>DX · AX</a:t>
+            </a:r>
+          </a:p>
+        </p:txBody>
+      </p:sp>
+      <p:sp>
+        <p:nvSpPr>
+          <p:cNvPr id="6" name="TextBox 5"/>
+          <p:cNvSpPr txBox="1"/>
+          <p:nvPr/>
+        </p:nvSpPr>
+        <p:spPr>
+          <a:xfrm>
+            <a:off x="0" y="4937760"/>
+            <a:ext cx="12191695" cy="457200"/>
+          </a:xfrm>
+          <a:prstGeom prst="rect">
+            <a:avLst/>
+          </a:prstGeom>
+          <a:noFill/>
+        </p:spPr>
+        <p:txBody>
+          <a:bodyPr wrap="none">
+            <a:spAutoFit/>
+          </a:bodyPr>
+          <a:lstStyle/>
+          <a:p>
+            <a:pPr algn="ctr"/>
+            <a:r>
+              <a:rPr sz="2200">
+                <a:solidFill>
+                  <a:srgbClr val="666666"/>
+                </a:solidFill>
+                <a:latin typeface="Pretendard Light"/>
+              </a:rPr>
+              <a:t>Digital Transformation · AI Transformation</a:t>
             </a:r>
           </a:p>
         </p:txBody>

</xml_diff>

<commit_message>
feat(bni-v10): add s7-s9 SoR/SoE/SoI triplet via shared builder
Task 4/5. 공통 build_sox() 빌더 1개로 3장:
- s7: SoR / 데이터 / ERP · 고객 명단 · 매출
- s8: SoE / 일 / 카톡 · 노션 · 결재
- s9: SoI / 판단 / 사장님 · 대시보드 · AI

상단 회색 mono 영문 약어 voltage anchor + 중앙 한글 140pt punch + 하단 회색 예시.

Co-Authored-By: Claude Opus 4.7 (1M context) <noreply@anthropic.com>
</commit_message>
<xml_diff>
--- a/lectures/03_sor_framework/BNI_SoR_v10.pptx
+++ b/lectures/03_sor_framework/BNI_SoR_v10.pptx
@@ -4828,6 +4828,111 @@
           </a:p>
         </p:txBody>
       </p:sp>
+      <p:sp>
+        <p:nvSpPr>
+          <p:cNvPr id="5" name="TextBox 4"/>
+          <p:cNvSpPr txBox="1"/>
+          <p:nvPr/>
+        </p:nvSpPr>
+        <p:spPr>
+          <a:xfrm>
+            <a:off x="0" y="1463040"/>
+            <a:ext cx="12191695" cy="548640"/>
+          </a:xfrm>
+          <a:prstGeom prst="rect">
+            <a:avLst/>
+          </a:prstGeom>
+          <a:noFill/>
+        </p:spPr>
+        <p:txBody>
+          <a:bodyPr wrap="none">
+            <a:spAutoFit/>
+          </a:bodyPr>
+          <a:lstStyle/>
+          <a:p>
+            <a:pPr algn="ctr"/>
+            <a:r>
+              <a:rPr sz="3200">
+                <a:solidFill>
+                  <a:srgbClr val="666666"/>
+                </a:solidFill>
+                <a:latin typeface="SF Mono"/>
+              </a:rPr>
+              <a:t>SoR</a:t>
+            </a:r>
+          </a:p>
+        </p:txBody>
+      </p:sp>
+      <p:sp>
+        <p:nvSpPr>
+          <p:cNvPr id="6" name="TextBox 5"/>
+          <p:cNvSpPr txBox="1"/>
+          <p:nvPr/>
+        </p:nvSpPr>
+        <p:spPr>
+          <a:xfrm>
+            <a:off x="0" y="2468880"/>
+            <a:ext cx="12191695" cy="2194560"/>
+          </a:xfrm>
+          <a:prstGeom prst="rect">
+            <a:avLst/>
+          </a:prstGeom>
+          <a:noFill/>
+        </p:spPr>
+        <p:txBody>
+          <a:bodyPr wrap="none" lIns="0" rIns="0" tIns="0" bIns="0" anchor="ctr">
+            <a:spAutoFit/>
+          </a:bodyPr>
+          <a:lstStyle/>
+          <a:p>
+            <a:pPr algn="ctr"/>
+            <a:r>
+              <a:rPr sz="14000">
+                <a:solidFill>
+                  <a:srgbClr val="FFFFFF"/>
+                </a:solidFill>
+                <a:latin typeface="Pretendard Black"/>
+              </a:rPr>
+              <a:t>데이터</a:t>
+            </a:r>
+          </a:p>
+        </p:txBody>
+      </p:sp>
+      <p:sp>
+        <p:nvSpPr>
+          <p:cNvPr id="7" name="TextBox 6"/>
+          <p:cNvSpPr txBox="1"/>
+          <p:nvPr/>
+        </p:nvSpPr>
+        <p:spPr>
+          <a:xfrm>
+            <a:off x="0" y="4937760"/>
+            <a:ext cx="12191695" cy="457200"/>
+          </a:xfrm>
+          <a:prstGeom prst="rect">
+            <a:avLst/>
+          </a:prstGeom>
+          <a:noFill/>
+        </p:spPr>
+        <p:txBody>
+          <a:bodyPr wrap="none">
+            <a:spAutoFit/>
+          </a:bodyPr>
+          <a:lstStyle/>
+          <a:p>
+            <a:pPr algn="ctr"/>
+            <a:r>
+              <a:rPr sz="2200">
+                <a:solidFill>
+                  <a:srgbClr val="666666"/>
+                </a:solidFill>
+                <a:latin typeface="Pretendard Light"/>
+              </a:rPr>
+              <a:t>ERP · 고객 명단 · 매출</a:t>
+            </a:r>
+          </a:p>
+        </p:txBody>
+      </p:sp>
     </p:spTree>
   </p:cSld>
   <p:clrMapOvr>
@@ -4959,6 +5064,111 @@
           </a:p>
         </p:txBody>
       </p:sp>
+      <p:sp>
+        <p:nvSpPr>
+          <p:cNvPr id="5" name="TextBox 4"/>
+          <p:cNvSpPr txBox="1"/>
+          <p:nvPr/>
+        </p:nvSpPr>
+        <p:spPr>
+          <a:xfrm>
+            <a:off x="0" y="1463040"/>
+            <a:ext cx="12191695" cy="548640"/>
+          </a:xfrm>
+          <a:prstGeom prst="rect">
+            <a:avLst/>
+          </a:prstGeom>
+          <a:noFill/>
+        </p:spPr>
+        <p:txBody>
+          <a:bodyPr wrap="none">
+            <a:spAutoFit/>
+          </a:bodyPr>
+          <a:lstStyle/>
+          <a:p>
+            <a:pPr algn="ctr"/>
+            <a:r>
+              <a:rPr sz="3200">
+                <a:solidFill>
+                  <a:srgbClr val="666666"/>
+                </a:solidFill>
+                <a:latin typeface="SF Mono"/>
+              </a:rPr>
+              <a:t>SoE</a:t>
+            </a:r>
+          </a:p>
+        </p:txBody>
+      </p:sp>
+      <p:sp>
+        <p:nvSpPr>
+          <p:cNvPr id="6" name="TextBox 5"/>
+          <p:cNvSpPr txBox="1"/>
+          <p:nvPr/>
+        </p:nvSpPr>
+        <p:spPr>
+          <a:xfrm>
+            <a:off x="0" y="2468880"/>
+            <a:ext cx="12191695" cy="2194560"/>
+          </a:xfrm>
+          <a:prstGeom prst="rect">
+            <a:avLst/>
+          </a:prstGeom>
+          <a:noFill/>
+        </p:spPr>
+        <p:txBody>
+          <a:bodyPr wrap="none" lIns="0" rIns="0" tIns="0" bIns="0" anchor="ctr">
+            <a:spAutoFit/>
+          </a:bodyPr>
+          <a:lstStyle/>
+          <a:p>
+            <a:pPr algn="ctr"/>
+            <a:r>
+              <a:rPr sz="14000">
+                <a:solidFill>
+                  <a:srgbClr val="FFFFFF"/>
+                </a:solidFill>
+                <a:latin typeface="Pretendard Black"/>
+              </a:rPr>
+              <a:t>일</a:t>
+            </a:r>
+          </a:p>
+        </p:txBody>
+      </p:sp>
+      <p:sp>
+        <p:nvSpPr>
+          <p:cNvPr id="7" name="TextBox 6"/>
+          <p:cNvSpPr txBox="1"/>
+          <p:nvPr/>
+        </p:nvSpPr>
+        <p:spPr>
+          <a:xfrm>
+            <a:off x="0" y="4937760"/>
+            <a:ext cx="12191695" cy="457200"/>
+          </a:xfrm>
+          <a:prstGeom prst="rect">
+            <a:avLst/>
+          </a:prstGeom>
+          <a:noFill/>
+        </p:spPr>
+        <p:txBody>
+          <a:bodyPr wrap="none">
+            <a:spAutoFit/>
+          </a:bodyPr>
+          <a:lstStyle/>
+          <a:p>
+            <a:pPr algn="ctr"/>
+            <a:r>
+              <a:rPr sz="2200">
+                <a:solidFill>
+                  <a:srgbClr val="666666"/>
+                </a:solidFill>
+                <a:latin typeface="Pretendard Light"/>
+              </a:rPr>
+              <a:t>카톡 · 노션 · 결재</a:t>
+            </a:r>
+          </a:p>
+        </p:txBody>
+      </p:sp>
     </p:spTree>
   </p:cSld>
   <p:clrMapOvr>
@@ -5086,6 +5296,111 @@
                 <a:latin typeface="Pretendard Black"/>
               </a:rPr>
               <a:t>SSOD</a:t>
+            </a:r>
+          </a:p>
+        </p:txBody>
+      </p:sp>
+      <p:sp>
+        <p:nvSpPr>
+          <p:cNvPr id="5" name="TextBox 4"/>
+          <p:cNvSpPr txBox="1"/>
+          <p:nvPr/>
+        </p:nvSpPr>
+        <p:spPr>
+          <a:xfrm>
+            <a:off x="0" y="1463040"/>
+            <a:ext cx="12191695" cy="548640"/>
+          </a:xfrm>
+          <a:prstGeom prst="rect">
+            <a:avLst/>
+          </a:prstGeom>
+          <a:noFill/>
+        </p:spPr>
+        <p:txBody>
+          <a:bodyPr wrap="none">
+            <a:spAutoFit/>
+          </a:bodyPr>
+          <a:lstStyle/>
+          <a:p>
+            <a:pPr algn="ctr"/>
+            <a:r>
+              <a:rPr sz="3200">
+                <a:solidFill>
+                  <a:srgbClr val="666666"/>
+                </a:solidFill>
+                <a:latin typeface="SF Mono"/>
+              </a:rPr>
+              <a:t>SoI</a:t>
+            </a:r>
+          </a:p>
+        </p:txBody>
+      </p:sp>
+      <p:sp>
+        <p:nvSpPr>
+          <p:cNvPr id="6" name="TextBox 5"/>
+          <p:cNvSpPr txBox="1"/>
+          <p:nvPr/>
+        </p:nvSpPr>
+        <p:spPr>
+          <a:xfrm>
+            <a:off x="0" y="2468880"/>
+            <a:ext cx="12191695" cy="2194560"/>
+          </a:xfrm>
+          <a:prstGeom prst="rect">
+            <a:avLst/>
+          </a:prstGeom>
+          <a:noFill/>
+        </p:spPr>
+        <p:txBody>
+          <a:bodyPr wrap="none" lIns="0" rIns="0" tIns="0" bIns="0" anchor="ctr">
+            <a:spAutoFit/>
+          </a:bodyPr>
+          <a:lstStyle/>
+          <a:p>
+            <a:pPr algn="ctr"/>
+            <a:r>
+              <a:rPr sz="14000">
+                <a:solidFill>
+                  <a:srgbClr val="FFFFFF"/>
+                </a:solidFill>
+                <a:latin typeface="Pretendard Black"/>
+              </a:rPr>
+              <a:t>판단</a:t>
+            </a:r>
+          </a:p>
+        </p:txBody>
+      </p:sp>
+      <p:sp>
+        <p:nvSpPr>
+          <p:cNvPr id="7" name="TextBox 6"/>
+          <p:cNvSpPr txBox="1"/>
+          <p:nvPr/>
+        </p:nvSpPr>
+        <p:spPr>
+          <a:xfrm>
+            <a:off x="0" y="4937760"/>
+            <a:ext cx="12191695" cy="457200"/>
+          </a:xfrm>
+          <a:prstGeom prst="rect">
+            <a:avLst/>
+          </a:prstGeom>
+          <a:noFill/>
+        </p:spPr>
+        <p:txBody>
+          <a:bodyPr wrap="none">
+            <a:spAutoFit/>
+          </a:bodyPr>
+          <a:lstStyle/>
+          <a:p>
+            <a:pPr algn="ctr"/>
+            <a:r>
+              <a:rPr sz="2200">
+                <a:solidFill>
+                  <a:srgbClr val="666666"/>
+                </a:solidFill>
+                <a:latin typeface="Pretendard Light"/>
+              </a:rPr>
+              <a:t>사장님 · 대시보드 · AI</a:t>
             </a:r>
           </a:p>
         </p:txBody>

</xml_diff>

<commit_message>
feat(bni-v10): complete 12-slide monochrome punch deck
Task 5/5. s10 + AI 추가 + main() 최종 통합. 12장 전수 빌드 완료:
s1 표지 / s2 promise / s3 7년 / s4 둘 다 / s5 3→상장사 / s6 DX·AX /
s7-9 SoR/SoE/SoI / s10 +AI / s11 자기진단 cliff hanger / s12 검정 마무리

v10 design spec 100% 매핑. 백지 reset 완료, 발화 대본은 다음 phase.

Co-Authored-By: Claude Opus 4.7 (1M context) <noreply@anthropic.com>
</commit_message>
<xml_diff>
--- a/lectures/03_sor_framework/BNI_SoR_v10.pptx
+++ b/lectures/03_sor_framework/BNI_SoR_v10.pptx
@@ -3339,6 +3339,76 @@
                 <a:latin typeface="Pretendard Black"/>
               </a:rPr>
               <a:t>SSOD</a:t>
+            </a:r>
+          </a:p>
+        </p:txBody>
+      </p:sp>
+      <p:sp>
+        <p:nvSpPr>
+          <p:cNvPr id="5" name="TextBox 4"/>
+          <p:cNvSpPr txBox="1"/>
+          <p:nvPr/>
+        </p:nvSpPr>
+        <p:spPr>
+          <a:xfrm>
+            <a:off x="0" y="1828800"/>
+            <a:ext cx="12191695" cy="457200"/>
+          </a:xfrm>
+          <a:prstGeom prst="rect">
+            <a:avLst/>
+          </a:prstGeom>
+          <a:noFill/>
+        </p:spPr>
+        <p:txBody>
+          <a:bodyPr wrap="none">
+            <a:spAutoFit/>
+          </a:bodyPr>
+          <a:lstStyle/>
+          <a:p>
+            <a:pPr algn="ctr"/>
+            <a:r>
+              <a:rPr sz="2800">
+                <a:solidFill>
+                  <a:srgbClr val="666666"/>
+                </a:solidFill>
+                <a:latin typeface="Pretendard Light"/>
+              </a:rPr>
+              <a:t>그 위에</a:t>
+            </a:r>
+          </a:p>
+        </p:txBody>
+      </p:sp>
+      <p:sp>
+        <p:nvSpPr>
+          <p:cNvPr id="6" name="TextBox 5"/>
+          <p:cNvSpPr txBox="1"/>
+          <p:nvPr/>
+        </p:nvSpPr>
+        <p:spPr>
+          <a:xfrm>
+            <a:off x="0" y="2743200"/>
+            <a:ext cx="12191695" cy="2743200"/>
+          </a:xfrm>
+          <a:prstGeom prst="rect">
+            <a:avLst/>
+          </a:prstGeom>
+          <a:noFill/>
+        </p:spPr>
+        <p:txBody>
+          <a:bodyPr wrap="none" lIns="0" rIns="0" tIns="0" bIns="0" anchor="ctr">
+            <a:spAutoFit/>
+          </a:bodyPr>
+          <a:lstStyle/>
+          <a:p>
+            <a:pPr algn="ctr"/>
+            <a:r>
+              <a:rPr sz="24000">
+                <a:solidFill>
+                  <a:srgbClr val="FFFFFF"/>
+                </a:solidFill>
+                <a:latin typeface="Pretendard Black"/>
+              </a:rPr>
+              <a:t>+ AI</a:t>
             </a:r>
           </a:p>
         </p:txBody>

</xml_diff>

<commit_message>
fix(bni-v10): replace bottom-right SSOD wordmark text with white logo PNG
ssod-logo-mono.svg (currentColor) → sed 변환 → cairosvg PNG 렌더
(600×356, aspect 1.685 강제). brandlogy 헬퍼에서 텍스트 워드마크 폐기,
PNG 임베드(0.42" h)로 교체. s12 마무리도 로고(0.6" h)+김지명 분리.

대상: s2~s10 본문 9장 + s12. s1 표지·s11 cliff hanger는 미적용
(사용자 결정 대기).

Co-Authored-By: Claude Opus 4.7 (1M context) <noreply@anthropic.com>
</commit_message>
<xml_diff>
--- a/lectures/03_sor_framework/BNI_SoR_v10.pptx
+++ b/lectures/03_sor_framework/BNI_SoR_v10.pptx
@@ -3308,41 +3308,30 @@
           </a:p>
         </p:txBody>
       </p:sp>
-      <p:sp>
-        <p:nvSpPr>
-          <p:cNvPr id="4" name="TextBox 3"/>
-          <p:cNvSpPr txBox="1"/>
-          <p:nvPr/>
-        </p:nvSpPr>
-        <p:spPr>
-          <a:xfrm>
-            <a:off x="10515600" y="6355080"/>
-            <a:ext cx="1371600" cy="274320"/>
-          </a:xfrm>
-          <a:prstGeom prst="rect">
-            <a:avLst/>
-          </a:prstGeom>
-          <a:noFill/>
-        </p:spPr>
-        <p:txBody>
-          <a:bodyPr wrap="none">
-            <a:spAutoFit/>
-          </a:bodyPr>
-          <a:lstStyle/>
-          <a:p>
-            <a:pPr algn="r"/>
-            <a:r>
-              <a:rPr sz="1100">
-                <a:solidFill>
-                  <a:srgbClr val="FFFFFF"/>
-                </a:solidFill>
-                <a:latin typeface="Pretendard Black"/>
-              </a:rPr>
-              <a:t>SSOD</a:t>
-            </a:r>
-          </a:p>
-        </p:txBody>
-      </p:sp>
+      <p:pic>
+        <p:nvPicPr>
+          <p:cNvPr id="4" name="Picture 3" descr="ssod-logo-white.png"/>
+          <p:cNvPicPr>
+            <a:picLocks noChangeAspect="1"/>
+          </p:cNvPicPr>
+          <p:nvPr/>
+        </p:nvPicPr>
+        <p:blipFill>
+          <a:blip r:embed="rId2"/>
+          <a:stretch>
+            <a:fillRect/>
+          </a:stretch>
+        </p:blipFill>
+        <p:spPr>
+          <a:xfrm>
+            <a:off x="11132944" y="6181344"/>
+            <a:ext cx="647271" cy="384048"/>
+          </a:xfrm>
+          <a:prstGeom prst="rect">
+            <a:avLst/>
+          </a:prstGeom>
+        </p:spPr>
+      </p:pic>
       <p:sp>
         <p:nvSpPr>
           <p:cNvPr id="5" name="TextBox 4"/>
@@ -3641,15 +3630,39 @@
           </a:p>
         </p:txBody>
       </p:sp>
-      <p:sp>
-        <p:nvSpPr>
-          <p:cNvPr id="3" name="TextBox 2"/>
+      <p:pic>
+        <p:nvPicPr>
+          <p:cNvPr id="3" name="Picture 2" descr="ssod-logo-white.png"/>
+          <p:cNvPicPr>
+            <a:picLocks noChangeAspect="1"/>
+          </p:cNvPicPr>
+          <p:nvPr/>
+        </p:nvPicPr>
+        <p:blipFill>
+          <a:blip r:embed="rId2"/>
+          <a:stretch>
+            <a:fillRect/>
+          </a:stretch>
+        </p:blipFill>
+        <p:spPr>
+          <a:xfrm>
+            <a:off x="10764101" y="5806440"/>
+            <a:ext cx="924674" cy="548640"/>
+          </a:xfrm>
+          <a:prstGeom prst="rect">
+            <a:avLst/>
+          </a:prstGeom>
+        </p:spPr>
+      </p:pic>
+      <p:sp>
+        <p:nvSpPr>
+          <p:cNvPr id="4" name="TextBox 3"/>
           <p:cNvSpPr txBox="1"/>
           <p:nvPr/>
         </p:nvSpPr>
         <p:spPr>
           <a:xfrm>
-            <a:off x="9601200" y="6263640"/>
+            <a:off x="9601200" y="5486400"/>
             <a:ext cx="2286000" cy="365760"/>
           </a:xfrm>
           <a:prstGeom prst="rect">
@@ -3665,13 +3678,13 @@
           <a:p>
             <a:pPr algn="r"/>
             <a:r>
-              <a:rPr sz="1400">
+              <a:rPr sz="1600">
                 <a:solidFill>
                   <a:srgbClr val="FFFFFF"/>
                 </a:solidFill>
                 <a:latin typeface="Pretendard Light"/>
               </a:rPr>
-              <a:t>SSOD · 김지명</a:t>
+              <a:t>김지명</a:t>
             </a:r>
           </a:p>
         </p:txBody>
@@ -3772,41 +3785,30 @@
           </a:p>
         </p:txBody>
       </p:sp>
-      <p:sp>
-        <p:nvSpPr>
-          <p:cNvPr id="4" name="TextBox 3"/>
-          <p:cNvSpPr txBox="1"/>
-          <p:nvPr/>
-        </p:nvSpPr>
-        <p:spPr>
-          <a:xfrm>
-            <a:off x="10515600" y="6355080"/>
-            <a:ext cx="1371600" cy="274320"/>
-          </a:xfrm>
-          <a:prstGeom prst="rect">
-            <a:avLst/>
-          </a:prstGeom>
-          <a:noFill/>
-        </p:spPr>
-        <p:txBody>
-          <a:bodyPr wrap="none">
-            <a:spAutoFit/>
-          </a:bodyPr>
-          <a:lstStyle/>
-          <a:p>
-            <a:pPr algn="r"/>
-            <a:r>
-              <a:rPr sz="1100">
-                <a:solidFill>
-                  <a:srgbClr val="FFFFFF"/>
-                </a:solidFill>
-                <a:latin typeface="Pretendard Black"/>
-              </a:rPr>
-              <a:t>SSOD</a:t>
-            </a:r>
-          </a:p>
-        </p:txBody>
-      </p:sp>
+      <p:pic>
+        <p:nvPicPr>
+          <p:cNvPr id="4" name="Picture 3" descr="ssod-logo-white.png"/>
+          <p:cNvPicPr>
+            <a:picLocks noChangeAspect="1"/>
+          </p:cNvPicPr>
+          <p:nvPr/>
+        </p:nvPicPr>
+        <p:blipFill>
+          <a:blip r:embed="rId2"/>
+          <a:stretch>
+            <a:fillRect/>
+          </a:stretch>
+        </p:blipFill>
+        <p:spPr>
+          <a:xfrm>
+            <a:off x="11132944" y="6181344"/>
+            <a:ext cx="647271" cy="384048"/>
+          </a:xfrm>
+          <a:prstGeom prst="rect">
+            <a:avLst/>
+          </a:prstGeom>
+        </p:spPr>
+      </p:pic>
       <p:sp>
         <p:nvSpPr>
           <p:cNvPr id="5" name="TextBox 4"/>
@@ -3993,41 +3995,30 @@
           </a:p>
         </p:txBody>
       </p:sp>
-      <p:sp>
-        <p:nvSpPr>
-          <p:cNvPr id="4" name="TextBox 3"/>
-          <p:cNvSpPr txBox="1"/>
-          <p:nvPr/>
-        </p:nvSpPr>
-        <p:spPr>
-          <a:xfrm>
-            <a:off x="10515600" y="6355080"/>
-            <a:ext cx="1371600" cy="274320"/>
-          </a:xfrm>
-          <a:prstGeom prst="rect">
-            <a:avLst/>
-          </a:prstGeom>
-          <a:noFill/>
-        </p:spPr>
-        <p:txBody>
-          <a:bodyPr wrap="none">
-            <a:spAutoFit/>
-          </a:bodyPr>
-          <a:lstStyle/>
-          <a:p>
-            <a:pPr algn="r"/>
-            <a:r>
-              <a:rPr sz="1100">
-                <a:solidFill>
-                  <a:srgbClr val="FFFFFF"/>
-                </a:solidFill>
-                <a:latin typeface="Pretendard Black"/>
-              </a:rPr>
-              <a:t>SSOD</a:t>
-            </a:r>
-          </a:p>
-        </p:txBody>
-      </p:sp>
+      <p:pic>
+        <p:nvPicPr>
+          <p:cNvPr id="4" name="Picture 3" descr="ssod-logo-white.png"/>
+          <p:cNvPicPr>
+            <a:picLocks noChangeAspect="1"/>
+          </p:cNvPicPr>
+          <p:nvPr/>
+        </p:nvPicPr>
+        <p:blipFill>
+          <a:blip r:embed="rId2"/>
+          <a:stretch>
+            <a:fillRect/>
+          </a:stretch>
+        </p:blipFill>
+        <p:spPr>
+          <a:xfrm>
+            <a:off x="11132944" y="6181344"/>
+            <a:ext cx="647271" cy="384048"/>
+          </a:xfrm>
+          <a:prstGeom prst="rect">
+            <a:avLst/>
+          </a:prstGeom>
+        </p:spPr>
+      </p:pic>
       <p:sp>
         <p:nvSpPr>
           <p:cNvPr id="5" name="TextBox 4"/>
@@ -4194,79 +4185,9 @@
           </a:p>
         </p:txBody>
       </p:sp>
-      <p:sp>
-        <p:nvSpPr>
-          <p:cNvPr id="4" name="TextBox 3"/>
-          <p:cNvSpPr txBox="1"/>
-          <p:nvPr/>
-        </p:nvSpPr>
-        <p:spPr>
-          <a:xfrm>
-            <a:off x="10515600" y="6355080"/>
-            <a:ext cx="1371600" cy="274320"/>
-          </a:xfrm>
-          <a:prstGeom prst="rect">
-            <a:avLst/>
-          </a:prstGeom>
-          <a:noFill/>
-        </p:spPr>
-        <p:txBody>
-          <a:bodyPr wrap="none">
-            <a:spAutoFit/>
-          </a:bodyPr>
-          <a:lstStyle/>
-          <a:p>
-            <a:pPr algn="r"/>
-            <a:r>
-              <a:rPr sz="1100">
-                <a:solidFill>
-                  <a:srgbClr val="FFFFFF"/>
-                </a:solidFill>
-                <a:latin typeface="Pretendard Black"/>
-              </a:rPr>
-              <a:t>SSOD</a:t>
-            </a:r>
-          </a:p>
-        </p:txBody>
-      </p:sp>
-      <p:sp>
-        <p:nvSpPr>
-          <p:cNvPr id="5" name="TextBox 4"/>
-          <p:cNvSpPr txBox="1"/>
-          <p:nvPr/>
-        </p:nvSpPr>
-        <p:spPr>
-          <a:xfrm>
-            <a:off x="0" y="1280160"/>
-            <a:ext cx="12191695" cy="2011680"/>
-          </a:xfrm>
-          <a:prstGeom prst="rect">
-            <a:avLst/>
-          </a:prstGeom>
-          <a:noFill/>
-        </p:spPr>
-        <p:txBody>
-          <a:bodyPr wrap="none" lIns="0" rIns="0" tIns="0" bIns="0" anchor="ctr">
-            <a:spAutoFit/>
-          </a:bodyPr>
-          <a:lstStyle/>
-          <a:p>
-            <a:pPr algn="ctr"/>
-            <a:r>
-              <a:rPr sz="16000">
-                <a:solidFill>
-                  <a:srgbClr val="FFFFFF"/>
-                </a:solidFill>
-                <a:latin typeface="Pretendard Black"/>
-              </a:rPr>
-              <a:t>둘 다</a:t>
-            </a:r>
-          </a:p>
-        </p:txBody>
-      </p:sp>
       <p:pic>
         <p:nvPicPr>
-          <p:cNvPr id="6" name="Picture 5" descr="notion-ambassador-badge.png"/>
+          <p:cNvPr id="4" name="Picture 3" descr="ssod-logo-white.png"/>
           <p:cNvPicPr>
             <a:picLocks noChangeAspect="1"/>
           </p:cNvPicPr>
@@ -4280,6 +4201,65 @@
         </p:blipFill>
         <p:spPr>
           <a:xfrm>
+            <a:off x="11132944" y="6181344"/>
+            <a:ext cx="647271" cy="384048"/>
+          </a:xfrm>
+          <a:prstGeom prst="rect">
+            <a:avLst/>
+          </a:prstGeom>
+        </p:spPr>
+      </p:pic>
+      <p:sp>
+        <p:nvSpPr>
+          <p:cNvPr id="5" name="TextBox 4"/>
+          <p:cNvSpPr txBox="1"/>
+          <p:nvPr/>
+        </p:nvSpPr>
+        <p:spPr>
+          <a:xfrm>
+            <a:off x="0" y="1280160"/>
+            <a:ext cx="12191695" cy="2011680"/>
+          </a:xfrm>
+          <a:prstGeom prst="rect">
+            <a:avLst/>
+          </a:prstGeom>
+          <a:noFill/>
+        </p:spPr>
+        <p:txBody>
+          <a:bodyPr wrap="none" lIns="0" rIns="0" tIns="0" bIns="0" anchor="ctr">
+            <a:spAutoFit/>
+          </a:bodyPr>
+          <a:lstStyle/>
+          <a:p>
+            <a:pPr algn="ctr"/>
+            <a:r>
+              <a:rPr sz="16000">
+                <a:solidFill>
+                  <a:srgbClr val="FFFFFF"/>
+                </a:solidFill>
+                <a:latin typeface="Pretendard Black"/>
+              </a:rPr>
+              <a:t>둘 다</a:t>
+            </a:r>
+          </a:p>
+        </p:txBody>
+      </p:sp>
+      <p:pic>
+        <p:nvPicPr>
+          <p:cNvPr id="6" name="Picture 5" descr="notion-ambassador-badge.png"/>
+          <p:cNvPicPr>
+            <a:picLocks noChangeAspect="1"/>
+          </p:cNvPicPr>
+          <p:nvPr/>
+        </p:nvPicPr>
+        <p:blipFill>
+          <a:blip r:embed="rId3"/>
+          <a:stretch>
+            <a:fillRect/>
+          </a:stretch>
+        </p:blipFill>
+        <p:spPr>
+          <a:xfrm>
             <a:off x="3931920" y="4023360"/>
             <a:ext cx="4163122" cy="1280160"/>
           </a:xfrm>
@@ -4297,7 +4277,7 @@
           <p:nvPr/>
         </p:nvPicPr>
         <p:blipFill>
-          <a:blip r:embed="rId3"/>
+          <a:blip r:embed="rId4"/>
           <a:stretch>
             <a:fillRect/>
           </a:stretch>
@@ -4443,41 +4423,30 @@
           </a:p>
         </p:txBody>
       </p:sp>
-      <p:sp>
-        <p:nvSpPr>
-          <p:cNvPr id="4" name="TextBox 3"/>
-          <p:cNvSpPr txBox="1"/>
-          <p:nvPr/>
-        </p:nvSpPr>
-        <p:spPr>
-          <a:xfrm>
-            <a:off x="10515600" y="6355080"/>
-            <a:ext cx="1371600" cy="274320"/>
-          </a:xfrm>
-          <a:prstGeom prst="rect">
-            <a:avLst/>
-          </a:prstGeom>
-          <a:noFill/>
-        </p:spPr>
-        <p:txBody>
-          <a:bodyPr wrap="none">
-            <a:spAutoFit/>
-          </a:bodyPr>
-          <a:lstStyle/>
-          <a:p>
-            <a:pPr algn="r"/>
-            <a:r>
-              <a:rPr sz="1100">
-                <a:solidFill>
-                  <a:srgbClr val="FFFFFF"/>
-                </a:solidFill>
-                <a:latin typeface="Pretendard Black"/>
-              </a:rPr>
-              <a:t>SSOD</a:t>
-            </a:r>
-          </a:p>
-        </p:txBody>
-      </p:sp>
+      <p:pic>
+        <p:nvPicPr>
+          <p:cNvPr id="4" name="Picture 3" descr="ssod-logo-white.png"/>
+          <p:cNvPicPr>
+            <a:picLocks noChangeAspect="1"/>
+          </p:cNvPicPr>
+          <p:nvPr/>
+        </p:nvPicPr>
+        <p:blipFill>
+          <a:blip r:embed="rId2"/>
+          <a:stretch>
+            <a:fillRect/>
+          </a:stretch>
+        </p:blipFill>
+        <p:spPr>
+          <a:xfrm>
+            <a:off x="11132944" y="6181344"/>
+            <a:ext cx="647271" cy="384048"/>
+          </a:xfrm>
+          <a:prstGeom prst="rect">
+            <a:avLst/>
+          </a:prstGeom>
+        </p:spPr>
+      </p:pic>
       <p:sp>
         <p:nvSpPr>
           <p:cNvPr id="5" name="TextBox 4"/>
@@ -4662,41 +4631,30 @@
           </a:p>
         </p:txBody>
       </p:sp>
-      <p:sp>
-        <p:nvSpPr>
-          <p:cNvPr id="4" name="TextBox 3"/>
-          <p:cNvSpPr txBox="1"/>
-          <p:nvPr/>
-        </p:nvSpPr>
-        <p:spPr>
-          <a:xfrm>
-            <a:off x="10515600" y="6355080"/>
-            <a:ext cx="1371600" cy="274320"/>
-          </a:xfrm>
-          <a:prstGeom prst="rect">
-            <a:avLst/>
-          </a:prstGeom>
-          <a:noFill/>
-        </p:spPr>
-        <p:txBody>
-          <a:bodyPr wrap="none">
-            <a:spAutoFit/>
-          </a:bodyPr>
-          <a:lstStyle/>
-          <a:p>
-            <a:pPr algn="r"/>
-            <a:r>
-              <a:rPr sz="1100">
-                <a:solidFill>
-                  <a:srgbClr val="FFFFFF"/>
-                </a:solidFill>
-                <a:latin typeface="Pretendard Black"/>
-              </a:rPr>
-              <a:t>SSOD</a:t>
-            </a:r>
-          </a:p>
-        </p:txBody>
-      </p:sp>
+      <p:pic>
+        <p:nvPicPr>
+          <p:cNvPr id="4" name="Picture 3" descr="ssod-logo-white.png"/>
+          <p:cNvPicPr>
+            <a:picLocks noChangeAspect="1"/>
+          </p:cNvPicPr>
+          <p:nvPr/>
+        </p:nvPicPr>
+        <p:blipFill>
+          <a:blip r:embed="rId2"/>
+          <a:stretch>
+            <a:fillRect/>
+          </a:stretch>
+        </p:blipFill>
+        <p:spPr>
+          <a:xfrm>
+            <a:off x="11132944" y="6181344"/>
+            <a:ext cx="647271" cy="384048"/>
+          </a:xfrm>
+          <a:prstGeom prst="rect">
+            <a:avLst/>
+          </a:prstGeom>
+        </p:spPr>
+      </p:pic>
       <p:sp>
         <p:nvSpPr>
           <p:cNvPr id="5" name="TextBox 4"/>
@@ -4863,41 +4821,30 @@
           </a:p>
         </p:txBody>
       </p:sp>
-      <p:sp>
-        <p:nvSpPr>
-          <p:cNvPr id="4" name="TextBox 3"/>
-          <p:cNvSpPr txBox="1"/>
-          <p:nvPr/>
-        </p:nvSpPr>
-        <p:spPr>
-          <a:xfrm>
-            <a:off x="10515600" y="6355080"/>
-            <a:ext cx="1371600" cy="274320"/>
-          </a:xfrm>
-          <a:prstGeom prst="rect">
-            <a:avLst/>
-          </a:prstGeom>
-          <a:noFill/>
-        </p:spPr>
-        <p:txBody>
-          <a:bodyPr wrap="none">
-            <a:spAutoFit/>
-          </a:bodyPr>
-          <a:lstStyle/>
-          <a:p>
-            <a:pPr algn="r"/>
-            <a:r>
-              <a:rPr sz="1100">
-                <a:solidFill>
-                  <a:srgbClr val="FFFFFF"/>
-                </a:solidFill>
-                <a:latin typeface="Pretendard Black"/>
-              </a:rPr>
-              <a:t>SSOD</a:t>
-            </a:r>
-          </a:p>
-        </p:txBody>
-      </p:sp>
+      <p:pic>
+        <p:nvPicPr>
+          <p:cNvPr id="4" name="Picture 3" descr="ssod-logo-white.png"/>
+          <p:cNvPicPr>
+            <a:picLocks noChangeAspect="1"/>
+          </p:cNvPicPr>
+          <p:nvPr/>
+        </p:nvPicPr>
+        <p:blipFill>
+          <a:blip r:embed="rId2"/>
+          <a:stretch>
+            <a:fillRect/>
+          </a:stretch>
+        </p:blipFill>
+        <p:spPr>
+          <a:xfrm>
+            <a:off x="11132944" y="6181344"/>
+            <a:ext cx="647271" cy="384048"/>
+          </a:xfrm>
+          <a:prstGeom prst="rect">
+            <a:avLst/>
+          </a:prstGeom>
+        </p:spPr>
+      </p:pic>
       <p:sp>
         <p:nvSpPr>
           <p:cNvPr id="5" name="TextBox 4"/>
@@ -5099,41 +5046,30 @@
           </a:p>
         </p:txBody>
       </p:sp>
-      <p:sp>
-        <p:nvSpPr>
-          <p:cNvPr id="4" name="TextBox 3"/>
-          <p:cNvSpPr txBox="1"/>
-          <p:nvPr/>
-        </p:nvSpPr>
-        <p:spPr>
-          <a:xfrm>
-            <a:off x="10515600" y="6355080"/>
-            <a:ext cx="1371600" cy="274320"/>
-          </a:xfrm>
-          <a:prstGeom prst="rect">
-            <a:avLst/>
-          </a:prstGeom>
-          <a:noFill/>
-        </p:spPr>
-        <p:txBody>
-          <a:bodyPr wrap="none">
-            <a:spAutoFit/>
-          </a:bodyPr>
-          <a:lstStyle/>
-          <a:p>
-            <a:pPr algn="r"/>
-            <a:r>
-              <a:rPr sz="1100">
-                <a:solidFill>
-                  <a:srgbClr val="FFFFFF"/>
-                </a:solidFill>
-                <a:latin typeface="Pretendard Black"/>
-              </a:rPr>
-              <a:t>SSOD</a:t>
-            </a:r>
-          </a:p>
-        </p:txBody>
-      </p:sp>
+      <p:pic>
+        <p:nvPicPr>
+          <p:cNvPr id="4" name="Picture 3" descr="ssod-logo-white.png"/>
+          <p:cNvPicPr>
+            <a:picLocks noChangeAspect="1"/>
+          </p:cNvPicPr>
+          <p:nvPr/>
+        </p:nvPicPr>
+        <p:blipFill>
+          <a:blip r:embed="rId2"/>
+          <a:stretch>
+            <a:fillRect/>
+          </a:stretch>
+        </p:blipFill>
+        <p:spPr>
+          <a:xfrm>
+            <a:off x="11132944" y="6181344"/>
+            <a:ext cx="647271" cy="384048"/>
+          </a:xfrm>
+          <a:prstGeom prst="rect">
+            <a:avLst/>
+          </a:prstGeom>
+        </p:spPr>
+      </p:pic>
       <p:sp>
         <p:nvSpPr>
           <p:cNvPr id="5" name="TextBox 4"/>
@@ -5335,41 +5271,30 @@
           </a:p>
         </p:txBody>
       </p:sp>
-      <p:sp>
-        <p:nvSpPr>
-          <p:cNvPr id="4" name="TextBox 3"/>
-          <p:cNvSpPr txBox="1"/>
-          <p:nvPr/>
-        </p:nvSpPr>
-        <p:spPr>
-          <a:xfrm>
-            <a:off x="10515600" y="6355080"/>
-            <a:ext cx="1371600" cy="274320"/>
-          </a:xfrm>
-          <a:prstGeom prst="rect">
-            <a:avLst/>
-          </a:prstGeom>
-          <a:noFill/>
-        </p:spPr>
-        <p:txBody>
-          <a:bodyPr wrap="none">
-            <a:spAutoFit/>
-          </a:bodyPr>
-          <a:lstStyle/>
-          <a:p>
-            <a:pPr algn="r"/>
-            <a:r>
-              <a:rPr sz="1100">
-                <a:solidFill>
-                  <a:srgbClr val="FFFFFF"/>
-                </a:solidFill>
-                <a:latin typeface="Pretendard Black"/>
-              </a:rPr>
-              <a:t>SSOD</a:t>
-            </a:r>
-          </a:p>
-        </p:txBody>
-      </p:sp>
+      <p:pic>
+        <p:nvPicPr>
+          <p:cNvPr id="4" name="Picture 3" descr="ssod-logo-white.png"/>
+          <p:cNvPicPr>
+            <a:picLocks noChangeAspect="1"/>
+          </p:cNvPicPr>
+          <p:nvPr/>
+        </p:nvPicPr>
+        <p:blipFill>
+          <a:blip r:embed="rId2"/>
+          <a:stretch>
+            <a:fillRect/>
+          </a:stretch>
+        </p:blipFill>
+        <p:spPr>
+          <a:xfrm>
+            <a:off x="11132944" y="6181344"/>
+            <a:ext cx="647271" cy="384048"/>
+          </a:xfrm>
+          <a:prstGeom prst="rect">
+            <a:avLst/>
+          </a:prstGeom>
+        </p:spPr>
+      </p:pic>
       <p:sp>
         <p:nvSpPr>
           <p:cNvPr id="5" name="TextBox 4"/>

</xml_diff>

<commit_message>
fix(bni-v10): force Pretendard on East Asian track via OOXML patch
진단: python-pptx font.name은 Latin track만 잡아 한글이 시스템 serif로
fallback. PowerPoint는 ea(EastAsian)·cs(ComplexScript) track 별도 보유.

수정: set_font() 헬퍼 신설 — rPr 밑에 a:latin·a:ea·a:cs 3 track 모두
동일 typeface 강제. 모든 슬라이드 빌더에 적용 (9 callsites).

또한 ~/Library/Fonts에 Pretendard-Black/Light/Bold.otf 개별 weight 파일
설치 완료 (Variable font의 weight axis는 PowerPoint family picker로
선택 불가).

Co-Authored-By: Claude Opus 4.7 (1M context) <noreply@anthropic.com>
</commit_message>
<xml_diff>
--- a/lectures/03_sor_framework/BNI_SoR_v10.pptx
+++ b/lectures/03_sor_framework/BNI_SoR_v10.pptx
@@ -3171,6 +3171,8 @@
                   <a:srgbClr val="FFFFFF"/>
                 </a:solidFill>
                 <a:latin typeface="Pretendard Black"/>
+                <a:ea typeface="Pretendard Black"/>
+                <a:cs typeface="Pretendard Black"/>
               </a:rPr>
               <a:t>AI 시대 일하는 구조</a:t>
             </a:r>
@@ -3206,6 +3208,8 @@
                   <a:srgbClr val="FFFFFF"/>
                 </a:solidFill>
                 <a:latin typeface="Pretendard Light"/>
+                <a:ea typeface="Pretendard Light"/>
+                <a:cs typeface="Pretendard Light"/>
               </a:rPr>
               <a:t>SSOD · 김지명</a:t>
             </a:r>
@@ -3302,6 +3306,8 @@
                   <a:srgbClr val="666666"/>
                 </a:solidFill>
                 <a:latin typeface="SF Mono"/>
+                <a:ea typeface="SF Mono"/>
+                <a:cs typeface="SF Mono"/>
               </a:rPr>
               <a:t>10/12</a:t>
             </a:r>
@@ -3361,6 +3367,8 @@
                   <a:srgbClr val="666666"/>
                 </a:solidFill>
                 <a:latin typeface="Pretendard Light"/>
+                <a:ea typeface="Pretendard Light"/>
+                <a:cs typeface="Pretendard Light"/>
               </a:rPr>
               <a:t>그 위에</a:t>
             </a:r>
@@ -3396,6 +3404,8 @@
                   <a:srgbClr val="FFFFFF"/>
                 </a:solidFill>
                 <a:latin typeface="Pretendard Black"/>
+                <a:ea typeface="Pretendard Black"/>
+                <a:cs typeface="Pretendard Black"/>
               </a:rPr>
               <a:t>+ AI</a:t>
             </a:r>
@@ -3492,6 +3502,8 @@
                   <a:srgbClr val="FFFFFF"/>
                 </a:solidFill>
                 <a:latin typeface="Pretendard Black"/>
+                <a:ea typeface="Pretendard Black"/>
+                <a:cs typeface="Pretendard Black"/>
               </a:rPr>
               <a:t>우리 회사는?</a:t>
             </a:r>
@@ -3531,6 +3543,8 @@
                   <a:srgbClr val="666666"/>
                 </a:solidFill>
                 <a:latin typeface="Pretendard Light"/>
+                <a:ea typeface="Pretendard Light"/>
+                <a:cs typeface="Pretendard Light"/>
               </a:rPr>
               <a:t>☐  SoR — 데이터</a:t>
             </a:r>
@@ -3547,6 +3561,8 @@
                   <a:srgbClr val="666666"/>
                 </a:solidFill>
                 <a:latin typeface="Pretendard Light"/>
+                <a:ea typeface="Pretendard Light"/>
+                <a:cs typeface="Pretendard Light"/>
               </a:rPr>
               <a:t>☐  SoE — 일</a:t>
             </a:r>
@@ -3563,6 +3579,8 @@
                   <a:srgbClr val="666666"/>
                 </a:solidFill>
                 <a:latin typeface="Pretendard Light"/>
+                <a:ea typeface="Pretendard Light"/>
+                <a:cs typeface="Pretendard Light"/>
               </a:rPr>
               <a:t>☐  SoI — 판단</a:t>
             </a:r>
@@ -3683,6 +3701,8 @@
                   <a:srgbClr val="FFFFFF"/>
                 </a:solidFill>
                 <a:latin typeface="Pretendard Light"/>
+                <a:ea typeface="Pretendard Light"/>
+                <a:cs typeface="Pretendard Light"/>
               </a:rPr>
               <a:t>김지명</a:t>
             </a:r>
@@ -3779,6 +3799,8 @@
                   <a:srgbClr val="666666"/>
                 </a:solidFill>
                 <a:latin typeface="SF Mono"/>
+                <a:ea typeface="SF Mono"/>
+                <a:cs typeface="SF Mono"/>
               </a:rPr>
               <a:t>02/12</a:t>
             </a:r>
@@ -3838,6 +3860,8 @@
                   <a:srgbClr val="FFFFFF"/>
                 </a:solidFill>
                 <a:latin typeface="Pretendard Black"/>
+                <a:ea typeface="Pretendard Black"/>
+                <a:cs typeface="Pretendard Black"/>
               </a:rPr>
               <a:t>오늘 가져가실 2가지</a:t>
             </a:r>
@@ -3877,6 +3901,8 @@
                   <a:srgbClr val="FFFFFF"/>
                 </a:solidFill>
                 <a:latin typeface="Pretendard Light"/>
+                <a:ea typeface="Pretendard Light"/>
+                <a:cs typeface="Pretendard Light"/>
               </a:rPr>
               <a:t>①  SSOD는 무엇을 하는가?</a:t>
             </a:r>
@@ -3893,6 +3919,8 @@
                   <a:srgbClr val="FFFFFF"/>
                 </a:solidFill>
                 <a:latin typeface="Pretendard Light"/>
+                <a:ea typeface="Pretendard Light"/>
+                <a:cs typeface="Pretendard Light"/>
               </a:rPr>
               <a:t>②  우리 회사는?</a:t>
             </a:r>
@@ -3989,6 +4017,8 @@
                   <a:srgbClr val="666666"/>
                 </a:solidFill>
                 <a:latin typeface="SF Mono"/>
+                <a:ea typeface="SF Mono"/>
+                <a:cs typeface="SF Mono"/>
               </a:rPr>
               <a:t>03/12</a:t>
             </a:r>
@@ -4048,6 +4078,8 @@
                   <a:srgbClr val="FFFFFF"/>
                 </a:solidFill>
                 <a:latin typeface="Pretendard Black"/>
+                <a:ea typeface="Pretendard Black"/>
+                <a:cs typeface="Pretendard Black"/>
               </a:rPr>
               <a:t>7년</a:t>
             </a:r>
@@ -4083,6 +4115,8 @@
                   <a:srgbClr val="666666"/>
                 </a:solidFill>
                 <a:latin typeface="Pretendard Light"/>
+                <a:ea typeface="Pretendard Light"/>
+                <a:cs typeface="Pretendard Light"/>
               </a:rPr>
               <a:t>B2B 컨설팅</a:t>
             </a:r>
@@ -4179,6 +4213,8 @@
                   <a:srgbClr val="666666"/>
                 </a:solidFill>
                 <a:latin typeface="SF Mono"/>
+                <a:ea typeface="SF Mono"/>
+                <a:cs typeface="SF Mono"/>
               </a:rPr>
               <a:t>04/12</a:t>
             </a:r>
@@ -4238,6 +4274,8 @@
                   <a:srgbClr val="FFFFFF"/>
                 </a:solidFill>
                 <a:latin typeface="Pretendard Black"/>
+                <a:ea typeface="Pretendard Black"/>
+                <a:cs typeface="Pretendard Black"/>
               </a:rPr>
               <a:t>둘 다</a:t>
             </a:r>
@@ -4321,6 +4359,8 @@
                   <a:srgbClr val="666666"/>
                 </a:solidFill>
                 <a:latin typeface="Pretendard Light"/>
+                <a:ea typeface="Pretendard Light"/>
+                <a:cs typeface="Pretendard Light"/>
               </a:rPr>
               <a:t>글로벌 공식 앰버서더 — 한국에 쏘드뿐</a:t>
             </a:r>
@@ -4417,6 +4457,8 @@
                   <a:srgbClr val="666666"/>
                 </a:solidFill>
                 <a:latin typeface="SF Mono"/>
+                <a:ea typeface="SF Mono"/>
+                <a:cs typeface="SF Mono"/>
               </a:rPr>
               <a:t>05/12</a:t>
             </a:r>
@@ -4476,6 +4518,8 @@
                   <a:srgbClr val="FFFFFF"/>
                 </a:solidFill>
                 <a:latin typeface="Pretendard Black"/>
+                <a:ea typeface="Pretendard Black"/>
+                <a:cs typeface="Pretendard Black"/>
               </a:rPr>
               <a:t>3</a:t>
             </a:r>
@@ -4485,6 +4529,8 @@
                   <a:srgbClr val="666666"/>
                 </a:solidFill>
                 <a:latin typeface="Pretendard Black"/>
+                <a:ea typeface="Pretendard Black"/>
+                <a:cs typeface="Pretendard Black"/>
               </a:rPr>
               <a:t>   →   </a:t>
             </a:r>
@@ -4494,6 +4540,8 @@
                   <a:srgbClr val="FFFFFF"/>
                 </a:solidFill>
                 <a:latin typeface="Pretendard Black"/>
+                <a:ea typeface="Pretendard Black"/>
+                <a:cs typeface="Pretendard Black"/>
               </a:rPr>
               <a:t>상장사</a:t>
             </a:r>
@@ -4529,6 +4577,8 @@
                   <a:srgbClr val="666666"/>
                 </a:solidFill>
                 <a:latin typeface="Pretendard Light"/>
+                <a:ea typeface="Pretendard Light"/>
+                <a:cs typeface="Pretendard Light"/>
               </a:rPr>
               <a:t>직원 3명 사무실부터 상장사까지</a:t>
             </a:r>
@@ -4625,6 +4675,8 @@
                   <a:srgbClr val="666666"/>
                 </a:solidFill>
                 <a:latin typeface="SF Mono"/>
+                <a:ea typeface="SF Mono"/>
+                <a:cs typeface="SF Mono"/>
               </a:rPr>
               <a:t>06/12</a:t>
             </a:r>
@@ -4684,6 +4736,8 @@
                   <a:srgbClr val="FFFFFF"/>
                 </a:solidFill>
                 <a:latin typeface="Pretendard Black"/>
+                <a:ea typeface="Pretendard Black"/>
+                <a:cs typeface="Pretendard Black"/>
               </a:rPr>
               <a:t>DX · AX</a:t>
             </a:r>
@@ -4719,6 +4773,8 @@
                   <a:srgbClr val="666666"/>
                 </a:solidFill>
                 <a:latin typeface="Pretendard Light"/>
+                <a:ea typeface="Pretendard Light"/>
+                <a:cs typeface="Pretendard Light"/>
               </a:rPr>
               <a:t>Digital Transformation · AI Transformation</a:t>
             </a:r>
@@ -4815,6 +4871,8 @@
                   <a:srgbClr val="666666"/>
                 </a:solidFill>
                 <a:latin typeface="SF Mono"/>
+                <a:ea typeface="SF Mono"/>
+                <a:cs typeface="SF Mono"/>
               </a:rPr>
               <a:t>07/12</a:t>
             </a:r>
@@ -4874,6 +4932,8 @@
                   <a:srgbClr val="666666"/>
                 </a:solidFill>
                 <a:latin typeface="SF Mono"/>
+                <a:ea typeface="SF Mono"/>
+                <a:cs typeface="SF Mono"/>
               </a:rPr>
               <a:t>SoR</a:t>
             </a:r>
@@ -4909,6 +4969,8 @@
                   <a:srgbClr val="FFFFFF"/>
                 </a:solidFill>
                 <a:latin typeface="Pretendard Black"/>
+                <a:ea typeface="Pretendard Black"/>
+                <a:cs typeface="Pretendard Black"/>
               </a:rPr>
               <a:t>데이터</a:t>
             </a:r>
@@ -4944,6 +5006,8 @@
                   <a:srgbClr val="666666"/>
                 </a:solidFill>
                 <a:latin typeface="Pretendard Light"/>
+                <a:ea typeface="Pretendard Light"/>
+                <a:cs typeface="Pretendard Light"/>
               </a:rPr>
               <a:t>ERP · 고객 명단 · 매출</a:t>
             </a:r>
@@ -5040,6 +5104,8 @@
                   <a:srgbClr val="666666"/>
                 </a:solidFill>
                 <a:latin typeface="SF Mono"/>
+                <a:ea typeface="SF Mono"/>
+                <a:cs typeface="SF Mono"/>
               </a:rPr>
               <a:t>08/12</a:t>
             </a:r>
@@ -5099,6 +5165,8 @@
                   <a:srgbClr val="666666"/>
                 </a:solidFill>
                 <a:latin typeface="SF Mono"/>
+                <a:ea typeface="SF Mono"/>
+                <a:cs typeface="SF Mono"/>
               </a:rPr>
               <a:t>SoE</a:t>
             </a:r>
@@ -5134,6 +5202,8 @@
                   <a:srgbClr val="FFFFFF"/>
                 </a:solidFill>
                 <a:latin typeface="Pretendard Black"/>
+                <a:ea typeface="Pretendard Black"/>
+                <a:cs typeface="Pretendard Black"/>
               </a:rPr>
               <a:t>일</a:t>
             </a:r>
@@ -5169,6 +5239,8 @@
                   <a:srgbClr val="666666"/>
                 </a:solidFill>
                 <a:latin typeface="Pretendard Light"/>
+                <a:ea typeface="Pretendard Light"/>
+                <a:cs typeface="Pretendard Light"/>
               </a:rPr>
               <a:t>카톡 · 노션 · 결재</a:t>
             </a:r>
@@ -5265,6 +5337,8 @@
                   <a:srgbClr val="666666"/>
                 </a:solidFill>
                 <a:latin typeface="SF Mono"/>
+                <a:ea typeface="SF Mono"/>
+                <a:cs typeface="SF Mono"/>
               </a:rPr>
               <a:t>09/12</a:t>
             </a:r>
@@ -5324,6 +5398,8 @@
                   <a:srgbClr val="666666"/>
                 </a:solidFill>
                 <a:latin typeface="SF Mono"/>
+                <a:ea typeface="SF Mono"/>
+                <a:cs typeface="SF Mono"/>
               </a:rPr>
               <a:t>SoI</a:t>
             </a:r>
@@ -5359,6 +5435,8 @@
                   <a:srgbClr val="FFFFFF"/>
                 </a:solidFill>
                 <a:latin typeface="Pretendard Black"/>
+                <a:ea typeface="Pretendard Black"/>
+                <a:cs typeface="Pretendard Black"/>
               </a:rPr>
               <a:t>판단</a:t>
             </a:r>
@@ -5394,6 +5472,8 @@
                   <a:srgbClr val="666666"/>
                 </a:solidFill>
                 <a:latin typeface="Pretendard Light"/>
+                <a:ea typeface="Pretendard Light"/>
+                <a:cs typeface="Pretendard Light"/>
               </a:rPr>
               <a:t>사장님 · 대시보드 · AI</a:t>
             </a:r>

</xml_diff>

<commit_message>
feat(bni-v10): flip SoX hierarchy + add s10 connection diagram (13 slides)
사용자 피드백 2건 반영:
1. SoX 위계 flip — 영문 약어(SoR/SoE/SoI)를 메인 흰 punch 200pt로,
   한글(데이터/일/판단)은 보조 회색 48pt로. 영문이 visual anchor 됨.
2. 신규 s10 다이어그램 — 3-layer 수직 스택(SoI ↑ SoE ↑ SoR) outline
   박스 + 화살표로 Palantir Ontology 모델 시각화. 데이터→일→판단
   상승 흐름. 기존 +AI는 s11, self-audit는 s12, 검정은 s13으로 밀림.
3. brandlogy NN/12 → NN/13 일괄 갱신.

총 13장. design-v10-spec.md 업데이트는 다음 commit.

Co-Authored-By: Claude Opus 4.7 (1M context) <noreply@anthropic.com>
</commit_message>
<xml_diff>
--- a/lectures/03_sor_framework/BNI_SoR_v10.pptx
+++ b/lectures/03_sor_framework/BNI_SoR_v10.pptx
@@ -17,6 +17,7 @@
     <p:sldId id="265" r:id="rId16"/>
     <p:sldId id="266" r:id="rId17"/>
     <p:sldId id="267" r:id="rId18"/>
+    <p:sldId id="268" r:id="rId19"/>
   </p:sldIdLst>
   <p:sldSz cx="12191695" cy="6858000" type="screen4x3"/>
   <p:notesSz cx="6858000" cy="9144000"/>
@@ -3309,7 +3310,7 @@
                 <a:ea typeface="SF Mono"/>
                 <a:cs typeface="SF Mono"/>
               </a:rPr>
-              <a:t>10/12</a:t>
+              <a:t>10/13</a:t>
             </a:r>
           </a:p>
         </p:txBody>
@@ -3340,27 +3341,57 @@
       </p:pic>
       <p:sp>
         <p:nvSpPr>
-          <p:cNvPr id="5" name="TextBox 4"/>
-          <p:cNvSpPr txBox="1"/>
-          <p:nvPr/>
-        </p:nvSpPr>
-        <p:spPr>
-          <a:xfrm>
-            <a:off x="0" y="1828800"/>
-            <a:ext cx="12191695" cy="457200"/>
-          </a:xfrm>
-          <a:prstGeom prst="rect">
-            <a:avLst/>
+          <p:cNvPr id="5" name="Rounded Rectangle 4"/>
+          <p:cNvSpPr/>
+          <p:nvPr/>
+        </p:nvSpPr>
+        <p:spPr>
+          <a:xfrm>
+            <a:off x="3352647" y="1234440"/>
+            <a:ext cx="5486400" cy="1051560"/>
+          </a:xfrm>
+          <a:prstGeom prst="roundRect">
+            <a:avLst>
+              <a:gd name="adj" fmla="val 15000"/>
+            </a:avLst>
           </a:prstGeom>
           <a:noFill/>
-        </p:spPr>
-        <p:txBody>
-          <a:bodyPr wrap="none">
-            <a:spAutoFit/>
-          </a:bodyPr>
+          <a:ln w="19050">
+            <a:solidFill>
+              <a:srgbClr val="FFFFFF"/>
+            </a:solidFill>
+          </a:ln>
+        </p:spPr>
+        <p:style>
+          <a:lnRef idx="1">
+            <a:schemeClr val="accent1"/>
+          </a:lnRef>
+          <a:fillRef idx="3">
+            <a:schemeClr val="accent1"/>
+          </a:fillRef>
+          <a:effectRef idx="2">
+            <a:schemeClr val="accent1"/>
+          </a:effectRef>
+          <a:fontRef idx="minor">
+            <a:schemeClr val="lt1"/>
+          </a:fontRef>
+        </p:style>
+        <p:txBody>
+          <a:bodyPr rtlCol="0" anchor="ctr" lIns="365760" rIns="365760"/>
           <a:lstStyle/>
           <a:p>
             <a:pPr algn="ctr"/>
+            <a:r>
+              <a:rPr sz="5400">
+                <a:solidFill>
+                  <a:srgbClr val="FFFFFF"/>
+                </a:solidFill>
+                <a:latin typeface="Pretendard Black"/>
+                <a:ea typeface="Pretendard Black"/>
+                <a:cs typeface="Pretendard Black"/>
+              </a:rPr>
+              <a:t>SoI</a:t>
+            </a:r>
             <a:r>
               <a:rPr sz="2800">
                 <a:solidFill>
@@ -3370,36 +3401,55 @@
                 <a:ea typeface="Pretendard Light"/>
                 <a:cs typeface="Pretendard Light"/>
               </a:rPr>
-              <a:t>그 위에</a:t>
-            </a:r>
-          </a:p>
-        </p:txBody>
-      </p:sp>
-      <p:sp>
-        <p:nvSpPr>
-          <p:cNvPr id="6" name="TextBox 5"/>
-          <p:cNvSpPr txBox="1"/>
-          <p:nvPr/>
-        </p:nvSpPr>
-        <p:spPr>
-          <a:xfrm>
-            <a:off x="0" y="2743200"/>
-            <a:ext cx="12191695" cy="2743200"/>
-          </a:xfrm>
-          <a:prstGeom prst="rect">
-            <a:avLst/>
+              <a:t>    판단</a:t>
+            </a:r>
+          </a:p>
+        </p:txBody>
+      </p:sp>
+      <p:sp>
+        <p:nvSpPr>
+          <p:cNvPr id="6" name="Rounded Rectangle 5"/>
+          <p:cNvSpPr/>
+          <p:nvPr/>
+        </p:nvSpPr>
+        <p:spPr>
+          <a:xfrm>
+            <a:off x="3352647" y="2697480"/>
+            <a:ext cx="5486400" cy="1051560"/>
+          </a:xfrm>
+          <a:prstGeom prst="roundRect">
+            <a:avLst>
+              <a:gd name="adj" fmla="val 15000"/>
+            </a:avLst>
           </a:prstGeom>
           <a:noFill/>
-        </p:spPr>
-        <p:txBody>
-          <a:bodyPr wrap="none" lIns="0" rIns="0" tIns="0" bIns="0" anchor="ctr">
-            <a:spAutoFit/>
-          </a:bodyPr>
+          <a:ln w="19050">
+            <a:solidFill>
+              <a:srgbClr val="FFFFFF"/>
+            </a:solidFill>
+          </a:ln>
+        </p:spPr>
+        <p:style>
+          <a:lnRef idx="1">
+            <a:schemeClr val="accent1"/>
+          </a:lnRef>
+          <a:fillRef idx="3">
+            <a:schemeClr val="accent1"/>
+          </a:fillRef>
+          <a:effectRef idx="2">
+            <a:schemeClr val="accent1"/>
+          </a:effectRef>
+          <a:fontRef idx="minor">
+            <a:schemeClr val="lt1"/>
+          </a:fontRef>
+        </p:style>
+        <p:txBody>
+          <a:bodyPr rtlCol="0" anchor="ctr" lIns="365760" rIns="365760"/>
           <a:lstStyle/>
           <a:p>
             <a:pPr algn="ctr"/>
             <a:r>
-              <a:rPr sz="24000">
+              <a:rPr sz="5400">
                 <a:solidFill>
                   <a:srgbClr val="FFFFFF"/>
                 </a:solidFill>
@@ -3407,7 +3457,159 @@
                 <a:ea typeface="Pretendard Black"/>
                 <a:cs typeface="Pretendard Black"/>
               </a:rPr>
-              <a:t>+ AI</a:t>
+              <a:t>SoE</a:t>
+            </a:r>
+            <a:r>
+              <a:rPr sz="2800">
+                <a:solidFill>
+                  <a:srgbClr val="666666"/>
+                </a:solidFill>
+                <a:latin typeface="Pretendard Light"/>
+                <a:ea typeface="Pretendard Light"/>
+                <a:cs typeface="Pretendard Light"/>
+              </a:rPr>
+              <a:t>    일</a:t>
+            </a:r>
+          </a:p>
+        </p:txBody>
+      </p:sp>
+      <p:sp>
+        <p:nvSpPr>
+          <p:cNvPr id="7" name="TextBox 6"/>
+          <p:cNvSpPr txBox="1"/>
+          <p:nvPr/>
+        </p:nvSpPr>
+        <p:spPr>
+          <a:xfrm>
+            <a:off x="3352647" y="2331720"/>
+            <a:ext cx="5486400" cy="320040"/>
+          </a:xfrm>
+          <a:prstGeom prst="rect">
+            <a:avLst/>
+          </a:prstGeom>
+          <a:noFill/>
+        </p:spPr>
+        <p:txBody>
+          <a:bodyPr wrap="none">
+            <a:spAutoFit/>
+          </a:bodyPr>
+          <a:lstStyle/>
+          <a:p>
+            <a:pPr algn="ctr"/>
+            <a:r>
+              <a:rPr sz="2600">
+                <a:solidFill>
+                  <a:srgbClr val="666666"/>
+                </a:solidFill>
+                <a:latin typeface="Pretendard Light"/>
+                <a:ea typeface="Pretendard Light"/>
+                <a:cs typeface="Pretendard Light"/>
+              </a:rPr>
+              <a:t>↑</a:t>
+            </a:r>
+          </a:p>
+        </p:txBody>
+      </p:sp>
+      <p:sp>
+        <p:nvSpPr>
+          <p:cNvPr id="8" name="Rounded Rectangle 7"/>
+          <p:cNvSpPr/>
+          <p:nvPr/>
+        </p:nvSpPr>
+        <p:spPr>
+          <a:xfrm>
+            <a:off x="3352647" y="4160520"/>
+            <a:ext cx="5486400" cy="1051560"/>
+          </a:xfrm>
+          <a:prstGeom prst="roundRect">
+            <a:avLst>
+              <a:gd name="adj" fmla="val 15000"/>
+            </a:avLst>
+          </a:prstGeom>
+          <a:noFill/>
+          <a:ln w="19050">
+            <a:solidFill>
+              <a:srgbClr val="FFFFFF"/>
+            </a:solidFill>
+          </a:ln>
+        </p:spPr>
+        <p:style>
+          <a:lnRef idx="1">
+            <a:schemeClr val="accent1"/>
+          </a:lnRef>
+          <a:fillRef idx="3">
+            <a:schemeClr val="accent1"/>
+          </a:fillRef>
+          <a:effectRef idx="2">
+            <a:schemeClr val="accent1"/>
+          </a:effectRef>
+          <a:fontRef idx="minor">
+            <a:schemeClr val="lt1"/>
+          </a:fontRef>
+        </p:style>
+        <p:txBody>
+          <a:bodyPr rtlCol="0" anchor="ctr" lIns="365760" rIns="365760"/>
+          <a:lstStyle/>
+          <a:p>
+            <a:pPr algn="ctr"/>
+            <a:r>
+              <a:rPr sz="5400">
+                <a:solidFill>
+                  <a:srgbClr val="FFFFFF"/>
+                </a:solidFill>
+                <a:latin typeface="Pretendard Black"/>
+                <a:ea typeface="Pretendard Black"/>
+                <a:cs typeface="Pretendard Black"/>
+              </a:rPr>
+              <a:t>SoR</a:t>
+            </a:r>
+            <a:r>
+              <a:rPr sz="2800">
+                <a:solidFill>
+                  <a:srgbClr val="666666"/>
+                </a:solidFill>
+                <a:latin typeface="Pretendard Light"/>
+                <a:ea typeface="Pretendard Light"/>
+                <a:cs typeface="Pretendard Light"/>
+              </a:rPr>
+              <a:t>    데이터</a:t>
+            </a:r>
+          </a:p>
+        </p:txBody>
+      </p:sp>
+      <p:sp>
+        <p:nvSpPr>
+          <p:cNvPr id="9" name="TextBox 8"/>
+          <p:cNvSpPr txBox="1"/>
+          <p:nvPr/>
+        </p:nvSpPr>
+        <p:spPr>
+          <a:xfrm>
+            <a:off x="3352647" y="3794760"/>
+            <a:ext cx="5486400" cy="320040"/>
+          </a:xfrm>
+          <a:prstGeom prst="rect">
+            <a:avLst/>
+          </a:prstGeom>
+          <a:noFill/>
+        </p:spPr>
+        <p:txBody>
+          <a:bodyPr wrap="none">
+            <a:spAutoFit/>
+          </a:bodyPr>
+          <a:lstStyle/>
+          <a:p>
+            <a:pPr algn="ctr"/>
+            <a:r>
+              <a:rPr sz="2600">
+                <a:solidFill>
+                  <a:srgbClr val="666666"/>
+                </a:solidFill>
+                <a:latin typeface="Pretendard Light"/>
+                <a:ea typeface="Pretendard Light"/>
+                <a:cs typeface="Pretendard Light"/>
+              </a:rPr>
+              <a:t>↑</a:t>
             </a:r>
           </a:p>
         </p:txBody>
@@ -3481,8 +3683,106 @@
         </p:nvSpPr>
         <p:spPr>
           <a:xfrm>
-            <a:off x="0" y="1371600"/>
-            <a:ext cx="12191695" cy="1188720"/>
+            <a:off x="365760" y="274320"/>
+            <a:ext cx="914400" cy="274320"/>
+          </a:xfrm>
+          <a:prstGeom prst="rect">
+            <a:avLst/>
+          </a:prstGeom>
+          <a:noFill/>
+        </p:spPr>
+        <p:txBody>
+          <a:bodyPr wrap="none">
+            <a:spAutoFit/>
+          </a:bodyPr>
+          <a:lstStyle/>
+          <a:p>
+            <a:pPr algn="l"/>
+            <a:r>
+              <a:rPr sz="1100">
+                <a:solidFill>
+                  <a:srgbClr val="666666"/>
+                </a:solidFill>
+                <a:latin typeface="SF Mono"/>
+                <a:ea typeface="SF Mono"/>
+                <a:cs typeface="SF Mono"/>
+              </a:rPr>
+              <a:t>11/13</a:t>
+            </a:r>
+          </a:p>
+        </p:txBody>
+      </p:sp>
+      <p:pic>
+        <p:nvPicPr>
+          <p:cNvPr id="4" name="Picture 3" descr="ssod-logo-white.png"/>
+          <p:cNvPicPr>
+            <a:picLocks noChangeAspect="1"/>
+          </p:cNvPicPr>
+          <p:nvPr/>
+        </p:nvPicPr>
+        <p:blipFill>
+          <a:blip r:embed="rId2"/>
+          <a:stretch>
+            <a:fillRect/>
+          </a:stretch>
+        </p:blipFill>
+        <p:spPr>
+          <a:xfrm>
+            <a:off x="11132944" y="6181344"/>
+            <a:ext cx="647271" cy="384048"/>
+          </a:xfrm>
+          <a:prstGeom prst="rect">
+            <a:avLst/>
+          </a:prstGeom>
+        </p:spPr>
+      </p:pic>
+      <p:sp>
+        <p:nvSpPr>
+          <p:cNvPr id="5" name="TextBox 4"/>
+          <p:cNvSpPr txBox="1"/>
+          <p:nvPr/>
+        </p:nvSpPr>
+        <p:spPr>
+          <a:xfrm>
+            <a:off x="0" y="1828800"/>
+            <a:ext cx="12191695" cy="457200"/>
+          </a:xfrm>
+          <a:prstGeom prst="rect">
+            <a:avLst/>
+          </a:prstGeom>
+          <a:noFill/>
+        </p:spPr>
+        <p:txBody>
+          <a:bodyPr wrap="none">
+            <a:spAutoFit/>
+          </a:bodyPr>
+          <a:lstStyle/>
+          <a:p>
+            <a:pPr algn="ctr"/>
+            <a:r>
+              <a:rPr sz="2800">
+                <a:solidFill>
+                  <a:srgbClr val="666666"/>
+                </a:solidFill>
+                <a:latin typeface="Pretendard Light"/>
+                <a:ea typeface="Pretendard Light"/>
+                <a:cs typeface="Pretendard Light"/>
+              </a:rPr>
+              <a:t>그 위에</a:t>
+            </a:r>
+          </a:p>
+        </p:txBody>
+      </p:sp>
+      <p:sp>
+        <p:nvSpPr>
+          <p:cNvPr id="6" name="TextBox 5"/>
+          <p:cNvSpPr txBox="1"/>
+          <p:nvPr/>
+        </p:nvSpPr>
+        <p:spPr>
+          <a:xfrm>
+            <a:off x="0" y="2743200"/>
+            <a:ext cx="12191695" cy="2743200"/>
           </a:xfrm>
           <a:prstGeom prst="rect">
             <a:avLst/>
@@ -3497,7 +3797,7 @@
           <a:p>
             <a:pPr algn="ctr"/>
             <a:r>
-              <a:rPr sz="9600">
+              <a:rPr sz="24000">
                 <a:solidFill>
                   <a:srgbClr val="FFFFFF"/>
                 </a:solidFill>
@@ -3505,84 +3805,7 @@
                 <a:ea typeface="Pretendard Black"/>
                 <a:cs typeface="Pretendard Black"/>
               </a:rPr>
-              <a:t>우리 회사는?</a:t>
-            </a:r>
-          </a:p>
-        </p:txBody>
-      </p:sp>
-      <p:sp>
-        <p:nvSpPr>
-          <p:cNvPr id="4" name="TextBox 3"/>
-          <p:cNvSpPr txBox="1"/>
-          <p:nvPr/>
-        </p:nvSpPr>
-        <p:spPr>
-          <a:xfrm>
-            <a:off x="0" y="3383280"/>
-            <a:ext cx="12191695" cy="2743200"/>
-          </a:xfrm>
-          <a:prstGeom prst="rect">
-            <a:avLst/>
-          </a:prstGeom>
-          <a:noFill/>
-        </p:spPr>
-        <p:txBody>
-          <a:bodyPr wrap="none" anchor="t">
-            <a:spAutoFit/>
-          </a:bodyPr>
-          <a:lstStyle/>
-          <a:p>
-            <a:pPr algn="ctr">
-              <a:spcAft>
-                <a:spcPts val="1600"/>
-              </a:spcAft>
-            </a:pPr>
-            <a:r>
-              <a:rPr sz="3600">
-                <a:solidFill>
-                  <a:srgbClr val="666666"/>
-                </a:solidFill>
-                <a:latin typeface="Pretendard Light"/>
-                <a:ea typeface="Pretendard Light"/>
-                <a:cs typeface="Pretendard Light"/>
-              </a:rPr>
-              <a:t>☐  SoR — 데이터</a:t>
-            </a:r>
-          </a:p>
-          <a:p>
-            <a:pPr algn="ctr">
-              <a:spcAft>
-                <a:spcPts val="1600"/>
-              </a:spcAft>
-            </a:pPr>
-            <a:r>
-              <a:rPr sz="3600">
-                <a:solidFill>
-                  <a:srgbClr val="666666"/>
-                </a:solidFill>
-                <a:latin typeface="Pretendard Light"/>
-                <a:ea typeface="Pretendard Light"/>
-                <a:cs typeface="Pretendard Light"/>
-              </a:rPr>
-              <a:t>☐  SoE — 일</a:t>
-            </a:r>
-          </a:p>
-          <a:p>
-            <a:pPr algn="ctr">
-              <a:spcAft>
-                <a:spcPts val="1600"/>
-              </a:spcAft>
-            </a:pPr>
-            <a:r>
-              <a:rPr sz="3600">
-                <a:solidFill>
-                  <a:srgbClr val="666666"/>
-                </a:solidFill>
-                <a:latin typeface="Pretendard Light"/>
-                <a:ea typeface="Pretendard Light"/>
-                <a:cs typeface="Pretendard Light"/>
-              </a:rPr>
-              <a:t>☐  SoI — 판단</a:t>
+              <a:t>+ AI</a:t>
             </a:r>
           </a:p>
         </p:txBody>
@@ -3648,6 +3871,181 @@
           </a:p>
         </p:txBody>
       </p:sp>
+      <p:sp>
+        <p:nvSpPr>
+          <p:cNvPr id="3" name="TextBox 2"/>
+          <p:cNvSpPr txBox="1"/>
+          <p:nvPr/>
+        </p:nvSpPr>
+        <p:spPr>
+          <a:xfrm>
+            <a:off x="0" y="1371600"/>
+            <a:ext cx="12191695" cy="1188720"/>
+          </a:xfrm>
+          <a:prstGeom prst="rect">
+            <a:avLst/>
+          </a:prstGeom>
+          <a:noFill/>
+        </p:spPr>
+        <p:txBody>
+          <a:bodyPr wrap="none" lIns="0" rIns="0" tIns="0" bIns="0" anchor="ctr">
+            <a:spAutoFit/>
+          </a:bodyPr>
+          <a:lstStyle/>
+          <a:p>
+            <a:pPr algn="ctr"/>
+            <a:r>
+              <a:rPr sz="9600">
+                <a:solidFill>
+                  <a:srgbClr val="FFFFFF"/>
+                </a:solidFill>
+                <a:latin typeface="Pretendard Black"/>
+                <a:ea typeface="Pretendard Black"/>
+                <a:cs typeface="Pretendard Black"/>
+              </a:rPr>
+              <a:t>우리 회사는?</a:t>
+            </a:r>
+          </a:p>
+        </p:txBody>
+      </p:sp>
+      <p:sp>
+        <p:nvSpPr>
+          <p:cNvPr id="4" name="TextBox 3"/>
+          <p:cNvSpPr txBox="1"/>
+          <p:nvPr/>
+        </p:nvSpPr>
+        <p:spPr>
+          <a:xfrm>
+            <a:off x="0" y="3383280"/>
+            <a:ext cx="12191695" cy="2743200"/>
+          </a:xfrm>
+          <a:prstGeom prst="rect">
+            <a:avLst/>
+          </a:prstGeom>
+          <a:noFill/>
+        </p:spPr>
+        <p:txBody>
+          <a:bodyPr wrap="none" anchor="t">
+            <a:spAutoFit/>
+          </a:bodyPr>
+          <a:lstStyle/>
+          <a:p>
+            <a:pPr algn="ctr">
+              <a:spcAft>
+                <a:spcPts val="1600"/>
+              </a:spcAft>
+            </a:pPr>
+            <a:r>
+              <a:rPr sz="3600">
+                <a:solidFill>
+                  <a:srgbClr val="666666"/>
+                </a:solidFill>
+                <a:latin typeface="Pretendard Light"/>
+                <a:ea typeface="Pretendard Light"/>
+                <a:cs typeface="Pretendard Light"/>
+              </a:rPr>
+              <a:t>☐  SoR — 데이터</a:t>
+            </a:r>
+          </a:p>
+          <a:p>
+            <a:pPr algn="ctr">
+              <a:spcAft>
+                <a:spcPts val="1600"/>
+              </a:spcAft>
+            </a:pPr>
+            <a:r>
+              <a:rPr sz="3600">
+                <a:solidFill>
+                  <a:srgbClr val="666666"/>
+                </a:solidFill>
+                <a:latin typeface="Pretendard Light"/>
+                <a:ea typeface="Pretendard Light"/>
+                <a:cs typeface="Pretendard Light"/>
+              </a:rPr>
+              <a:t>☐  SoE — 일</a:t>
+            </a:r>
+          </a:p>
+          <a:p>
+            <a:pPr algn="ctr">
+              <a:spcAft>
+                <a:spcPts val="1600"/>
+              </a:spcAft>
+            </a:pPr>
+            <a:r>
+              <a:rPr sz="3600">
+                <a:solidFill>
+                  <a:srgbClr val="666666"/>
+                </a:solidFill>
+                <a:latin typeface="Pretendard Light"/>
+                <a:ea typeface="Pretendard Light"/>
+                <a:cs typeface="Pretendard Light"/>
+              </a:rPr>
+              <a:t>☐  SoI — 판단</a:t>
+            </a:r>
+          </a:p>
+        </p:txBody>
+      </p:sp>
+    </p:spTree>
+  </p:cSld>
+  <p:clrMapOvr>
+    <a:masterClrMapping/>
+  </p:clrMapOvr>
+</p:sld>
+</file>
+
+<file path=ppt/slides/slide13.xml><?xml version="1.0" encoding="utf-8"?>
+<p:sld xmlns:a="http://schemas.openxmlformats.org/drawingml/2006/main" xmlns:p="http://schemas.openxmlformats.org/presentationml/2006/main" xmlns:r="http://schemas.openxmlformats.org/officeDocument/2006/relationships">
+  <p:cSld>
+    <p:spTree>
+      <p:nvGrpSpPr>
+        <p:cNvPr id="1" name=""/>
+        <p:cNvGrpSpPr/>
+        <p:nvPr/>
+      </p:nvGrpSpPr>
+      <p:grpSpPr/>
+      <p:sp>
+        <p:nvSpPr>
+          <p:cNvPr id="2" name="Rectangle 1"/>
+          <p:cNvSpPr/>
+          <p:nvPr/>
+        </p:nvSpPr>
+        <p:spPr>
+          <a:xfrm>
+            <a:off x="0" y="0"/>
+            <a:ext cx="12191695" cy="6858000"/>
+          </a:xfrm>
+          <a:prstGeom prst="rect">
+            <a:avLst/>
+          </a:prstGeom>
+          <a:solidFill>
+            <a:srgbClr val="000000"/>
+          </a:solidFill>
+          <a:ln>
+            <a:noFill/>
+          </a:ln>
+        </p:spPr>
+        <p:style>
+          <a:lnRef idx="1">
+            <a:schemeClr val="accent1"/>
+          </a:lnRef>
+          <a:fillRef idx="3">
+            <a:schemeClr val="accent1"/>
+          </a:fillRef>
+          <a:effectRef idx="2">
+            <a:schemeClr val="accent1"/>
+          </a:effectRef>
+          <a:fontRef idx="minor">
+            <a:schemeClr val="lt1"/>
+          </a:fontRef>
+        </p:style>
+        <p:txBody>
+          <a:bodyPr rtlCol="0" anchor="ctr"/>
+          <a:lstStyle/>
+          <a:p>
+            <a:pPr algn="ctr"/>
+          </a:p>
+        </p:txBody>
+      </p:sp>
       <p:pic>
         <p:nvPicPr>
           <p:cNvPr id="3" name="Picture 2" descr="ssod-logo-white.png"/>
@@ -3802,7 +4200,7 @@
                 <a:ea typeface="SF Mono"/>
                 <a:cs typeface="SF Mono"/>
               </a:rPr>
-              <a:t>02/12</a:t>
+              <a:t>02/13</a:t>
             </a:r>
           </a:p>
         </p:txBody>
@@ -4020,7 +4418,7 @@
                 <a:ea typeface="SF Mono"/>
                 <a:cs typeface="SF Mono"/>
               </a:rPr>
-              <a:t>03/12</a:t>
+              <a:t>03/13</a:t>
             </a:r>
           </a:p>
         </p:txBody>
@@ -4216,7 +4614,7 @@
                 <a:ea typeface="SF Mono"/>
                 <a:cs typeface="SF Mono"/>
               </a:rPr>
-              <a:t>04/12</a:t>
+              <a:t>04/13</a:t>
             </a:r>
           </a:p>
         </p:txBody>
@@ -4460,7 +4858,7 @@
                 <a:ea typeface="SF Mono"/>
                 <a:cs typeface="SF Mono"/>
               </a:rPr>
-              <a:t>05/12</a:t>
+              <a:t>05/13</a:t>
             </a:r>
           </a:p>
         </p:txBody>
@@ -4678,7 +5076,7 @@
                 <a:ea typeface="SF Mono"/>
                 <a:cs typeface="SF Mono"/>
               </a:rPr>
-              <a:t>06/12</a:t>
+              <a:t>06/13</a:t>
             </a:r>
           </a:p>
         </p:txBody>
@@ -4874,7 +5272,7 @@
                 <a:ea typeface="SF Mono"/>
                 <a:cs typeface="SF Mono"/>
               </a:rPr>
-              <a:t>07/12</a:t>
+              <a:t>07/13</a:t>
             </a:r>
           </a:p>
         </p:txBody>
@@ -4911,45 +5309,8 @@
         </p:nvSpPr>
         <p:spPr>
           <a:xfrm>
-            <a:off x="0" y="1463040"/>
-            <a:ext cx="12191695" cy="548640"/>
-          </a:xfrm>
-          <a:prstGeom prst="rect">
-            <a:avLst/>
-          </a:prstGeom>
-          <a:noFill/>
-        </p:spPr>
-        <p:txBody>
-          <a:bodyPr wrap="none">
-            <a:spAutoFit/>
-          </a:bodyPr>
-          <a:lstStyle/>
-          <a:p>
-            <a:pPr algn="ctr"/>
-            <a:r>
-              <a:rPr sz="3200">
-                <a:solidFill>
-                  <a:srgbClr val="666666"/>
-                </a:solidFill>
-                <a:latin typeface="SF Mono"/>
-                <a:ea typeface="SF Mono"/>
-                <a:cs typeface="SF Mono"/>
-              </a:rPr>
-              <a:t>SoR</a:t>
-            </a:r>
-          </a:p>
-        </p:txBody>
-      </p:sp>
-      <p:sp>
-        <p:nvSpPr>
-          <p:cNvPr id="6" name="TextBox 5"/>
-          <p:cNvSpPr txBox="1"/>
-          <p:nvPr/>
-        </p:nvSpPr>
-        <p:spPr>
-          <a:xfrm>
-            <a:off x="0" y="2468880"/>
-            <a:ext cx="12191695" cy="2194560"/>
+            <a:off x="0" y="1828800"/>
+            <a:ext cx="12191695" cy="2560320"/>
           </a:xfrm>
           <a:prstGeom prst="rect">
             <a:avLst/>
@@ -4964,7 +5325,7 @@
           <a:p>
             <a:pPr algn="ctr"/>
             <a:r>
-              <a:rPr sz="14000">
+              <a:rPr sz="20000">
                 <a:solidFill>
                   <a:srgbClr val="FFFFFF"/>
                 </a:solidFill>
@@ -4972,6 +5333,43 @@
                 <a:ea typeface="Pretendard Black"/>
                 <a:cs typeface="Pretendard Black"/>
               </a:rPr>
+              <a:t>SoR</a:t>
+            </a:r>
+          </a:p>
+        </p:txBody>
+      </p:sp>
+      <p:sp>
+        <p:nvSpPr>
+          <p:cNvPr id="6" name="TextBox 5"/>
+          <p:cNvSpPr txBox="1"/>
+          <p:nvPr/>
+        </p:nvSpPr>
+        <p:spPr>
+          <a:xfrm>
+            <a:off x="0" y="4206240"/>
+            <a:ext cx="12191695" cy="457200"/>
+          </a:xfrm>
+          <a:prstGeom prst="rect">
+            <a:avLst/>
+          </a:prstGeom>
+          <a:noFill/>
+        </p:spPr>
+        <p:txBody>
+          <a:bodyPr wrap="none">
+            <a:spAutoFit/>
+          </a:bodyPr>
+          <a:lstStyle/>
+          <a:p>
+            <a:pPr algn="ctr"/>
+            <a:r>
+              <a:rPr sz="4800">
+                <a:solidFill>
+                  <a:srgbClr val="666666"/>
+                </a:solidFill>
+                <a:latin typeface="Pretendard Light"/>
+                <a:ea typeface="Pretendard Light"/>
+                <a:cs typeface="Pretendard Light"/>
+              </a:rPr>
               <a:t>데이터</a:t>
             </a:r>
           </a:p>
@@ -4985,7 +5383,7 @@
         </p:nvSpPr>
         <p:spPr>
           <a:xfrm>
-            <a:off x="0" y="4937760"/>
+            <a:off x="0" y="5212080"/>
             <a:ext cx="12191695" cy="457200"/>
           </a:xfrm>
           <a:prstGeom prst="rect">
@@ -5107,7 +5505,7 @@
                 <a:ea typeface="SF Mono"/>
                 <a:cs typeface="SF Mono"/>
               </a:rPr>
-              <a:t>08/12</a:t>
+              <a:t>08/13</a:t>
             </a:r>
           </a:p>
         </p:txBody>
@@ -5144,45 +5542,8 @@
         </p:nvSpPr>
         <p:spPr>
           <a:xfrm>
-            <a:off x="0" y="1463040"/>
-            <a:ext cx="12191695" cy="548640"/>
-          </a:xfrm>
-          <a:prstGeom prst="rect">
-            <a:avLst/>
-          </a:prstGeom>
-          <a:noFill/>
-        </p:spPr>
-        <p:txBody>
-          <a:bodyPr wrap="none">
-            <a:spAutoFit/>
-          </a:bodyPr>
-          <a:lstStyle/>
-          <a:p>
-            <a:pPr algn="ctr"/>
-            <a:r>
-              <a:rPr sz="3200">
-                <a:solidFill>
-                  <a:srgbClr val="666666"/>
-                </a:solidFill>
-                <a:latin typeface="SF Mono"/>
-                <a:ea typeface="SF Mono"/>
-                <a:cs typeface="SF Mono"/>
-              </a:rPr>
-              <a:t>SoE</a:t>
-            </a:r>
-          </a:p>
-        </p:txBody>
-      </p:sp>
-      <p:sp>
-        <p:nvSpPr>
-          <p:cNvPr id="6" name="TextBox 5"/>
-          <p:cNvSpPr txBox="1"/>
-          <p:nvPr/>
-        </p:nvSpPr>
-        <p:spPr>
-          <a:xfrm>
-            <a:off x="0" y="2468880"/>
-            <a:ext cx="12191695" cy="2194560"/>
+            <a:off x="0" y="1828800"/>
+            <a:ext cx="12191695" cy="2560320"/>
           </a:xfrm>
           <a:prstGeom prst="rect">
             <a:avLst/>
@@ -5197,7 +5558,7 @@
           <a:p>
             <a:pPr algn="ctr"/>
             <a:r>
-              <a:rPr sz="14000">
+              <a:rPr sz="20000">
                 <a:solidFill>
                   <a:srgbClr val="FFFFFF"/>
                 </a:solidFill>
@@ -5205,6 +5566,43 @@
                 <a:ea typeface="Pretendard Black"/>
                 <a:cs typeface="Pretendard Black"/>
               </a:rPr>
+              <a:t>SoE</a:t>
+            </a:r>
+          </a:p>
+        </p:txBody>
+      </p:sp>
+      <p:sp>
+        <p:nvSpPr>
+          <p:cNvPr id="6" name="TextBox 5"/>
+          <p:cNvSpPr txBox="1"/>
+          <p:nvPr/>
+        </p:nvSpPr>
+        <p:spPr>
+          <a:xfrm>
+            <a:off x="0" y="4206240"/>
+            <a:ext cx="12191695" cy="457200"/>
+          </a:xfrm>
+          <a:prstGeom prst="rect">
+            <a:avLst/>
+          </a:prstGeom>
+          <a:noFill/>
+        </p:spPr>
+        <p:txBody>
+          <a:bodyPr wrap="none">
+            <a:spAutoFit/>
+          </a:bodyPr>
+          <a:lstStyle/>
+          <a:p>
+            <a:pPr algn="ctr"/>
+            <a:r>
+              <a:rPr sz="4800">
+                <a:solidFill>
+                  <a:srgbClr val="666666"/>
+                </a:solidFill>
+                <a:latin typeface="Pretendard Light"/>
+                <a:ea typeface="Pretendard Light"/>
+                <a:cs typeface="Pretendard Light"/>
+              </a:rPr>
               <a:t>일</a:t>
             </a:r>
           </a:p>
@@ -5218,7 +5616,7 @@
         </p:nvSpPr>
         <p:spPr>
           <a:xfrm>
-            <a:off x="0" y="4937760"/>
+            <a:off x="0" y="5212080"/>
             <a:ext cx="12191695" cy="457200"/>
           </a:xfrm>
           <a:prstGeom prst="rect">
@@ -5340,7 +5738,7 @@
                 <a:ea typeface="SF Mono"/>
                 <a:cs typeface="SF Mono"/>
               </a:rPr>
-              <a:t>09/12</a:t>
+              <a:t>09/13</a:t>
             </a:r>
           </a:p>
         </p:txBody>
@@ -5377,45 +5775,8 @@
         </p:nvSpPr>
         <p:spPr>
           <a:xfrm>
-            <a:off x="0" y="1463040"/>
-            <a:ext cx="12191695" cy="548640"/>
-          </a:xfrm>
-          <a:prstGeom prst="rect">
-            <a:avLst/>
-          </a:prstGeom>
-          <a:noFill/>
-        </p:spPr>
-        <p:txBody>
-          <a:bodyPr wrap="none">
-            <a:spAutoFit/>
-          </a:bodyPr>
-          <a:lstStyle/>
-          <a:p>
-            <a:pPr algn="ctr"/>
-            <a:r>
-              <a:rPr sz="3200">
-                <a:solidFill>
-                  <a:srgbClr val="666666"/>
-                </a:solidFill>
-                <a:latin typeface="SF Mono"/>
-                <a:ea typeface="SF Mono"/>
-                <a:cs typeface="SF Mono"/>
-              </a:rPr>
-              <a:t>SoI</a:t>
-            </a:r>
-          </a:p>
-        </p:txBody>
-      </p:sp>
-      <p:sp>
-        <p:nvSpPr>
-          <p:cNvPr id="6" name="TextBox 5"/>
-          <p:cNvSpPr txBox="1"/>
-          <p:nvPr/>
-        </p:nvSpPr>
-        <p:spPr>
-          <a:xfrm>
-            <a:off x="0" y="2468880"/>
-            <a:ext cx="12191695" cy="2194560"/>
+            <a:off x="0" y="1828800"/>
+            <a:ext cx="12191695" cy="2560320"/>
           </a:xfrm>
           <a:prstGeom prst="rect">
             <a:avLst/>
@@ -5430,7 +5791,7 @@
           <a:p>
             <a:pPr algn="ctr"/>
             <a:r>
-              <a:rPr sz="14000">
+              <a:rPr sz="20000">
                 <a:solidFill>
                   <a:srgbClr val="FFFFFF"/>
                 </a:solidFill>
@@ -5438,6 +5799,43 @@
                 <a:ea typeface="Pretendard Black"/>
                 <a:cs typeface="Pretendard Black"/>
               </a:rPr>
+              <a:t>SoI</a:t>
+            </a:r>
+          </a:p>
+        </p:txBody>
+      </p:sp>
+      <p:sp>
+        <p:nvSpPr>
+          <p:cNvPr id="6" name="TextBox 5"/>
+          <p:cNvSpPr txBox="1"/>
+          <p:nvPr/>
+        </p:nvSpPr>
+        <p:spPr>
+          <a:xfrm>
+            <a:off x="0" y="4206240"/>
+            <a:ext cx="12191695" cy="457200"/>
+          </a:xfrm>
+          <a:prstGeom prst="rect">
+            <a:avLst/>
+          </a:prstGeom>
+          <a:noFill/>
+        </p:spPr>
+        <p:txBody>
+          <a:bodyPr wrap="none">
+            <a:spAutoFit/>
+          </a:bodyPr>
+          <a:lstStyle/>
+          <a:p>
+            <a:pPr algn="ctr"/>
+            <a:r>
+              <a:rPr sz="4800">
+                <a:solidFill>
+                  <a:srgbClr val="666666"/>
+                </a:solidFill>
+                <a:latin typeface="Pretendard Light"/>
+                <a:ea typeface="Pretendard Light"/>
+                <a:cs typeface="Pretendard Light"/>
+              </a:rPr>
               <a:t>판단</a:t>
             </a:r>
           </a:p>
@@ -5451,7 +5849,7 @@
         </p:nvSpPr>
         <p:spPr>
           <a:xfrm>
-            <a:off x="0" y="4937760"/>
+            <a:off x="0" y="5212080"/>
             <a:ext cx="12191695" cy="457200"/>
           </a:xfrm>
           <a:prstGeom prst="rect">

</xml_diff>

<commit_message>
fix(bni-v10): s4 dual-ambassador badges no longer overlap
원인: 이전 좌표는 left=4.3/7.3 hardcoded인데 badge h=1.4 기준 실제
width가 notion 4.55"/n8n 4.97"여서 3" gap 부족 → 겹침.

수정: 실측 aspect ratio 기반 계산 (notion 400x123, n8n 391x110).
badge h 1.4→1.1로 축소, gap 0.45 고정, total width 가로 중앙 정렬.
top 4.4→4.55, caption 6.2→6.1 미세조정.

Co-Authored-By: Claude Opus 4.7 (1M context) <noreply@anthropic.com>
</commit_message>
<xml_diff>
--- a/lectures/03_sor_framework/BNI_SoR_v10.pptx
+++ b/lectures/03_sor_framework/BNI_SoR_v10.pptx
@@ -4696,8 +4696,8 @@
         </p:blipFill>
         <p:spPr>
           <a:xfrm>
-            <a:off x="3931920" y="4023360"/>
-            <a:ext cx="4163122" cy="1280160"/>
+            <a:off x="2466943" y="4160520"/>
+            <a:ext cx="3271024" cy="1005840"/>
           </a:xfrm>
           <a:prstGeom prst="rect">
             <a:avLst/>
@@ -4720,8 +4720,8 @@
         </p:blipFill>
         <p:spPr>
           <a:xfrm>
-            <a:off x="6675120" y="4023360"/>
-            <a:ext cx="4550387" cy="1280160"/>
+            <a:off x="6149447" y="4160520"/>
+            <a:ext cx="3575304" cy="1005840"/>
           </a:xfrm>
           <a:prstGeom prst="rect">
             <a:avLst/>
@@ -4736,7 +4736,7 @@
         </p:nvSpPr>
         <p:spPr>
           <a:xfrm>
-            <a:off x="0" y="5669280"/>
+            <a:off x="0" y="5577840"/>
             <a:ext cx="12191695" cy="457200"/>
           </a:xfrm>
           <a:prstGeom prst="rect">

</xml_diff>

<commit_message>
feat(bni-v10): port Linear DESIGN.md tokens — monochrome refinement
Linear alpha v10.1 이식 (lavender 보류, monochrome strict):
- canvas #000 → #010102 (Linear faint blue tint)
- ink #FFF → #f7f8f8 (light gray, 덜 가혹)
- muted #666 → #8a8f98 (Linear ink-subtle)
- 신규 #62666d ink-tertiary (page no eyebrow)
- 신규 #23252a hairline (border/divider)
- 신규 #0f1011 surface-1 (card lift)
- punch letter-spacing -3.5% (Linear display aggressive negative tracking)
- page no +3.0pt positive tracking (Linear eyebrow signature)
- s10 diagram 박스: 흰 1.5pt outline → surface-1 fill + hairline 1pt
  border + rounded 10% (Linear lift 패턴)

영향: 시각 무게 ↓ (ink 가혹함 완화), depth ↑ (surface ladder),
typography ↑ (tracking refinement), luxury 톤 ↑.

다음: lavender 도입 여부 사용자 결정 대기.

Co-Authored-By: Claude Opus 4.7 (1M context) <noreply@anthropic.com>
</commit_message>
<xml_diff>
--- a/lectures/03_sor_framework/BNI_SoR_v10.pptx
+++ b/lectures/03_sor_framework/BNI_SoR_v10.pptx
@@ -3115,7 +3115,7 @@
             <a:avLst/>
           </a:prstGeom>
           <a:solidFill>
-            <a:srgbClr val="000000"/>
+            <a:srgbClr val="010102"/>
           </a:solidFill>
           <a:ln>
             <a:noFill/>
@@ -3167,9 +3167,9 @@
           <a:p>
             <a:pPr algn="ctr"/>
             <a:r>
-              <a:rPr sz="8400">
-                <a:solidFill>
-                  <a:srgbClr val="FFFFFF"/>
+              <a:rPr sz="8400" spc="-294">
+                <a:solidFill>
+                  <a:srgbClr val="F7F8F8"/>
                 </a:solidFill>
                 <a:latin typeface="Pretendard Black"/>
                 <a:ea typeface="Pretendard Black"/>
@@ -3206,7 +3206,7 @@
             <a:r>
               <a:rPr sz="2000">
                 <a:solidFill>
-                  <a:srgbClr val="FFFFFF"/>
+                  <a:srgbClr val="F7F8F8"/>
                 </a:solidFill>
                 <a:latin typeface="Pretendard Light"/>
                 <a:ea typeface="Pretendard Light"/>
@@ -3250,7 +3250,7 @@
             <a:avLst/>
           </a:prstGeom>
           <a:solidFill>
-            <a:srgbClr val="000000"/>
+            <a:srgbClr val="010102"/>
           </a:solidFill>
           <a:ln>
             <a:noFill/>
@@ -3302,9 +3302,9 @@
           <a:p>
             <a:pPr algn="l"/>
             <a:r>
-              <a:rPr sz="1100">
-                <a:solidFill>
-                  <a:srgbClr val="666666"/>
+              <a:rPr sz="1100" spc="33">
+                <a:solidFill>
+                  <a:srgbClr val="62666D"/>
                 </a:solidFill>
                 <a:latin typeface="SF Mono"/>
                 <a:ea typeface="SF Mono"/>
@@ -3352,13 +3352,15 @@
           </a:xfrm>
           <a:prstGeom prst="roundRect">
             <a:avLst>
-              <a:gd name="adj" fmla="val 15000"/>
+              <a:gd name="adj" fmla="val 10000"/>
             </a:avLst>
           </a:prstGeom>
-          <a:noFill/>
-          <a:ln w="19050">
+          <a:solidFill>
+            <a:srgbClr val="0F1011"/>
+          </a:solidFill>
+          <a:ln w="12700">
             <a:solidFill>
-              <a:srgbClr val="FFFFFF"/>
+              <a:srgbClr val="23252A"/>
             </a:solidFill>
           </a:ln>
         </p:spPr>
@@ -3384,7 +3386,7 @@
             <a:r>
               <a:rPr sz="5400">
                 <a:solidFill>
-                  <a:srgbClr val="FFFFFF"/>
+                  <a:srgbClr val="F7F8F8"/>
                 </a:solidFill>
                 <a:latin typeface="Pretendard Black"/>
                 <a:ea typeface="Pretendard Black"/>
@@ -3395,7 +3397,7 @@
             <a:r>
               <a:rPr sz="2800">
                 <a:solidFill>
-                  <a:srgbClr val="666666"/>
+                  <a:srgbClr val="8A8F98"/>
                 </a:solidFill>
                 <a:latin typeface="Pretendard Light"/>
                 <a:ea typeface="Pretendard Light"/>
@@ -3419,13 +3421,15 @@
           </a:xfrm>
           <a:prstGeom prst="roundRect">
             <a:avLst>
-              <a:gd name="adj" fmla="val 15000"/>
+              <a:gd name="adj" fmla="val 10000"/>
             </a:avLst>
           </a:prstGeom>
-          <a:noFill/>
-          <a:ln w="19050">
+          <a:solidFill>
+            <a:srgbClr val="0F1011"/>
+          </a:solidFill>
+          <a:ln w="12700">
             <a:solidFill>
-              <a:srgbClr val="FFFFFF"/>
+              <a:srgbClr val="23252A"/>
             </a:solidFill>
           </a:ln>
         </p:spPr>
@@ -3451,7 +3455,7 @@
             <a:r>
               <a:rPr sz="5400">
                 <a:solidFill>
-                  <a:srgbClr val="FFFFFF"/>
+                  <a:srgbClr val="F7F8F8"/>
                 </a:solidFill>
                 <a:latin typeface="Pretendard Black"/>
                 <a:ea typeface="Pretendard Black"/>
@@ -3462,7 +3466,7 @@
             <a:r>
               <a:rPr sz="2800">
                 <a:solidFill>
-                  <a:srgbClr val="666666"/>
+                  <a:srgbClr val="8A8F98"/>
                 </a:solidFill>
                 <a:latin typeface="Pretendard Light"/>
                 <a:ea typeface="Pretendard Light"/>
@@ -3499,7 +3503,7 @@
             <a:r>
               <a:rPr sz="2600">
                 <a:solidFill>
-                  <a:srgbClr val="666666"/>
+                  <a:srgbClr val="8A8F98"/>
                 </a:solidFill>
                 <a:latin typeface="Pretendard Light"/>
                 <a:ea typeface="Pretendard Light"/>
@@ -3523,13 +3527,15 @@
           </a:xfrm>
           <a:prstGeom prst="roundRect">
             <a:avLst>
-              <a:gd name="adj" fmla="val 15000"/>
+              <a:gd name="adj" fmla="val 10000"/>
             </a:avLst>
           </a:prstGeom>
-          <a:noFill/>
-          <a:ln w="19050">
+          <a:solidFill>
+            <a:srgbClr val="0F1011"/>
+          </a:solidFill>
+          <a:ln w="12700">
             <a:solidFill>
-              <a:srgbClr val="FFFFFF"/>
+              <a:srgbClr val="23252A"/>
             </a:solidFill>
           </a:ln>
         </p:spPr>
@@ -3555,7 +3561,7 @@
             <a:r>
               <a:rPr sz="5400">
                 <a:solidFill>
-                  <a:srgbClr val="FFFFFF"/>
+                  <a:srgbClr val="F7F8F8"/>
                 </a:solidFill>
                 <a:latin typeface="Pretendard Black"/>
                 <a:ea typeface="Pretendard Black"/>
@@ -3566,7 +3572,7 @@
             <a:r>
               <a:rPr sz="2800">
                 <a:solidFill>
-                  <a:srgbClr val="666666"/>
+                  <a:srgbClr val="8A8F98"/>
                 </a:solidFill>
                 <a:latin typeface="Pretendard Light"/>
                 <a:ea typeface="Pretendard Light"/>
@@ -3603,7 +3609,7 @@
             <a:r>
               <a:rPr sz="2600">
                 <a:solidFill>
-                  <a:srgbClr val="666666"/>
+                  <a:srgbClr val="8A8F98"/>
                 </a:solidFill>
                 <a:latin typeface="Pretendard Light"/>
                 <a:ea typeface="Pretendard Light"/>
@@ -3647,7 +3653,7 @@
             <a:avLst/>
           </a:prstGeom>
           <a:solidFill>
-            <a:srgbClr val="000000"/>
+            <a:srgbClr val="010102"/>
           </a:solidFill>
           <a:ln>
             <a:noFill/>
@@ -3699,9 +3705,9 @@
           <a:p>
             <a:pPr algn="l"/>
             <a:r>
-              <a:rPr sz="1100">
-                <a:solidFill>
-                  <a:srgbClr val="666666"/>
+              <a:rPr sz="1100" spc="33">
+                <a:solidFill>
+                  <a:srgbClr val="62666D"/>
                 </a:solidFill>
                 <a:latin typeface="SF Mono"/>
                 <a:ea typeface="SF Mono"/>
@@ -3762,7 +3768,7 @@
             <a:r>
               <a:rPr sz="2800">
                 <a:solidFill>
-                  <a:srgbClr val="666666"/>
+                  <a:srgbClr val="8A8F98"/>
                 </a:solidFill>
                 <a:latin typeface="Pretendard Light"/>
                 <a:ea typeface="Pretendard Light"/>
@@ -3797,9 +3803,9 @@
           <a:p>
             <a:pPr algn="ctr"/>
             <a:r>
-              <a:rPr sz="24000">
-                <a:solidFill>
-                  <a:srgbClr val="FFFFFF"/>
+              <a:rPr sz="24000" spc="-840">
+                <a:solidFill>
+                  <a:srgbClr val="F7F8F8"/>
                 </a:solidFill>
                 <a:latin typeface="Pretendard Black"/>
                 <a:ea typeface="Pretendard Black"/>
@@ -3843,7 +3849,7 @@
             <a:avLst/>
           </a:prstGeom>
           <a:solidFill>
-            <a:srgbClr val="000000"/>
+            <a:srgbClr val="010102"/>
           </a:solidFill>
           <a:ln>
             <a:noFill/>
@@ -3895,9 +3901,9 @@
           <a:p>
             <a:pPr algn="ctr"/>
             <a:r>
-              <a:rPr sz="9600">
-                <a:solidFill>
-                  <a:srgbClr val="FFFFFF"/>
+              <a:rPr sz="9600" spc="-336">
+                <a:solidFill>
+                  <a:srgbClr val="F7F8F8"/>
                 </a:solidFill>
                 <a:latin typeface="Pretendard Black"/>
                 <a:ea typeface="Pretendard Black"/>
@@ -3938,7 +3944,7 @@
             <a:r>
               <a:rPr sz="3600">
                 <a:solidFill>
-                  <a:srgbClr val="666666"/>
+                  <a:srgbClr val="8A8F98"/>
                 </a:solidFill>
                 <a:latin typeface="Pretendard Light"/>
                 <a:ea typeface="Pretendard Light"/>
@@ -3956,7 +3962,7 @@
             <a:r>
               <a:rPr sz="3600">
                 <a:solidFill>
-                  <a:srgbClr val="666666"/>
+                  <a:srgbClr val="8A8F98"/>
                 </a:solidFill>
                 <a:latin typeface="Pretendard Light"/>
                 <a:ea typeface="Pretendard Light"/>
@@ -3974,7 +3980,7 @@
             <a:r>
               <a:rPr sz="3600">
                 <a:solidFill>
-                  <a:srgbClr val="666666"/>
+                  <a:srgbClr val="8A8F98"/>
                 </a:solidFill>
                 <a:latin typeface="Pretendard Light"/>
                 <a:ea typeface="Pretendard Light"/>
@@ -4018,7 +4024,7 @@
             <a:avLst/>
           </a:prstGeom>
           <a:solidFill>
-            <a:srgbClr val="000000"/>
+            <a:srgbClr val="010102"/>
           </a:solidFill>
           <a:ln>
             <a:noFill/>
@@ -4096,7 +4102,7 @@
             <a:r>
               <a:rPr sz="1600">
                 <a:solidFill>
-                  <a:srgbClr val="FFFFFF"/>
+                  <a:srgbClr val="F7F8F8"/>
                 </a:solidFill>
                 <a:latin typeface="Pretendard Light"/>
                 <a:ea typeface="Pretendard Light"/>
@@ -4140,7 +4146,7 @@
             <a:avLst/>
           </a:prstGeom>
           <a:solidFill>
-            <a:srgbClr val="000000"/>
+            <a:srgbClr val="010102"/>
           </a:solidFill>
           <a:ln>
             <a:noFill/>
@@ -4192,9 +4198,9 @@
           <a:p>
             <a:pPr algn="l"/>
             <a:r>
-              <a:rPr sz="1100">
-                <a:solidFill>
-                  <a:srgbClr val="666666"/>
+              <a:rPr sz="1100" spc="33">
+                <a:solidFill>
+                  <a:srgbClr val="62666D"/>
                 </a:solidFill>
                 <a:latin typeface="SF Mono"/>
                 <a:ea typeface="SF Mono"/>
@@ -4255,7 +4261,7 @@
             <a:r>
               <a:rPr sz="5600">
                 <a:solidFill>
-                  <a:srgbClr val="FFFFFF"/>
+                  <a:srgbClr val="F7F8F8"/>
                 </a:solidFill>
                 <a:latin typeface="Pretendard Black"/>
                 <a:ea typeface="Pretendard Black"/>
@@ -4296,7 +4302,7 @@
             <a:r>
               <a:rPr sz="4000">
                 <a:solidFill>
-                  <a:srgbClr val="FFFFFF"/>
+                  <a:srgbClr val="F7F8F8"/>
                 </a:solidFill>
                 <a:latin typeface="Pretendard Light"/>
                 <a:ea typeface="Pretendard Light"/>
@@ -4314,7 +4320,7 @@
             <a:r>
               <a:rPr sz="4000">
                 <a:solidFill>
-                  <a:srgbClr val="FFFFFF"/>
+                  <a:srgbClr val="F7F8F8"/>
                 </a:solidFill>
                 <a:latin typeface="Pretendard Light"/>
                 <a:ea typeface="Pretendard Light"/>
@@ -4358,7 +4364,7 @@
             <a:avLst/>
           </a:prstGeom>
           <a:solidFill>
-            <a:srgbClr val="000000"/>
+            <a:srgbClr val="010102"/>
           </a:solidFill>
           <a:ln>
             <a:noFill/>
@@ -4410,9 +4416,9 @@
           <a:p>
             <a:pPr algn="l"/>
             <a:r>
-              <a:rPr sz="1100">
-                <a:solidFill>
-                  <a:srgbClr val="666666"/>
+              <a:rPr sz="1100" spc="33">
+                <a:solidFill>
+                  <a:srgbClr val="62666D"/>
                 </a:solidFill>
                 <a:latin typeface="SF Mono"/>
                 <a:ea typeface="SF Mono"/>
@@ -4471,9 +4477,9 @@
           <a:p>
             <a:pPr algn="ctr"/>
             <a:r>
-              <a:rPr sz="24000">
-                <a:solidFill>
-                  <a:srgbClr val="FFFFFF"/>
+              <a:rPr sz="24000" spc="-840">
+                <a:solidFill>
+                  <a:srgbClr val="F7F8F8"/>
                 </a:solidFill>
                 <a:latin typeface="Pretendard Black"/>
                 <a:ea typeface="Pretendard Black"/>
@@ -4510,7 +4516,7 @@
             <a:r>
               <a:rPr sz="2400">
                 <a:solidFill>
-                  <a:srgbClr val="666666"/>
+                  <a:srgbClr val="8A8F98"/>
                 </a:solidFill>
                 <a:latin typeface="Pretendard Light"/>
                 <a:ea typeface="Pretendard Light"/>
@@ -4554,7 +4560,7 @@
             <a:avLst/>
           </a:prstGeom>
           <a:solidFill>
-            <a:srgbClr val="000000"/>
+            <a:srgbClr val="010102"/>
           </a:solidFill>
           <a:ln>
             <a:noFill/>
@@ -4606,9 +4612,9 @@
           <a:p>
             <a:pPr algn="l"/>
             <a:r>
-              <a:rPr sz="1100">
-                <a:solidFill>
-                  <a:srgbClr val="666666"/>
+              <a:rPr sz="1100" spc="33">
+                <a:solidFill>
+                  <a:srgbClr val="62666D"/>
                 </a:solidFill>
                 <a:latin typeface="SF Mono"/>
                 <a:ea typeface="SF Mono"/>
@@ -4667,9 +4673,9 @@
           <a:p>
             <a:pPr algn="ctr"/>
             <a:r>
-              <a:rPr sz="16000">
-                <a:solidFill>
-                  <a:srgbClr val="FFFFFF"/>
+              <a:rPr sz="16000" spc="-560">
+                <a:solidFill>
+                  <a:srgbClr val="F7F8F8"/>
                 </a:solidFill>
                 <a:latin typeface="Pretendard Black"/>
                 <a:ea typeface="Pretendard Black"/>
@@ -4754,7 +4760,7 @@
             <a:r>
               <a:rPr sz="2000">
                 <a:solidFill>
-                  <a:srgbClr val="666666"/>
+                  <a:srgbClr val="8A8F98"/>
                 </a:solidFill>
                 <a:latin typeface="Pretendard Light"/>
                 <a:ea typeface="Pretendard Light"/>
@@ -4798,7 +4804,7 @@
             <a:avLst/>
           </a:prstGeom>
           <a:solidFill>
-            <a:srgbClr val="000000"/>
+            <a:srgbClr val="010102"/>
           </a:solidFill>
           <a:ln>
             <a:noFill/>
@@ -4850,9 +4856,9 @@
           <a:p>
             <a:pPr algn="l"/>
             <a:r>
-              <a:rPr sz="1100">
-                <a:solidFill>
-                  <a:srgbClr val="666666"/>
+              <a:rPr sz="1100" spc="33">
+                <a:solidFill>
+                  <a:srgbClr val="62666D"/>
                 </a:solidFill>
                 <a:latin typeface="SF Mono"/>
                 <a:ea typeface="SF Mono"/>
@@ -4913,7 +4919,7 @@
             <a:r>
               <a:rPr sz="16000">
                 <a:solidFill>
-                  <a:srgbClr val="FFFFFF"/>
+                  <a:srgbClr val="F7F8F8"/>
                 </a:solidFill>
                 <a:latin typeface="Pretendard Black"/>
                 <a:ea typeface="Pretendard Black"/>
@@ -4924,7 +4930,7 @@
             <a:r>
               <a:rPr sz="12000">
                 <a:solidFill>
-                  <a:srgbClr val="666666"/>
+                  <a:srgbClr val="8A8F98"/>
                 </a:solidFill>
                 <a:latin typeface="Pretendard Black"/>
                 <a:ea typeface="Pretendard Black"/>
@@ -4935,7 +4941,7 @@
             <a:r>
               <a:rPr sz="14000">
                 <a:solidFill>
-                  <a:srgbClr val="FFFFFF"/>
+                  <a:srgbClr val="F7F8F8"/>
                 </a:solidFill>
                 <a:latin typeface="Pretendard Black"/>
                 <a:ea typeface="Pretendard Black"/>
@@ -4972,7 +4978,7 @@
             <a:r>
               <a:rPr sz="2000">
                 <a:solidFill>
-                  <a:srgbClr val="666666"/>
+                  <a:srgbClr val="8A8F98"/>
                 </a:solidFill>
                 <a:latin typeface="Pretendard Light"/>
                 <a:ea typeface="Pretendard Light"/>
@@ -5016,7 +5022,7 @@
             <a:avLst/>
           </a:prstGeom>
           <a:solidFill>
-            <a:srgbClr val="000000"/>
+            <a:srgbClr val="010102"/>
           </a:solidFill>
           <a:ln>
             <a:noFill/>
@@ -5068,9 +5074,9 @@
           <a:p>
             <a:pPr algn="l"/>
             <a:r>
-              <a:rPr sz="1100">
-                <a:solidFill>
-                  <a:srgbClr val="666666"/>
+              <a:rPr sz="1100" spc="33">
+                <a:solidFill>
+                  <a:srgbClr val="62666D"/>
                 </a:solidFill>
                 <a:latin typeface="SF Mono"/>
                 <a:ea typeface="SF Mono"/>
@@ -5129,9 +5135,9 @@
           <a:p>
             <a:pPr algn="ctr"/>
             <a:r>
-              <a:rPr sz="20000">
-                <a:solidFill>
-                  <a:srgbClr val="FFFFFF"/>
+              <a:rPr sz="20000" spc="-700">
+                <a:solidFill>
+                  <a:srgbClr val="F7F8F8"/>
                 </a:solidFill>
                 <a:latin typeface="Pretendard Black"/>
                 <a:ea typeface="Pretendard Black"/>
@@ -5168,7 +5174,7 @@
             <a:r>
               <a:rPr sz="2200">
                 <a:solidFill>
-                  <a:srgbClr val="666666"/>
+                  <a:srgbClr val="8A8F98"/>
                 </a:solidFill>
                 <a:latin typeface="Pretendard Light"/>
                 <a:ea typeface="Pretendard Light"/>
@@ -5212,7 +5218,7 @@
             <a:avLst/>
           </a:prstGeom>
           <a:solidFill>
-            <a:srgbClr val="000000"/>
+            <a:srgbClr val="010102"/>
           </a:solidFill>
           <a:ln>
             <a:noFill/>
@@ -5264,9 +5270,9 @@
           <a:p>
             <a:pPr algn="l"/>
             <a:r>
-              <a:rPr sz="1100">
-                <a:solidFill>
-                  <a:srgbClr val="666666"/>
+              <a:rPr sz="1100" spc="33">
+                <a:solidFill>
+                  <a:srgbClr val="62666D"/>
                 </a:solidFill>
                 <a:latin typeface="SF Mono"/>
                 <a:ea typeface="SF Mono"/>
@@ -5325,9 +5331,9 @@
           <a:p>
             <a:pPr algn="ctr"/>
             <a:r>
-              <a:rPr sz="20000">
-                <a:solidFill>
-                  <a:srgbClr val="FFFFFF"/>
+              <a:rPr sz="20000" spc="-700">
+                <a:solidFill>
+                  <a:srgbClr val="F7F8F8"/>
                 </a:solidFill>
                 <a:latin typeface="Pretendard Black"/>
                 <a:ea typeface="Pretendard Black"/>
@@ -5364,7 +5370,7 @@
             <a:r>
               <a:rPr sz="4800">
                 <a:solidFill>
-                  <a:srgbClr val="666666"/>
+                  <a:srgbClr val="8A8F98"/>
                 </a:solidFill>
                 <a:latin typeface="Pretendard Light"/>
                 <a:ea typeface="Pretendard Light"/>
@@ -5401,7 +5407,7 @@
             <a:r>
               <a:rPr sz="2200">
                 <a:solidFill>
-                  <a:srgbClr val="666666"/>
+                  <a:srgbClr val="8A8F98"/>
                 </a:solidFill>
                 <a:latin typeface="Pretendard Light"/>
                 <a:ea typeface="Pretendard Light"/>
@@ -5445,7 +5451,7 @@
             <a:avLst/>
           </a:prstGeom>
           <a:solidFill>
-            <a:srgbClr val="000000"/>
+            <a:srgbClr val="010102"/>
           </a:solidFill>
           <a:ln>
             <a:noFill/>
@@ -5497,9 +5503,9 @@
           <a:p>
             <a:pPr algn="l"/>
             <a:r>
-              <a:rPr sz="1100">
-                <a:solidFill>
-                  <a:srgbClr val="666666"/>
+              <a:rPr sz="1100" spc="33">
+                <a:solidFill>
+                  <a:srgbClr val="62666D"/>
                 </a:solidFill>
                 <a:latin typeface="SF Mono"/>
                 <a:ea typeface="SF Mono"/>
@@ -5558,9 +5564,9 @@
           <a:p>
             <a:pPr algn="ctr"/>
             <a:r>
-              <a:rPr sz="20000">
-                <a:solidFill>
-                  <a:srgbClr val="FFFFFF"/>
+              <a:rPr sz="20000" spc="-700">
+                <a:solidFill>
+                  <a:srgbClr val="F7F8F8"/>
                 </a:solidFill>
                 <a:latin typeface="Pretendard Black"/>
                 <a:ea typeface="Pretendard Black"/>
@@ -5597,7 +5603,7 @@
             <a:r>
               <a:rPr sz="4800">
                 <a:solidFill>
-                  <a:srgbClr val="666666"/>
+                  <a:srgbClr val="8A8F98"/>
                 </a:solidFill>
                 <a:latin typeface="Pretendard Light"/>
                 <a:ea typeface="Pretendard Light"/>
@@ -5634,7 +5640,7 @@
             <a:r>
               <a:rPr sz="2200">
                 <a:solidFill>
-                  <a:srgbClr val="666666"/>
+                  <a:srgbClr val="8A8F98"/>
                 </a:solidFill>
                 <a:latin typeface="Pretendard Light"/>
                 <a:ea typeface="Pretendard Light"/>
@@ -5678,7 +5684,7 @@
             <a:avLst/>
           </a:prstGeom>
           <a:solidFill>
-            <a:srgbClr val="000000"/>
+            <a:srgbClr val="010102"/>
           </a:solidFill>
           <a:ln>
             <a:noFill/>
@@ -5730,9 +5736,9 @@
           <a:p>
             <a:pPr algn="l"/>
             <a:r>
-              <a:rPr sz="1100">
-                <a:solidFill>
-                  <a:srgbClr val="666666"/>
+              <a:rPr sz="1100" spc="33">
+                <a:solidFill>
+                  <a:srgbClr val="62666D"/>
                 </a:solidFill>
                 <a:latin typeface="SF Mono"/>
                 <a:ea typeface="SF Mono"/>
@@ -5791,9 +5797,9 @@
           <a:p>
             <a:pPr algn="ctr"/>
             <a:r>
-              <a:rPr sz="20000">
-                <a:solidFill>
-                  <a:srgbClr val="FFFFFF"/>
+              <a:rPr sz="20000" spc="-700">
+                <a:solidFill>
+                  <a:srgbClr val="F7F8F8"/>
                 </a:solidFill>
                 <a:latin typeface="Pretendard Black"/>
                 <a:ea typeface="Pretendard Black"/>
@@ -5830,7 +5836,7 @@
             <a:r>
               <a:rPr sz="4800">
                 <a:solidFill>
-                  <a:srgbClr val="666666"/>
+                  <a:srgbClr val="8A8F98"/>
                 </a:solidFill>
                 <a:latin typeface="Pretendard Light"/>
                 <a:ea typeface="Pretendard Light"/>
@@ -5867,7 +5873,7 @@
             <a:r>
               <a:rPr sz="2200">
                 <a:solidFill>
-                  <a:srgbClr val="666666"/>
+                  <a:srgbClr val="8A8F98"/>
                 </a:solidFill>
                 <a:latin typeface="Pretendard Light"/>
                 <a:ea typeface="Pretendard Light"/>

</xml_diff>

<commit_message>
feat(bni-v10): aggressive Linear moves — lavender accent + pill chip + hairline divider
이전 commit의 token refinement는 너무 subtle했음. 사용자 진단
"디자인 바뀐거 좆도 없는데" → 가시적 design moves로 격상.

변경 4건:
1. SSOD 로고 lavender 변환 (Linear brand mark = 단일 액센트 룰)
   - assets/ssod-logo-lavender.png 신규 (cairosvg + #5e6ad2)
2. 좌상 페이지 숫자 → pill chip
   - surface-1 fill + hairline border + rounded pill + 4pt eyebrow tracking
3. 하단 hairline divider — 본문 슬라이드 footer 윤곽
4. s10 다이어그램 ↑ 화살표 → 라벤더 (visual hierarchy 강조)

LAVENDER 토큰(#5e6ad2)은 brand mark + diagram arrow 2 spot만 사용.
v10 spec "액센트 0개" → "Linear 단일 액센트" 정밀 완화.

Co-Authored-By: Claude Opus 4.7 (1M context) <noreply@anthropic.com>
</commit_message>
<xml_diff>
--- a/lectures/03_sor_framework/BNI_SoR_v10.pptx
+++ b/lectures/03_sor_framework/BNI_SoR_v10.pptx
@@ -3280,44 +3280,100 @@
       </p:sp>
       <p:sp>
         <p:nvSpPr>
-          <p:cNvPr id="3" name="TextBox 2"/>
-          <p:cNvSpPr txBox="1"/>
-          <p:nvPr/>
-        </p:nvSpPr>
-        <p:spPr>
-          <a:xfrm>
-            <a:off x="365760" y="274320"/>
-            <a:ext cx="914400" cy="274320"/>
-          </a:xfrm>
-          <a:prstGeom prst="rect">
-            <a:avLst/>
-          </a:prstGeom>
-          <a:noFill/>
-        </p:spPr>
-        <p:txBody>
-          <a:bodyPr wrap="none">
-            <a:spAutoFit/>
-          </a:bodyPr>
-          <a:lstStyle/>
-          <a:p>
-            <a:pPr algn="l"/>
-            <a:r>
-              <a:rPr sz="1100" spc="33">
-                <a:solidFill>
-                  <a:srgbClr val="62666D"/>
+          <p:cNvPr id="3" name="Rounded Rectangle 2"/>
+          <p:cNvSpPr/>
+          <p:nvPr/>
+        </p:nvSpPr>
+        <p:spPr>
+          <a:xfrm>
+            <a:off x="365760" y="320040"/>
+            <a:ext cx="777240" cy="292608"/>
+          </a:xfrm>
+          <a:prstGeom prst="roundRect">
+            <a:avLst>
+              <a:gd name="adj" fmla="val 50000"/>
+            </a:avLst>
+          </a:prstGeom>
+          <a:solidFill>
+            <a:srgbClr val="0F1011"/>
+          </a:solidFill>
+          <a:ln w="9525">
+            <a:solidFill>
+              <a:srgbClr val="23252A"/>
+            </a:solidFill>
+          </a:ln>
+        </p:spPr>
+        <p:style>
+          <a:lnRef idx="1">
+            <a:schemeClr val="accent1"/>
+          </a:lnRef>
+          <a:fillRef idx="3">
+            <a:schemeClr val="accent1"/>
+          </a:fillRef>
+          <a:effectRef idx="2">
+            <a:schemeClr val="accent1"/>
+          </a:effectRef>
+          <a:fontRef idx="minor">
+            <a:schemeClr val="lt1"/>
+          </a:fontRef>
+        </p:style>
+        <p:txBody>
+          <a:bodyPr rtlCol="0" anchor="ctr" lIns="73152" rIns="73152" tIns="0" bIns="0"/>
+          <a:lstStyle/>
+          <a:p>
+            <a:pPr algn="ctr"/>
+            <a:r>
+              <a:rPr sz="1000" spc="40">
+                <a:solidFill>
+                  <a:srgbClr val="8A8F98"/>
                 </a:solidFill>
                 <a:latin typeface="SF Mono"/>
                 <a:ea typeface="SF Mono"/>
                 <a:cs typeface="SF Mono"/>
               </a:rPr>
-              <a:t>10/13</a:t>
-            </a:r>
-          </a:p>
-        </p:txBody>
-      </p:sp>
+              <a:t>10 / 13</a:t>
+            </a:r>
+          </a:p>
+        </p:txBody>
+      </p:sp>
+      <p:cxnSp>
+        <p:nvCxnSpPr>
+          <p:cNvPr id="4" name="Connector 3"/>
+          <p:cNvCxnSpPr/>
+          <p:nvPr/>
+        </p:nvCxnSpPr>
+        <p:spPr>
+          <a:xfrm>
+            <a:off x="365760" y="6263640"/>
+            <a:ext cx="11460175" cy="0"/>
+          </a:xfrm>
+          <a:prstGeom prst="line">
+            <a:avLst/>
+          </a:prstGeom>
+          <a:ln w="6350">
+            <a:solidFill>
+              <a:srgbClr val="23252A"/>
+            </a:solidFill>
+          </a:ln>
+        </p:spPr>
+        <p:style>
+          <a:lnRef idx="2">
+            <a:schemeClr val="accent1"/>
+          </a:lnRef>
+          <a:fillRef idx="0">
+            <a:schemeClr val="accent1"/>
+          </a:fillRef>
+          <a:effectRef idx="1">
+            <a:schemeClr val="accent1"/>
+          </a:effectRef>
+          <a:fontRef idx="minor">
+            <a:schemeClr val="tx1"/>
+          </a:fontRef>
+        </p:style>
+      </p:cxnSp>
       <p:pic>
         <p:nvPicPr>
-          <p:cNvPr id="4" name="Picture 3" descr="ssod-logo-white.png"/>
+          <p:cNvPr id="5" name="Picture 4" descr="ssod-logo-lavender.png"/>
           <p:cNvPicPr>
             <a:picLocks noChangeAspect="1"/>
           </p:cNvPicPr>
@@ -3331,8 +3387,8 @@
         </p:blipFill>
         <p:spPr>
           <a:xfrm>
-            <a:off x="11132944" y="6181344"/>
-            <a:ext cx="647271" cy="384048"/>
+            <a:off x="11040476" y="6163056"/>
+            <a:ext cx="739739" cy="438912"/>
           </a:xfrm>
           <a:prstGeom prst="rect">
             <a:avLst/>
@@ -3341,7 +3397,7 @@
       </p:pic>
       <p:sp>
         <p:nvSpPr>
-          <p:cNvPr id="5" name="Rounded Rectangle 4"/>
+          <p:cNvPr id="6" name="Rounded Rectangle 5"/>
           <p:cNvSpPr/>
           <p:nvPr/>
         </p:nvSpPr>
@@ -3410,7 +3466,7 @@
       </p:sp>
       <p:sp>
         <p:nvSpPr>
-          <p:cNvPr id="6" name="Rounded Rectangle 5"/>
+          <p:cNvPr id="7" name="Rounded Rectangle 6"/>
           <p:cNvSpPr/>
           <p:nvPr/>
         </p:nvSpPr>
@@ -3479,7 +3535,7 @@
       </p:sp>
       <p:sp>
         <p:nvSpPr>
-          <p:cNvPr id="7" name="TextBox 6"/>
+          <p:cNvPr id="8" name="TextBox 7"/>
           <p:cNvSpPr txBox="1"/>
           <p:nvPr/>
         </p:nvSpPr>
@@ -3501,13 +3557,13 @@
           <a:p>
             <a:pPr algn="ctr"/>
             <a:r>
-              <a:rPr sz="2600">
-                <a:solidFill>
-                  <a:srgbClr val="8A8F98"/>
-                </a:solidFill>
-                <a:latin typeface="Pretendard Light"/>
-                <a:ea typeface="Pretendard Light"/>
-                <a:cs typeface="Pretendard Light"/>
+              <a:rPr sz="2800">
+                <a:solidFill>
+                  <a:srgbClr val="5E6AD2"/>
+                </a:solidFill>
+                <a:latin typeface="Pretendard Black"/>
+                <a:ea typeface="Pretendard Black"/>
+                <a:cs typeface="Pretendard Black"/>
               </a:rPr>
               <a:t>↑</a:t>
             </a:r>
@@ -3516,7 +3572,7 @@
       </p:sp>
       <p:sp>
         <p:nvSpPr>
-          <p:cNvPr id="8" name="Rounded Rectangle 7"/>
+          <p:cNvPr id="9" name="Rounded Rectangle 8"/>
           <p:cNvSpPr/>
           <p:nvPr/>
         </p:nvSpPr>
@@ -3585,7 +3641,7 @@
       </p:sp>
       <p:sp>
         <p:nvSpPr>
-          <p:cNvPr id="9" name="TextBox 8"/>
+          <p:cNvPr id="10" name="TextBox 9"/>
           <p:cNvSpPr txBox="1"/>
           <p:nvPr/>
         </p:nvSpPr>
@@ -3607,13 +3663,13 @@
           <a:p>
             <a:pPr algn="ctr"/>
             <a:r>
-              <a:rPr sz="2600">
-                <a:solidFill>
-                  <a:srgbClr val="8A8F98"/>
-                </a:solidFill>
-                <a:latin typeface="Pretendard Light"/>
-                <a:ea typeface="Pretendard Light"/>
-                <a:cs typeface="Pretendard Light"/>
+              <a:rPr sz="2800">
+                <a:solidFill>
+                  <a:srgbClr val="5E6AD2"/>
+                </a:solidFill>
+                <a:latin typeface="Pretendard Black"/>
+                <a:ea typeface="Pretendard Black"/>
+                <a:cs typeface="Pretendard Black"/>
               </a:rPr>
               <a:t>↑</a:t>
             </a:r>
@@ -3683,44 +3739,100 @@
       </p:sp>
       <p:sp>
         <p:nvSpPr>
-          <p:cNvPr id="3" name="TextBox 2"/>
-          <p:cNvSpPr txBox="1"/>
-          <p:nvPr/>
-        </p:nvSpPr>
-        <p:spPr>
-          <a:xfrm>
-            <a:off x="365760" y="274320"/>
-            <a:ext cx="914400" cy="274320"/>
-          </a:xfrm>
-          <a:prstGeom prst="rect">
-            <a:avLst/>
-          </a:prstGeom>
-          <a:noFill/>
-        </p:spPr>
-        <p:txBody>
-          <a:bodyPr wrap="none">
-            <a:spAutoFit/>
-          </a:bodyPr>
-          <a:lstStyle/>
-          <a:p>
-            <a:pPr algn="l"/>
-            <a:r>
-              <a:rPr sz="1100" spc="33">
-                <a:solidFill>
-                  <a:srgbClr val="62666D"/>
+          <p:cNvPr id="3" name="Rounded Rectangle 2"/>
+          <p:cNvSpPr/>
+          <p:nvPr/>
+        </p:nvSpPr>
+        <p:spPr>
+          <a:xfrm>
+            <a:off x="365760" y="320040"/>
+            <a:ext cx="777240" cy="292608"/>
+          </a:xfrm>
+          <a:prstGeom prst="roundRect">
+            <a:avLst>
+              <a:gd name="adj" fmla="val 50000"/>
+            </a:avLst>
+          </a:prstGeom>
+          <a:solidFill>
+            <a:srgbClr val="0F1011"/>
+          </a:solidFill>
+          <a:ln w="9525">
+            <a:solidFill>
+              <a:srgbClr val="23252A"/>
+            </a:solidFill>
+          </a:ln>
+        </p:spPr>
+        <p:style>
+          <a:lnRef idx="1">
+            <a:schemeClr val="accent1"/>
+          </a:lnRef>
+          <a:fillRef idx="3">
+            <a:schemeClr val="accent1"/>
+          </a:fillRef>
+          <a:effectRef idx="2">
+            <a:schemeClr val="accent1"/>
+          </a:effectRef>
+          <a:fontRef idx="minor">
+            <a:schemeClr val="lt1"/>
+          </a:fontRef>
+        </p:style>
+        <p:txBody>
+          <a:bodyPr rtlCol="0" anchor="ctr" lIns="73152" rIns="73152" tIns="0" bIns="0"/>
+          <a:lstStyle/>
+          <a:p>
+            <a:pPr algn="ctr"/>
+            <a:r>
+              <a:rPr sz="1000" spc="40">
+                <a:solidFill>
+                  <a:srgbClr val="8A8F98"/>
                 </a:solidFill>
                 <a:latin typeface="SF Mono"/>
                 <a:ea typeface="SF Mono"/>
                 <a:cs typeface="SF Mono"/>
               </a:rPr>
-              <a:t>11/13</a:t>
-            </a:r>
-          </a:p>
-        </p:txBody>
-      </p:sp>
+              <a:t>11 / 13</a:t>
+            </a:r>
+          </a:p>
+        </p:txBody>
+      </p:sp>
+      <p:cxnSp>
+        <p:nvCxnSpPr>
+          <p:cNvPr id="4" name="Connector 3"/>
+          <p:cNvCxnSpPr/>
+          <p:nvPr/>
+        </p:nvCxnSpPr>
+        <p:spPr>
+          <a:xfrm>
+            <a:off x="365760" y="6263640"/>
+            <a:ext cx="11460175" cy="0"/>
+          </a:xfrm>
+          <a:prstGeom prst="line">
+            <a:avLst/>
+          </a:prstGeom>
+          <a:ln w="6350">
+            <a:solidFill>
+              <a:srgbClr val="23252A"/>
+            </a:solidFill>
+          </a:ln>
+        </p:spPr>
+        <p:style>
+          <a:lnRef idx="2">
+            <a:schemeClr val="accent1"/>
+          </a:lnRef>
+          <a:fillRef idx="0">
+            <a:schemeClr val="accent1"/>
+          </a:fillRef>
+          <a:effectRef idx="1">
+            <a:schemeClr val="accent1"/>
+          </a:effectRef>
+          <a:fontRef idx="minor">
+            <a:schemeClr val="tx1"/>
+          </a:fontRef>
+        </p:style>
+      </p:cxnSp>
       <p:pic>
         <p:nvPicPr>
-          <p:cNvPr id="4" name="Picture 3" descr="ssod-logo-white.png"/>
+          <p:cNvPr id="5" name="Picture 4" descr="ssod-logo-lavender.png"/>
           <p:cNvPicPr>
             <a:picLocks noChangeAspect="1"/>
           </p:cNvPicPr>
@@ -3734,8 +3846,8 @@
         </p:blipFill>
         <p:spPr>
           <a:xfrm>
-            <a:off x="11132944" y="6181344"/>
-            <a:ext cx="647271" cy="384048"/>
+            <a:off x="11040476" y="6163056"/>
+            <a:ext cx="739739" cy="438912"/>
           </a:xfrm>
           <a:prstGeom prst="rect">
             <a:avLst/>
@@ -3744,7 +3856,7 @@
       </p:pic>
       <p:sp>
         <p:nvSpPr>
-          <p:cNvPr id="5" name="TextBox 4"/>
+          <p:cNvPr id="6" name="TextBox 5"/>
           <p:cNvSpPr txBox="1"/>
           <p:nvPr/>
         </p:nvSpPr>
@@ -3781,7 +3893,7 @@
       </p:sp>
       <p:sp>
         <p:nvSpPr>
-          <p:cNvPr id="6" name="TextBox 5"/>
+          <p:cNvPr id="7" name="TextBox 6"/>
           <p:cNvSpPr txBox="1"/>
           <p:nvPr/>
         </p:nvSpPr>
@@ -4054,7 +4166,7 @@
       </p:sp>
       <p:pic>
         <p:nvPicPr>
-          <p:cNvPr id="3" name="Picture 2" descr="ssod-logo-white.png"/>
+          <p:cNvPr id="3" name="Picture 2" descr="ssod-logo-lavender.png"/>
           <p:cNvPicPr>
             <a:picLocks noChangeAspect="1"/>
           </p:cNvPicPr>
@@ -4068,8 +4180,8 @@
         </p:blipFill>
         <p:spPr>
           <a:xfrm>
-            <a:off x="10764101" y="5806440"/>
-            <a:ext cx="924674" cy="548640"/>
+            <a:off x="10532933" y="5669280"/>
+            <a:ext cx="1155842" cy="685800"/>
           </a:xfrm>
           <a:prstGeom prst="rect">
             <a:avLst/>
@@ -4176,44 +4288,100 @@
       </p:sp>
       <p:sp>
         <p:nvSpPr>
-          <p:cNvPr id="3" name="TextBox 2"/>
-          <p:cNvSpPr txBox="1"/>
-          <p:nvPr/>
-        </p:nvSpPr>
-        <p:spPr>
-          <a:xfrm>
-            <a:off x="365760" y="274320"/>
-            <a:ext cx="914400" cy="274320"/>
-          </a:xfrm>
-          <a:prstGeom prst="rect">
-            <a:avLst/>
-          </a:prstGeom>
-          <a:noFill/>
-        </p:spPr>
-        <p:txBody>
-          <a:bodyPr wrap="none">
-            <a:spAutoFit/>
-          </a:bodyPr>
-          <a:lstStyle/>
-          <a:p>
-            <a:pPr algn="l"/>
-            <a:r>
-              <a:rPr sz="1100" spc="33">
-                <a:solidFill>
-                  <a:srgbClr val="62666D"/>
+          <p:cNvPr id="3" name="Rounded Rectangle 2"/>
+          <p:cNvSpPr/>
+          <p:nvPr/>
+        </p:nvSpPr>
+        <p:spPr>
+          <a:xfrm>
+            <a:off x="365760" y="320040"/>
+            <a:ext cx="777240" cy="292608"/>
+          </a:xfrm>
+          <a:prstGeom prst="roundRect">
+            <a:avLst>
+              <a:gd name="adj" fmla="val 50000"/>
+            </a:avLst>
+          </a:prstGeom>
+          <a:solidFill>
+            <a:srgbClr val="0F1011"/>
+          </a:solidFill>
+          <a:ln w="9525">
+            <a:solidFill>
+              <a:srgbClr val="23252A"/>
+            </a:solidFill>
+          </a:ln>
+        </p:spPr>
+        <p:style>
+          <a:lnRef idx="1">
+            <a:schemeClr val="accent1"/>
+          </a:lnRef>
+          <a:fillRef idx="3">
+            <a:schemeClr val="accent1"/>
+          </a:fillRef>
+          <a:effectRef idx="2">
+            <a:schemeClr val="accent1"/>
+          </a:effectRef>
+          <a:fontRef idx="minor">
+            <a:schemeClr val="lt1"/>
+          </a:fontRef>
+        </p:style>
+        <p:txBody>
+          <a:bodyPr rtlCol="0" anchor="ctr" lIns="73152" rIns="73152" tIns="0" bIns="0"/>
+          <a:lstStyle/>
+          <a:p>
+            <a:pPr algn="ctr"/>
+            <a:r>
+              <a:rPr sz="1000" spc="40">
+                <a:solidFill>
+                  <a:srgbClr val="8A8F98"/>
                 </a:solidFill>
                 <a:latin typeface="SF Mono"/>
                 <a:ea typeface="SF Mono"/>
                 <a:cs typeface="SF Mono"/>
               </a:rPr>
-              <a:t>02/13</a:t>
-            </a:r>
-          </a:p>
-        </p:txBody>
-      </p:sp>
+              <a:t>02 / 13</a:t>
+            </a:r>
+          </a:p>
+        </p:txBody>
+      </p:sp>
+      <p:cxnSp>
+        <p:nvCxnSpPr>
+          <p:cNvPr id="4" name="Connector 3"/>
+          <p:cNvCxnSpPr/>
+          <p:nvPr/>
+        </p:nvCxnSpPr>
+        <p:spPr>
+          <a:xfrm>
+            <a:off x="365760" y="6263640"/>
+            <a:ext cx="11460175" cy="0"/>
+          </a:xfrm>
+          <a:prstGeom prst="line">
+            <a:avLst/>
+          </a:prstGeom>
+          <a:ln w="6350">
+            <a:solidFill>
+              <a:srgbClr val="23252A"/>
+            </a:solidFill>
+          </a:ln>
+        </p:spPr>
+        <p:style>
+          <a:lnRef idx="2">
+            <a:schemeClr val="accent1"/>
+          </a:lnRef>
+          <a:fillRef idx="0">
+            <a:schemeClr val="accent1"/>
+          </a:fillRef>
+          <a:effectRef idx="1">
+            <a:schemeClr val="accent1"/>
+          </a:effectRef>
+          <a:fontRef idx="minor">
+            <a:schemeClr val="tx1"/>
+          </a:fontRef>
+        </p:style>
+      </p:cxnSp>
       <p:pic>
         <p:nvPicPr>
-          <p:cNvPr id="4" name="Picture 3" descr="ssod-logo-white.png"/>
+          <p:cNvPr id="5" name="Picture 4" descr="ssod-logo-lavender.png"/>
           <p:cNvPicPr>
             <a:picLocks noChangeAspect="1"/>
           </p:cNvPicPr>
@@ -4227,8 +4395,8 @@
         </p:blipFill>
         <p:spPr>
           <a:xfrm>
-            <a:off x="11132944" y="6181344"/>
-            <a:ext cx="647271" cy="384048"/>
+            <a:off x="11040476" y="6163056"/>
+            <a:ext cx="739739" cy="438912"/>
           </a:xfrm>
           <a:prstGeom prst="rect">
             <a:avLst/>
@@ -4237,7 +4405,7 @@
       </p:pic>
       <p:sp>
         <p:nvSpPr>
-          <p:cNvPr id="5" name="TextBox 4"/>
+          <p:cNvPr id="6" name="TextBox 5"/>
           <p:cNvSpPr txBox="1"/>
           <p:nvPr/>
         </p:nvSpPr>
@@ -4274,7 +4442,7 @@
       </p:sp>
       <p:sp>
         <p:nvSpPr>
-          <p:cNvPr id="6" name="TextBox 5"/>
+          <p:cNvPr id="7" name="TextBox 6"/>
           <p:cNvSpPr txBox="1"/>
           <p:nvPr/>
         </p:nvSpPr>
@@ -4394,44 +4562,100 @@
       </p:sp>
       <p:sp>
         <p:nvSpPr>
-          <p:cNvPr id="3" name="TextBox 2"/>
-          <p:cNvSpPr txBox="1"/>
-          <p:nvPr/>
-        </p:nvSpPr>
-        <p:spPr>
-          <a:xfrm>
-            <a:off x="365760" y="274320"/>
-            <a:ext cx="914400" cy="274320"/>
-          </a:xfrm>
-          <a:prstGeom prst="rect">
-            <a:avLst/>
-          </a:prstGeom>
-          <a:noFill/>
-        </p:spPr>
-        <p:txBody>
-          <a:bodyPr wrap="none">
-            <a:spAutoFit/>
-          </a:bodyPr>
-          <a:lstStyle/>
-          <a:p>
-            <a:pPr algn="l"/>
-            <a:r>
-              <a:rPr sz="1100" spc="33">
-                <a:solidFill>
-                  <a:srgbClr val="62666D"/>
+          <p:cNvPr id="3" name="Rounded Rectangle 2"/>
+          <p:cNvSpPr/>
+          <p:nvPr/>
+        </p:nvSpPr>
+        <p:spPr>
+          <a:xfrm>
+            <a:off x="365760" y="320040"/>
+            <a:ext cx="777240" cy="292608"/>
+          </a:xfrm>
+          <a:prstGeom prst="roundRect">
+            <a:avLst>
+              <a:gd name="adj" fmla="val 50000"/>
+            </a:avLst>
+          </a:prstGeom>
+          <a:solidFill>
+            <a:srgbClr val="0F1011"/>
+          </a:solidFill>
+          <a:ln w="9525">
+            <a:solidFill>
+              <a:srgbClr val="23252A"/>
+            </a:solidFill>
+          </a:ln>
+        </p:spPr>
+        <p:style>
+          <a:lnRef idx="1">
+            <a:schemeClr val="accent1"/>
+          </a:lnRef>
+          <a:fillRef idx="3">
+            <a:schemeClr val="accent1"/>
+          </a:fillRef>
+          <a:effectRef idx="2">
+            <a:schemeClr val="accent1"/>
+          </a:effectRef>
+          <a:fontRef idx="minor">
+            <a:schemeClr val="lt1"/>
+          </a:fontRef>
+        </p:style>
+        <p:txBody>
+          <a:bodyPr rtlCol="0" anchor="ctr" lIns="73152" rIns="73152" tIns="0" bIns="0"/>
+          <a:lstStyle/>
+          <a:p>
+            <a:pPr algn="ctr"/>
+            <a:r>
+              <a:rPr sz="1000" spc="40">
+                <a:solidFill>
+                  <a:srgbClr val="8A8F98"/>
                 </a:solidFill>
                 <a:latin typeface="SF Mono"/>
                 <a:ea typeface="SF Mono"/>
                 <a:cs typeface="SF Mono"/>
               </a:rPr>
-              <a:t>03/13</a:t>
-            </a:r>
-          </a:p>
-        </p:txBody>
-      </p:sp>
+              <a:t>03 / 13</a:t>
+            </a:r>
+          </a:p>
+        </p:txBody>
+      </p:sp>
+      <p:cxnSp>
+        <p:nvCxnSpPr>
+          <p:cNvPr id="4" name="Connector 3"/>
+          <p:cNvCxnSpPr/>
+          <p:nvPr/>
+        </p:nvCxnSpPr>
+        <p:spPr>
+          <a:xfrm>
+            <a:off x="365760" y="6263640"/>
+            <a:ext cx="11460175" cy="0"/>
+          </a:xfrm>
+          <a:prstGeom prst="line">
+            <a:avLst/>
+          </a:prstGeom>
+          <a:ln w="6350">
+            <a:solidFill>
+              <a:srgbClr val="23252A"/>
+            </a:solidFill>
+          </a:ln>
+        </p:spPr>
+        <p:style>
+          <a:lnRef idx="2">
+            <a:schemeClr val="accent1"/>
+          </a:lnRef>
+          <a:fillRef idx="0">
+            <a:schemeClr val="accent1"/>
+          </a:fillRef>
+          <a:effectRef idx="1">
+            <a:schemeClr val="accent1"/>
+          </a:effectRef>
+          <a:fontRef idx="minor">
+            <a:schemeClr val="tx1"/>
+          </a:fontRef>
+        </p:style>
+      </p:cxnSp>
       <p:pic>
         <p:nvPicPr>
-          <p:cNvPr id="4" name="Picture 3" descr="ssod-logo-white.png"/>
+          <p:cNvPr id="5" name="Picture 4" descr="ssod-logo-lavender.png"/>
           <p:cNvPicPr>
             <a:picLocks noChangeAspect="1"/>
           </p:cNvPicPr>
@@ -4445,8 +4669,8 @@
         </p:blipFill>
         <p:spPr>
           <a:xfrm>
-            <a:off x="11132944" y="6181344"/>
-            <a:ext cx="647271" cy="384048"/>
+            <a:off x="11040476" y="6163056"/>
+            <a:ext cx="739739" cy="438912"/>
           </a:xfrm>
           <a:prstGeom prst="rect">
             <a:avLst/>
@@ -4455,7 +4679,7 @@
       </p:pic>
       <p:sp>
         <p:nvSpPr>
-          <p:cNvPr id="5" name="TextBox 4"/>
+          <p:cNvPr id="6" name="TextBox 5"/>
           <p:cNvSpPr txBox="1"/>
           <p:nvPr/>
         </p:nvSpPr>
@@ -4492,7 +4716,7 @@
       </p:sp>
       <p:sp>
         <p:nvSpPr>
-          <p:cNvPr id="6" name="TextBox 5"/>
+          <p:cNvPr id="7" name="TextBox 6"/>
           <p:cNvSpPr txBox="1"/>
           <p:nvPr/>
         </p:nvSpPr>
@@ -4590,44 +4814,100 @@
       </p:sp>
       <p:sp>
         <p:nvSpPr>
-          <p:cNvPr id="3" name="TextBox 2"/>
-          <p:cNvSpPr txBox="1"/>
-          <p:nvPr/>
-        </p:nvSpPr>
-        <p:spPr>
-          <a:xfrm>
-            <a:off x="365760" y="274320"/>
-            <a:ext cx="914400" cy="274320"/>
-          </a:xfrm>
-          <a:prstGeom prst="rect">
-            <a:avLst/>
-          </a:prstGeom>
-          <a:noFill/>
-        </p:spPr>
-        <p:txBody>
-          <a:bodyPr wrap="none">
-            <a:spAutoFit/>
-          </a:bodyPr>
-          <a:lstStyle/>
-          <a:p>
-            <a:pPr algn="l"/>
-            <a:r>
-              <a:rPr sz="1100" spc="33">
-                <a:solidFill>
-                  <a:srgbClr val="62666D"/>
+          <p:cNvPr id="3" name="Rounded Rectangle 2"/>
+          <p:cNvSpPr/>
+          <p:nvPr/>
+        </p:nvSpPr>
+        <p:spPr>
+          <a:xfrm>
+            <a:off x="365760" y="320040"/>
+            <a:ext cx="777240" cy="292608"/>
+          </a:xfrm>
+          <a:prstGeom prst="roundRect">
+            <a:avLst>
+              <a:gd name="adj" fmla="val 50000"/>
+            </a:avLst>
+          </a:prstGeom>
+          <a:solidFill>
+            <a:srgbClr val="0F1011"/>
+          </a:solidFill>
+          <a:ln w="9525">
+            <a:solidFill>
+              <a:srgbClr val="23252A"/>
+            </a:solidFill>
+          </a:ln>
+        </p:spPr>
+        <p:style>
+          <a:lnRef idx="1">
+            <a:schemeClr val="accent1"/>
+          </a:lnRef>
+          <a:fillRef idx="3">
+            <a:schemeClr val="accent1"/>
+          </a:fillRef>
+          <a:effectRef idx="2">
+            <a:schemeClr val="accent1"/>
+          </a:effectRef>
+          <a:fontRef idx="minor">
+            <a:schemeClr val="lt1"/>
+          </a:fontRef>
+        </p:style>
+        <p:txBody>
+          <a:bodyPr rtlCol="0" anchor="ctr" lIns="73152" rIns="73152" tIns="0" bIns="0"/>
+          <a:lstStyle/>
+          <a:p>
+            <a:pPr algn="ctr"/>
+            <a:r>
+              <a:rPr sz="1000" spc="40">
+                <a:solidFill>
+                  <a:srgbClr val="8A8F98"/>
                 </a:solidFill>
                 <a:latin typeface="SF Mono"/>
                 <a:ea typeface="SF Mono"/>
                 <a:cs typeface="SF Mono"/>
               </a:rPr>
-              <a:t>04/13</a:t>
-            </a:r>
-          </a:p>
-        </p:txBody>
-      </p:sp>
+              <a:t>04 / 13</a:t>
+            </a:r>
+          </a:p>
+        </p:txBody>
+      </p:sp>
+      <p:cxnSp>
+        <p:nvCxnSpPr>
+          <p:cNvPr id="4" name="Connector 3"/>
+          <p:cNvCxnSpPr/>
+          <p:nvPr/>
+        </p:nvCxnSpPr>
+        <p:spPr>
+          <a:xfrm>
+            <a:off x="365760" y="6263640"/>
+            <a:ext cx="11460175" cy="0"/>
+          </a:xfrm>
+          <a:prstGeom prst="line">
+            <a:avLst/>
+          </a:prstGeom>
+          <a:ln w="6350">
+            <a:solidFill>
+              <a:srgbClr val="23252A"/>
+            </a:solidFill>
+          </a:ln>
+        </p:spPr>
+        <p:style>
+          <a:lnRef idx="2">
+            <a:schemeClr val="accent1"/>
+          </a:lnRef>
+          <a:fillRef idx="0">
+            <a:schemeClr val="accent1"/>
+          </a:fillRef>
+          <a:effectRef idx="1">
+            <a:schemeClr val="accent1"/>
+          </a:effectRef>
+          <a:fontRef idx="minor">
+            <a:schemeClr val="tx1"/>
+          </a:fontRef>
+        </p:style>
+      </p:cxnSp>
       <p:pic>
         <p:nvPicPr>
-          <p:cNvPr id="4" name="Picture 3" descr="ssod-logo-white.png"/>
+          <p:cNvPr id="5" name="Picture 4" descr="ssod-logo-lavender.png"/>
           <p:cNvPicPr>
             <a:picLocks noChangeAspect="1"/>
           </p:cNvPicPr>
@@ -4641,8 +4921,8 @@
         </p:blipFill>
         <p:spPr>
           <a:xfrm>
-            <a:off x="11132944" y="6181344"/>
-            <a:ext cx="647271" cy="384048"/>
+            <a:off x="11040476" y="6163056"/>
+            <a:ext cx="739739" cy="438912"/>
           </a:xfrm>
           <a:prstGeom prst="rect">
             <a:avLst/>
@@ -4651,7 +4931,7 @@
       </p:pic>
       <p:sp>
         <p:nvSpPr>
-          <p:cNvPr id="5" name="TextBox 4"/>
+          <p:cNvPr id="6" name="TextBox 5"/>
           <p:cNvSpPr txBox="1"/>
           <p:nvPr/>
         </p:nvSpPr>
@@ -4688,7 +4968,7 @@
       </p:sp>
       <p:pic>
         <p:nvPicPr>
-          <p:cNvPr id="6" name="Picture 5" descr="notion-ambassador-badge.png"/>
+          <p:cNvPr id="7" name="Picture 6" descr="notion-ambassador-badge.png"/>
           <p:cNvPicPr>
             <a:picLocks noChangeAspect="1"/>
           </p:cNvPicPr>
@@ -4712,7 +4992,7 @@
       </p:pic>
       <p:pic>
         <p:nvPicPr>
-          <p:cNvPr id="7" name="Picture 6" descr="n8n-amber-ssod-black.png"/>
+          <p:cNvPr id="8" name="Picture 7" descr="n8n-amber-ssod-black.png"/>
           <p:cNvPicPr>
             <a:picLocks noChangeAspect="1"/>
           </p:cNvPicPr>
@@ -4736,7 +5016,7 @@
       </p:pic>
       <p:sp>
         <p:nvSpPr>
-          <p:cNvPr id="8" name="TextBox 7"/>
+          <p:cNvPr id="9" name="TextBox 8"/>
           <p:cNvSpPr txBox="1"/>
           <p:nvPr/>
         </p:nvSpPr>
@@ -4834,44 +5114,100 @@
       </p:sp>
       <p:sp>
         <p:nvSpPr>
-          <p:cNvPr id="3" name="TextBox 2"/>
-          <p:cNvSpPr txBox="1"/>
-          <p:nvPr/>
-        </p:nvSpPr>
-        <p:spPr>
-          <a:xfrm>
-            <a:off x="365760" y="274320"/>
-            <a:ext cx="914400" cy="274320"/>
-          </a:xfrm>
-          <a:prstGeom prst="rect">
-            <a:avLst/>
-          </a:prstGeom>
-          <a:noFill/>
-        </p:spPr>
-        <p:txBody>
-          <a:bodyPr wrap="none">
-            <a:spAutoFit/>
-          </a:bodyPr>
-          <a:lstStyle/>
-          <a:p>
-            <a:pPr algn="l"/>
-            <a:r>
-              <a:rPr sz="1100" spc="33">
-                <a:solidFill>
-                  <a:srgbClr val="62666D"/>
+          <p:cNvPr id="3" name="Rounded Rectangle 2"/>
+          <p:cNvSpPr/>
+          <p:nvPr/>
+        </p:nvSpPr>
+        <p:spPr>
+          <a:xfrm>
+            <a:off x="365760" y="320040"/>
+            <a:ext cx="777240" cy="292608"/>
+          </a:xfrm>
+          <a:prstGeom prst="roundRect">
+            <a:avLst>
+              <a:gd name="adj" fmla="val 50000"/>
+            </a:avLst>
+          </a:prstGeom>
+          <a:solidFill>
+            <a:srgbClr val="0F1011"/>
+          </a:solidFill>
+          <a:ln w="9525">
+            <a:solidFill>
+              <a:srgbClr val="23252A"/>
+            </a:solidFill>
+          </a:ln>
+        </p:spPr>
+        <p:style>
+          <a:lnRef idx="1">
+            <a:schemeClr val="accent1"/>
+          </a:lnRef>
+          <a:fillRef idx="3">
+            <a:schemeClr val="accent1"/>
+          </a:fillRef>
+          <a:effectRef idx="2">
+            <a:schemeClr val="accent1"/>
+          </a:effectRef>
+          <a:fontRef idx="minor">
+            <a:schemeClr val="lt1"/>
+          </a:fontRef>
+        </p:style>
+        <p:txBody>
+          <a:bodyPr rtlCol="0" anchor="ctr" lIns="73152" rIns="73152" tIns="0" bIns="0"/>
+          <a:lstStyle/>
+          <a:p>
+            <a:pPr algn="ctr"/>
+            <a:r>
+              <a:rPr sz="1000" spc="40">
+                <a:solidFill>
+                  <a:srgbClr val="8A8F98"/>
                 </a:solidFill>
                 <a:latin typeface="SF Mono"/>
                 <a:ea typeface="SF Mono"/>
                 <a:cs typeface="SF Mono"/>
               </a:rPr>
-              <a:t>05/13</a:t>
-            </a:r>
-          </a:p>
-        </p:txBody>
-      </p:sp>
+              <a:t>05 / 13</a:t>
+            </a:r>
+          </a:p>
+        </p:txBody>
+      </p:sp>
+      <p:cxnSp>
+        <p:nvCxnSpPr>
+          <p:cNvPr id="4" name="Connector 3"/>
+          <p:cNvCxnSpPr/>
+          <p:nvPr/>
+        </p:nvCxnSpPr>
+        <p:spPr>
+          <a:xfrm>
+            <a:off x="365760" y="6263640"/>
+            <a:ext cx="11460175" cy="0"/>
+          </a:xfrm>
+          <a:prstGeom prst="line">
+            <a:avLst/>
+          </a:prstGeom>
+          <a:ln w="6350">
+            <a:solidFill>
+              <a:srgbClr val="23252A"/>
+            </a:solidFill>
+          </a:ln>
+        </p:spPr>
+        <p:style>
+          <a:lnRef idx="2">
+            <a:schemeClr val="accent1"/>
+          </a:lnRef>
+          <a:fillRef idx="0">
+            <a:schemeClr val="accent1"/>
+          </a:fillRef>
+          <a:effectRef idx="1">
+            <a:schemeClr val="accent1"/>
+          </a:effectRef>
+          <a:fontRef idx="minor">
+            <a:schemeClr val="tx1"/>
+          </a:fontRef>
+        </p:style>
+      </p:cxnSp>
       <p:pic>
         <p:nvPicPr>
-          <p:cNvPr id="4" name="Picture 3" descr="ssod-logo-white.png"/>
+          <p:cNvPr id="5" name="Picture 4" descr="ssod-logo-lavender.png"/>
           <p:cNvPicPr>
             <a:picLocks noChangeAspect="1"/>
           </p:cNvPicPr>
@@ -4885,8 +5221,8 @@
         </p:blipFill>
         <p:spPr>
           <a:xfrm>
-            <a:off x="11132944" y="6181344"/>
-            <a:ext cx="647271" cy="384048"/>
+            <a:off x="11040476" y="6163056"/>
+            <a:ext cx="739739" cy="438912"/>
           </a:xfrm>
           <a:prstGeom prst="rect">
             <a:avLst/>
@@ -4895,7 +5231,7 @@
       </p:pic>
       <p:sp>
         <p:nvSpPr>
-          <p:cNvPr id="5" name="TextBox 4"/>
+          <p:cNvPr id="6" name="TextBox 5"/>
           <p:cNvSpPr txBox="1"/>
           <p:nvPr/>
         </p:nvSpPr>
@@ -4954,7 +5290,7 @@
       </p:sp>
       <p:sp>
         <p:nvSpPr>
-          <p:cNvPr id="6" name="TextBox 5"/>
+          <p:cNvPr id="7" name="TextBox 6"/>
           <p:cNvSpPr txBox="1"/>
           <p:nvPr/>
         </p:nvSpPr>
@@ -5052,44 +5388,100 @@
       </p:sp>
       <p:sp>
         <p:nvSpPr>
-          <p:cNvPr id="3" name="TextBox 2"/>
-          <p:cNvSpPr txBox="1"/>
-          <p:nvPr/>
-        </p:nvSpPr>
-        <p:spPr>
-          <a:xfrm>
-            <a:off x="365760" y="274320"/>
-            <a:ext cx="914400" cy="274320"/>
-          </a:xfrm>
-          <a:prstGeom prst="rect">
-            <a:avLst/>
-          </a:prstGeom>
-          <a:noFill/>
-        </p:spPr>
-        <p:txBody>
-          <a:bodyPr wrap="none">
-            <a:spAutoFit/>
-          </a:bodyPr>
-          <a:lstStyle/>
-          <a:p>
-            <a:pPr algn="l"/>
-            <a:r>
-              <a:rPr sz="1100" spc="33">
-                <a:solidFill>
-                  <a:srgbClr val="62666D"/>
+          <p:cNvPr id="3" name="Rounded Rectangle 2"/>
+          <p:cNvSpPr/>
+          <p:nvPr/>
+        </p:nvSpPr>
+        <p:spPr>
+          <a:xfrm>
+            <a:off x="365760" y="320040"/>
+            <a:ext cx="777240" cy="292608"/>
+          </a:xfrm>
+          <a:prstGeom prst="roundRect">
+            <a:avLst>
+              <a:gd name="adj" fmla="val 50000"/>
+            </a:avLst>
+          </a:prstGeom>
+          <a:solidFill>
+            <a:srgbClr val="0F1011"/>
+          </a:solidFill>
+          <a:ln w="9525">
+            <a:solidFill>
+              <a:srgbClr val="23252A"/>
+            </a:solidFill>
+          </a:ln>
+        </p:spPr>
+        <p:style>
+          <a:lnRef idx="1">
+            <a:schemeClr val="accent1"/>
+          </a:lnRef>
+          <a:fillRef idx="3">
+            <a:schemeClr val="accent1"/>
+          </a:fillRef>
+          <a:effectRef idx="2">
+            <a:schemeClr val="accent1"/>
+          </a:effectRef>
+          <a:fontRef idx="minor">
+            <a:schemeClr val="lt1"/>
+          </a:fontRef>
+        </p:style>
+        <p:txBody>
+          <a:bodyPr rtlCol="0" anchor="ctr" lIns="73152" rIns="73152" tIns="0" bIns="0"/>
+          <a:lstStyle/>
+          <a:p>
+            <a:pPr algn="ctr"/>
+            <a:r>
+              <a:rPr sz="1000" spc="40">
+                <a:solidFill>
+                  <a:srgbClr val="8A8F98"/>
                 </a:solidFill>
                 <a:latin typeface="SF Mono"/>
                 <a:ea typeface="SF Mono"/>
                 <a:cs typeface="SF Mono"/>
               </a:rPr>
-              <a:t>06/13</a:t>
-            </a:r>
-          </a:p>
-        </p:txBody>
-      </p:sp>
+              <a:t>06 / 13</a:t>
+            </a:r>
+          </a:p>
+        </p:txBody>
+      </p:sp>
+      <p:cxnSp>
+        <p:nvCxnSpPr>
+          <p:cNvPr id="4" name="Connector 3"/>
+          <p:cNvCxnSpPr/>
+          <p:nvPr/>
+        </p:nvCxnSpPr>
+        <p:spPr>
+          <a:xfrm>
+            <a:off x="365760" y="6263640"/>
+            <a:ext cx="11460175" cy="0"/>
+          </a:xfrm>
+          <a:prstGeom prst="line">
+            <a:avLst/>
+          </a:prstGeom>
+          <a:ln w="6350">
+            <a:solidFill>
+              <a:srgbClr val="23252A"/>
+            </a:solidFill>
+          </a:ln>
+        </p:spPr>
+        <p:style>
+          <a:lnRef idx="2">
+            <a:schemeClr val="accent1"/>
+          </a:lnRef>
+          <a:fillRef idx="0">
+            <a:schemeClr val="accent1"/>
+          </a:fillRef>
+          <a:effectRef idx="1">
+            <a:schemeClr val="accent1"/>
+          </a:effectRef>
+          <a:fontRef idx="minor">
+            <a:schemeClr val="tx1"/>
+          </a:fontRef>
+        </p:style>
+      </p:cxnSp>
       <p:pic>
         <p:nvPicPr>
-          <p:cNvPr id="4" name="Picture 3" descr="ssod-logo-white.png"/>
+          <p:cNvPr id="5" name="Picture 4" descr="ssod-logo-lavender.png"/>
           <p:cNvPicPr>
             <a:picLocks noChangeAspect="1"/>
           </p:cNvPicPr>
@@ -5103,8 +5495,8 @@
         </p:blipFill>
         <p:spPr>
           <a:xfrm>
-            <a:off x="11132944" y="6181344"/>
-            <a:ext cx="647271" cy="384048"/>
+            <a:off x="11040476" y="6163056"/>
+            <a:ext cx="739739" cy="438912"/>
           </a:xfrm>
           <a:prstGeom prst="rect">
             <a:avLst/>
@@ -5113,7 +5505,7 @@
       </p:pic>
       <p:sp>
         <p:nvSpPr>
-          <p:cNvPr id="5" name="TextBox 4"/>
+          <p:cNvPr id="6" name="TextBox 5"/>
           <p:cNvSpPr txBox="1"/>
           <p:nvPr/>
         </p:nvSpPr>
@@ -5150,7 +5542,7 @@
       </p:sp>
       <p:sp>
         <p:nvSpPr>
-          <p:cNvPr id="6" name="TextBox 5"/>
+          <p:cNvPr id="7" name="TextBox 6"/>
           <p:cNvSpPr txBox="1"/>
           <p:nvPr/>
         </p:nvSpPr>
@@ -5248,44 +5640,100 @@
       </p:sp>
       <p:sp>
         <p:nvSpPr>
-          <p:cNvPr id="3" name="TextBox 2"/>
-          <p:cNvSpPr txBox="1"/>
-          <p:nvPr/>
-        </p:nvSpPr>
-        <p:spPr>
-          <a:xfrm>
-            <a:off x="365760" y="274320"/>
-            <a:ext cx="914400" cy="274320"/>
-          </a:xfrm>
-          <a:prstGeom prst="rect">
-            <a:avLst/>
-          </a:prstGeom>
-          <a:noFill/>
-        </p:spPr>
-        <p:txBody>
-          <a:bodyPr wrap="none">
-            <a:spAutoFit/>
-          </a:bodyPr>
-          <a:lstStyle/>
-          <a:p>
-            <a:pPr algn="l"/>
-            <a:r>
-              <a:rPr sz="1100" spc="33">
-                <a:solidFill>
-                  <a:srgbClr val="62666D"/>
+          <p:cNvPr id="3" name="Rounded Rectangle 2"/>
+          <p:cNvSpPr/>
+          <p:nvPr/>
+        </p:nvSpPr>
+        <p:spPr>
+          <a:xfrm>
+            <a:off x="365760" y="320040"/>
+            <a:ext cx="777240" cy="292608"/>
+          </a:xfrm>
+          <a:prstGeom prst="roundRect">
+            <a:avLst>
+              <a:gd name="adj" fmla="val 50000"/>
+            </a:avLst>
+          </a:prstGeom>
+          <a:solidFill>
+            <a:srgbClr val="0F1011"/>
+          </a:solidFill>
+          <a:ln w="9525">
+            <a:solidFill>
+              <a:srgbClr val="23252A"/>
+            </a:solidFill>
+          </a:ln>
+        </p:spPr>
+        <p:style>
+          <a:lnRef idx="1">
+            <a:schemeClr val="accent1"/>
+          </a:lnRef>
+          <a:fillRef idx="3">
+            <a:schemeClr val="accent1"/>
+          </a:fillRef>
+          <a:effectRef idx="2">
+            <a:schemeClr val="accent1"/>
+          </a:effectRef>
+          <a:fontRef idx="minor">
+            <a:schemeClr val="lt1"/>
+          </a:fontRef>
+        </p:style>
+        <p:txBody>
+          <a:bodyPr rtlCol="0" anchor="ctr" lIns="73152" rIns="73152" tIns="0" bIns="0"/>
+          <a:lstStyle/>
+          <a:p>
+            <a:pPr algn="ctr"/>
+            <a:r>
+              <a:rPr sz="1000" spc="40">
+                <a:solidFill>
+                  <a:srgbClr val="8A8F98"/>
                 </a:solidFill>
                 <a:latin typeface="SF Mono"/>
                 <a:ea typeface="SF Mono"/>
                 <a:cs typeface="SF Mono"/>
               </a:rPr>
-              <a:t>07/13</a:t>
-            </a:r>
-          </a:p>
-        </p:txBody>
-      </p:sp>
+              <a:t>07 / 13</a:t>
+            </a:r>
+          </a:p>
+        </p:txBody>
+      </p:sp>
+      <p:cxnSp>
+        <p:nvCxnSpPr>
+          <p:cNvPr id="4" name="Connector 3"/>
+          <p:cNvCxnSpPr/>
+          <p:nvPr/>
+        </p:nvCxnSpPr>
+        <p:spPr>
+          <a:xfrm>
+            <a:off x="365760" y="6263640"/>
+            <a:ext cx="11460175" cy="0"/>
+          </a:xfrm>
+          <a:prstGeom prst="line">
+            <a:avLst/>
+          </a:prstGeom>
+          <a:ln w="6350">
+            <a:solidFill>
+              <a:srgbClr val="23252A"/>
+            </a:solidFill>
+          </a:ln>
+        </p:spPr>
+        <p:style>
+          <a:lnRef idx="2">
+            <a:schemeClr val="accent1"/>
+          </a:lnRef>
+          <a:fillRef idx="0">
+            <a:schemeClr val="accent1"/>
+          </a:fillRef>
+          <a:effectRef idx="1">
+            <a:schemeClr val="accent1"/>
+          </a:effectRef>
+          <a:fontRef idx="minor">
+            <a:schemeClr val="tx1"/>
+          </a:fontRef>
+        </p:style>
+      </p:cxnSp>
       <p:pic>
         <p:nvPicPr>
-          <p:cNvPr id="4" name="Picture 3" descr="ssod-logo-white.png"/>
+          <p:cNvPr id="5" name="Picture 4" descr="ssod-logo-lavender.png"/>
           <p:cNvPicPr>
             <a:picLocks noChangeAspect="1"/>
           </p:cNvPicPr>
@@ -5299,8 +5747,8 @@
         </p:blipFill>
         <p:spPr>
           <a:xfrm>
-            <a:off x="11132944" y="6181344"/>
-            <a:ext cx="647271" cy="384048"/>
+            <a:off x="11040476" y="6163056"/>
+            <a:ext cx="739739" cy="438912"/>
           </a:xfrm>
           <a:prstGeom prst="rect">
             <a:avLst/>
@@ -5309,7 +5757,7 @@
       </p:pic>
       <p:sp>
         <p:nvSpPr>
-          <p:cNvPr id="5" name="TextBox 4"/>
+          <p:cNvPr id="6" name="TextBox 5"/>
           <p:cNvSpPr txBox="1"/>
           <p:nvPr/>
         </p:nvSpPr>
@@ -5346,7 +5794,7 @@
       </p:sp>
       <p:sp>
         <p:nvSpPr>
-          <p:cNvPr id="6" name="TextBox 5"/>
+          <p:cNvPr id="7" name="TextBox 6"/>
           <p:cNvSpPr txBox="1"/>
           <p:nvPr/>
         </p:nvSpPr>
@@ -5383,7 +5831,7 @@
       </p:sp>
       <p:sp>
         <p:nvSpPr>
-          <p:cNvPr id="7" name="TextBox 6"/>
+          <p:cNvPr id="8" name="TextBox 7"/>
           <p:cNvSpPr txBox="1"/>
           <p:nvPr/>
         </p:nvSpPr>
@@ -5481,44 +5929,100 @@
       </p:sp>
       <p:sp>
         <p:nvSpPr>
-          <p:cNvPr id="3" name="TextBox 2"/>
-          <p:cNvSpPr txBox="1"/>
-          <p:nvPr/>
-        </p:nvSpPr>
-        <p:spPr>
-          <a:xfrm>
-            <a:off x="365760" y="274320"/>
-            <a:ext cx="914400" cy="274320"/>
-          </a:xfrm>
-          <a:prstGeom prst="rect">
-            <a:avLst/>
-          </a:prstGeom>
-          <a:noFill/>
-        </p:spPr>
-        <p:txBody>
-          <a:bodyPr wrap="none">
-            <a:spAutoFit/>
-          </a:bodyPr>
-          <a:lstStyle/>
-          <a:p>
-            <a:pPr algn="l"/>
-            <a:r>
-              <a:rPr sz="1100" spc="33">
-                <a:solidFill>
-                  <a:srgbClr val="62666D"/>
+          <p:cNvPr id="3" name="Rounded Rectangle 2"/>
+          <p:cNvSpPr/>
+          <p:nvPr/>
+        </p:nvSpPr>
+        <p:spPr>
+          <a:xfrm>
+            <a:off x="365760" y="320040"/>
+            <a:ext cx="777240" cy="292608"/>
+          </a:xfrm>
+          <a:prstGeom prst="roundRect">
+            <a:avLst>
+              <a:gd name="adj" fmla="val 50000"/>
+            </a:avLst>
+          </a:prstGeom>
+          <a:solidFill>
+            <a:srgbClr val="0F1011"/>
+          </a:solidFill>
+          <a:ln w="9525">
+            <a:solidFill>
+              <a:srgbClr val="23252A"/>
+            </a:solidFill>
+          </a:ln>
+        </p:spPr>
+        <p:style>
+          <a:lnRef idx="1">
+            <a:schemeClr val="accent1"/>
+          </a:lnRef>
+          <a:fillRef idx="3">
+            <a:schemeClr val="accent1"/>
+          </a:fillRef>
+          <a:effectRef idx="2">
+            <a:schemeClr val="accent1"/>
+          </a:effectRef>
+          <a:fontRef idx="minor">
+            <a:schemeClr val="lt1"/>
+          </a:fontRef>
+        </p:style>
+        <p:txBody>
+          <a:bodyPr rtlCol="0" anchor="ctr" lIns="73152" rIns="73152" tIns="0" bIns="0"/>
+          <a:lstStyle/>
+          <a:p>
+            <a:pPr algn="ctr"/>
+            <a:r>
+              <a:rPr sz="1000" spc="40">
+                <a:solidFill>
+                  <a:srgbClr val="8A8F98"/>
                 </a:solidFill>
                 <a:latin typeface="SF Mono"/>
                 <a:ea typeface="SF Mono"/>
                 <a:cs typeface="SF Mono"/>
               </a:rPr>
-              <a:t>08/13</a:t>
-            </a:r>
-          </a:p>
-        </p:txBody>
-      </p:sp>
+              <a:t>08 / 13</a:t>
+            </a:r>
+          </a:p>
+        </p:txBody>
+      </p:sp>
+      <p:cxnSp>
+        <p:nvCxnSpPr>
+          <p:cNvPr id="4" name="Connector 3"/>
+          <p:cNvCxnSpPr/>
+          <p:nvPr/>
+        </p:nvCxnSpPr>
+        <p:spPr>
+          <a:xfrm>
+            <a:off x="365760" y="6263640"/>
+            <a:ext cx="11460175" cy="0"/>
+          </a:xfrm>
+          <a:prstGeom prst="line">
+            <a:avLst/>
+          </a:prstGeom>
+          <a:ln w="6350">
+            <a:solidFill>
+              <a:srgbClr val="23252A"/>
+            </a:solidFill>
+          </a:ln>
+        </p:spPr>
+        <p:style>
+          <a:lnRef idx="2">
+            <a:schemeClr val="accent1"/>
+          </a:lnRef>
+          <a:fillRef idx="0">
+            <a:schemeClr val="accent1"/>
+          </a:fillRef>
+          <a:effectRef idx="1">
+            <a:schemeClr val="accent1"/>
+          </a:effectRef>
+          <a:fontRef idx="minor">
+            <a:schemeClr val="tx1"/>
+          </a:fontRef>
+        </p:style>
+      </p:cxnSp>
       <p:pic>
         <p:nvPicPr>
-          <p:cNvPr id="4" name="Picture 3" descr="ssod-logo-white.png"/>
+          <p:cNvPr id="5" name="Picture 4" descr="ssod-logo-lavender.png"/>
           <p:cNvPicPr>
             <a:picLocks noChangeAspect="1"/>
           </p:cNvPicPr>
@@ -5532,8 +6036,8 @@
         </p:blipFill>
         <p:spPr>
           <a:xfrm>
-            <a:off x="11132944" y="6181344"/>
-            <a:ext cx="647271" cy="384048"/>
+            <a:off x="11040476" y="6163056"/>
+            <a:ext cx="739739" cy="438912"/>
           </a:xfrm>
           <a:prstGeom prst="rect">
             <a:avLst/>
@@ -5542,7 +6046,7 @@
       </p:pic>
       <p:sp>
         <p:nvSpPr>
-          <p:cNvPr id="5" name="TextBox 4"/>
+          <p:cNvPr id="6" name="TextBox 5"/>
           <p:cNvSpPr txBox="1"/>
           <p:nvPr/>
         </p:nvSpPr>
@@ -5579,7 +6083,7 @@
       </p:sp>
       <p:sp>
         <p:nvSpPr>
-          <p:cNvPr id="6" name="TextBox 5"/>
+          <p:cNvPr id="7" name="TextBox 6"/>
           <p:cNvSpPr txBox="1"/>
           <p:nvPr/>
         </p:nvSpPr>
@@ -5616,7 +6120,7 @@
       </p:sp>
       <p:sp>
         <p:nvSpPr>
-          <p:cNvPr id="7" name="TextBox 6"/>
+          <p:cNvPr id="8" name="TextBox 7"/>
           <p:cNvSpPr txBox="1"/>
           <p:nvPr/>
         </p:nvSpPr>
@@ -5714,44 +6218,100 @@
       </p:sp>
       <p:sp>
         <p:nvSpPr>
-          <p:cNvPr id="3" name="TextBox 2"/>
-          <p:cNvSpPr txBox="1"/>
-          <p:nvPr/>
-        </p:nvSpPr>
-        <p:spPr>
-          <a:xfrm>
-            <a:off x="365760" y="274320"/>
-            <a:ext cx="914400" cy="274320"/>
-          </a:xfrm>
-          <a:prstGeom prst="rect">
-            <a:avLst/>
-          </a:prstGeom>
-          <a:noFill/>
-        </p:spPr>
-        <p:txBody>
-          <a:bodyPr wrap="none">
-            <a:spAutoFit/>
-          </a:bodyPr>
-          <a:lstStyle/>
-          <a:p>
-            <a:pPr algn="l"/>
-            <a:r>
-              <a:rPr sz="1100" spc="33">
-                <a:solidFill>
-                  <a:srgbClr val="62666D"/>
+          <p:cNvPr id="3" name="Rounded Rectangle 2"/>
+          <p:cNvSpPr/>
+          <p:nvPr/>
+        </p:nvSpPr>
+        <p:spPr>
+          <a:xfrm>
+            <a:off x="365760" y="320040"/>
+            <a:ext cx="777240" cy="292608"/>
+          </a:xfrm>
+          <a:prstGeom prst="roundRect">
+            <a:avLst>
+              <a:gd name="adj" fmla="val 50000"/>
+            </a:avLst>
+          </a:prstGeom>
+          <a:solidFill>
+            <a:srgbClr val="0F1011"/>
+          </a:solidFill>
+          <a:ln w="9525">
+            <a:solidFill>
+              <a:srgbClr val="23252A"/>
+            </a:solidFill>
+          </a:ln>
+        </p:spPr>
+        <p:style>
+          <a:lnRef idx="1">
+            <a:schemeClr val="accent1"/>
+          </a:lnRef>
+          <a:fillRef idx="3">
+            <a:schemeClr val="accent1"/>
+          </a:fillRef>
+          <a:effectRef idx="2">
+            <a:schemeClr val="accent1"/>
+          </a:effectRef>
+          <a:fontRef idx="minor">
+            <a:schemeClr val="lt1"/>
+          </a:fontRef>
+        </p:style>
+        <p:txBody>
+          <a:bodyPr rtlCol="0" anchor="ctr" lIns="73152" rIns="73152" tIns="0" bIns="0"/>
+          <a:lstStyle/>
+          <a:p>
+            <a:pPr algn="ctr"/>
+            <a:r>
+              <a:rPr sz="1000" spc="40">
+                <a:solidFill>
+                  <a:srgbClr val="8A8F98"/>
                 </a:solidFill>
                 <a:latin typeface="SF Mono"/>
                 <a:ea typeface="SF Mono"/>
                 <a:cs typeface="SF Mono"/>
               </a:rPr>
-              <a:t>09/13</a:t>
-            </a:r>
-          </a:p>
-        </p:txBody>
-      </p:sp>
+              <a:t>09 / 13</a:t>
+            </a:r>
+          </a:p>
+        </p:txBody>
+      </p:sp>
+      <p:cxnSp>
+        <p:nvCxnSpPr>
+          <p:cNvPr id="4" name="Connector 3"/>
+          <p:cNvCxnSpPr/>
+          <p:nvPr/>
+        </p:nvCxnSpPr>
+        <p:spPr>
+          <a:xfrm>
+            <a:off x="365760" y="6263640"/>
+            <a:ext cx="11460175" cy="0"/>
+          </a:xfrm>
+          <a:prstGeom prst="line">
+            <a:avLst/>
+          </a:prstGeom>
+          <a:ln w="6350">
+            <a:solidFill>
+              <a:srgbClr val="23252A"/>
+            </a:solidFill>
+          </a:ln>
+        </p:spPr>
+        <p:style>
+          <a:lnRef idx="2">
+            <a:schemeClr val="accent1"/>
+          </a:lnRef>
+          <a:fillRef idx="0">
+            <a:schemeClr val="accent1"/>
+          </a:fillRef>
+          <a:effectRef idx="1">
+            <a:schemeClr val="accent1"/>
+          </a:effectRef>
+          <a:fontRef idx="minor">
+            <a:schemeClr val="tx1"/>
+          </a:fontRef>
+        </p:style>
+      </p:cxnSp>
       <p:pic>
         <p:nvPicPr>
-          <p:cNvPr id="4" name="Picture 3" descr="ssod-logo-white.png"/>
+          <p:cNvPr id="5" name="Picture 4" descr="ssod-logo-lavender.png"/>
           <p:cNvPicPr>
             <a:picLocks noChangeAspect="1"/>
           </p:cNvPicPr>
@@ -5765,8 +6325,8 @@
         </p:blipFill>
         <p:spPr>
           <a:xfrm>
-            <a:off x="11132944" y="6181344"/>
-            <a:ext cx="647271" cy="384048"/>
+            <a:off x="11040476" y="6163056"/>
+            <a:ext cx="739739" cy="438912"/>
           </a:xfrm>
           <a:prstGeom prst="rect">
             <a:avLst/>
@@ -5775,7 +6335,7 @@
       </p:pic>
       <p:sp>
         <p:nvSpPr>
-          <p:cNvPr id="5" name="TextBox 4"/>
+          <p:cNvPr id="6" name="TextBox 5"/>
           <p:cNvSpPr txBox="1"/>
           <p:nvPr/>
         </p:nvSpPr>
@@ -5812,7 +6372,7 @@
       </p:sp>
       <p:sp>
         <p:nvSpPr>
-          <p:cNvPr id="6" name="TextBox 5"/>
+          <p:cNvPr id="7" name="TextBox 6"/>
           <p:cNvSpPr txBox="1"/>
           <p:nvPr/>
         </p:nvSpPr>
@@ -5849,7 +6409,7 @@
       </p:sp>
       <p:sp>
         <p:nvSpPr>
-          <p:cNvPr id="7" name="TextBox 6"/>
+          <p:cNvPr id="8" name="TextBox 7"/>
           <p:cNvSpPr txBox="1"/>
           <p:nvPr/>
         </p:nvSpPr>

</xml_diff>

<commit_message>
WIP(bni-v10): 13-slide layout pass — original wordmark + s1 cover redesign + Moore/Chen vocab
- 슬라이드 14장→13장 reflow (photo wall 폐기, s4 "둘다"→"국내 유일"·캡션 "이중 앰버서더는 국내 SSOD뿐")
- 가로형 워드마크(ssod-wordmark.png) 도입: 라벤더 단색 변종 폐기, 원본 컬러 SSOD 마크+영문 통합. footer 영역 안에 가둠
- footer brandlogy 재설계: page chip 좌상→좌하, word_wrap=False로 줄바꿈 차단, divider 6.85→6.72, 로고 height 0.40→0.62 (chip과 vertical center align)
- SoR/SoE/SoI 어휘 원전 직역 (Moore·Chen): 데이터/일/판단 → 기록/참여/지능, 부제 1줄 증첩, 예시 도구 일관성 (ERP·CRM·매출 / 카톡·노션·메일 / BI·대시보드·AI)
- s10 다이어그램·s12 자기진단도 어휘 통일
- s1 표지 재설계: "AI 시대 일하는 구조" 단일 line → eyebrow "AI 시대" + punch "준비해야하는 일의 구조" + 중앙 워드마크. 그라데이션 BG는 폐기, 검정 BG 복귀

Co-Authored-By: Claude Opus 4.7 (1M context) <noreply@anthropic.com>
</commit_message>
<xml_diff>
--- a/lectures/03_sor_framework/BNI_SoR_v10.pptx
+++ b/lectures/03_sor_framework/BNI_SoR_v10.pptx
@@ -3151,8 +3151,45 @@
         </p:nvSpPr>
         <p:spPr>
           <a:xfrm>
-            <a:off x="0" y="2651760"/>
-            <a:ext cx="12191695" cy="1371600"/>
+            <a:off x="0" y="2194560"/>
+            <a:ext cx="12191695" cy="457200"/>
+          </a:xfrm>
+          <a:prstGeom prst="rect">
+            <a:avLst/>
+          </a:prstGeom>
+          <a:noFill/>
+        </p:spPr>
+        <p:txBody>
+          <a:bodyPr wrap="none">
+            <a:spAutoFit/>
+          </a:bodyPr>
+          <a:lstStyle/>
+          <a:p>
+            <a:pPr algn="ctr"/>
+            <a:r>
+              <a:rPr sz="2800">
+                <a:solidFill>
+                  <a:srgbClr val="8A8F98"/>
+                </a:solidFill>
+                <a:latin typeface="Pretendard Light"/>
+                <a:ea typeface="Pretendard Light"/>
+                <a:cs typeface="Pretendard Light"/>
+              </a:rPr>
+              <a:t>AI 시대</a:t>
+            </a:r>
+          </a:p>
+        </p:txBody>
+      </p:sp>
+      <p:sp>
+        <p:nvSpPr>
+          <p:cNvPr id="4" name="TextBox 3"/>
+          <p:cNvSpPr txBox="1"/>
+          <p:nvPr/>
+        </p:nvSpPr>
+        <p:spPr>
+          <a:xfrm>
+            <a:off x="0" y="2788920"/>
+            <a:ext cx="12191695" cy="1463040"/>
           </a:xfrm>
           <a:prstGeom prst="rect">
             <a:avLst/>
@@ -3167,7 +3204,7 @@
           <a:p>
             <a:pPr algn="ctr"/>
             <a:r>
-              <a:rPr sz="8400" spc="-294">
+              <a:rPr sz="7200">
                 <a:solidFill>
                   <a:srgbClr val="F7F8F8"/>
                 </a:solidFill>
@@ -3175,48 +3212,35 @@
                 <a:ea typeface="Pretendard Black"/>
                 <a:cs typeface="Pretendard Black"/>
               </a:rPr>
-              <a:t>AI 시대 일하는 구조</a:t>
-            </a:r>
-          </a:p>
-        </p:txBody>
-      </p:sp>
-      <p:sp>
-        <p:nvSpPr>
-          <p:cNvPr id="4" name="TextBox 3"/>
-          <p:cNvSpPr txBox="1"/>
-          <p:nvPr/>
-        </p:nvSpPr>
-        <p:spPr>
-          <a:xfrm>
-            <a:off x="0" y="4206240"/>
-            <a:ext cx="12191695" cy="457200"/>
+              <a:t>준비해야하는 일의 구조</a:t>
+            </a:r>
+          </a:p>
+        </p:txBody>
+      </p:sp>
+      <p:pic>
+        <p:nvPicPr>
+          <p:cNvPr id="5" name="Picture 4" descr="ssod-wordmark.png"/>
+          <p:cNvPicPr>
+            <a:picLocks noChangeAspect="1"/>
+          </p:cNvPicPr>
+          <p:nvPr/>
+        </p:nvPicPr>
+        <p:blipFill>
+          <a:blip r:embed="rId2"/>
+          <a:stretch>
+            <a:fillRect/>
+          </a:stretch>
+        </p:blipFill>
+        <p:spPr>
+          <a:xfrm>
+            <a:off x="5603168" y="4846320"/>
+            <a:ext cx="985359" cy="640080"/>
           </a:xfrm>
           <a:prstGeom prst="rect">
             <a:avLst/>
           </a:prstGeom>
-          <a:noFill/>
-        </p:spPr>
-        <p:txBody>
-          <a:bodyPr wrap="none">
-            <a:spAutoFit/>
-          </a:bodyPr>
-          <a:lstStyle/>
-          <a:p>
-            <a:pPr algn="ctr"/>
-            <a:r>
-              <a:rPr sz="2000">
-                <a:solidFill>
-                  <a:srgbClr val="F7F8F8"/>
-                </a:solidFill>
-                <a:latin typeface="Pretendard Light"/>
-                <a:ea typeface="Pretendard Light"/>
-                <a:cs typeface="Pretendard Light"/>
-              </a:rPr>
-              <a:t>SSOD · 김지명</a:t>
-            </a:r>
-          </a:p>
-        </p:txBody>
-      </p:sp>
+        </p:spPr>
+      </p:pic>
     </p:spTree>
   </p:cSld>
   <p:clrMapOvr>
@@ -3278,16 +3302,51 @@
           </a:p>
         </p:txBody>
       </p:sp>
-      <p:sp>
-        <p:nvSpPr>
-          <p:cNvPr id="3" name="Rounded Rectangle 2"/>
+      <p:cxnSp>
+        <p:nvCxnSpPr>
+          <p:cNvPr id="3" name="Connector 2"/>
+          <p:cNvCxnSpPr/>
+          <p:nvPr/>
+        </p:nvCxnSpPr>
+        <p:spPr>
+          <a:xfrm>
+            <a:off x="365760" y="6144768"/>
+            <a:ext cx="11460175" cy="0"/>
+          </a:xfrm>
+          <a:prstGeom prst="line">
+            <a:avLst/>
+          </a:prstGeom>
+          <a:ln w="6350">
+            <a:solidFill>
+              <a:srgbClr val="23252A"/>
+            </a:solidFill>
+          </a:ln>
+        </p:spPr>
+        <p:style>
+          <a:lnRef idx="2">
+            <a:schemeClr val="accent1"/>
+          </a:lnRef>
+          <a:fillRef idx="0">
+            <a:schemeClr val="accent1"/>
+          </a:fillRef>
+          <a:effectRef idx="1">
+            <a:schemeClr val="accent1"/>
+          </a:effectRef>
+          <a:fontRef idx="minor">
+            <a:schemeClr val="tx1"/>
+          </a:fontRef>
+        </p:style>
+      </p:cxnSp>
+      <p:sp>
+        <p:nvSpPr>
+          <p:cNvPr id="4" name="Rounded Rectangle 3"/>
           <p:cNvSpPr/>
           <p:nvPr/>
         </p:nvSpPr>
         <p:spPr>
           <a:xfrm>
-            <a:off x="365760" y="320040"/>
-            <a:ext cx="777240" cy="292608"/>
+            <a:off x="365760" y="6373368"/>
+            <a:ext cx="960120" cy="292608"/>
           </a:xfrm>
           <a:prstGeom prst="roundRect">
             <a:avLst>
@@ -3318,7 +3377,7 @@
           </a:fontRef>
         </p:style>
         <p:txBody>
-          <a:bodyPr rtlCol="0" anchor="ctr" lIns="73152" rIns="73152" tIns="0" bIns="0"/>
+          <a:bodyPr rtlCol="0" anchor="ctr" wrap="none" tIns="0" bIns="0"/>
           <a:lstStyle/>
           <a:p>
             <a:pPr algn="ctr"/>
@@ -3336,44 +3395,9 @@
           </a:p>
         </p:txBody>
       </p:sp>
-      <p:cxnSp>
-        <p:nvCxnSpPr>
-          <p:cNvPr id="4" name="Connector 3"/>
-          <p:cNvCxnSpPr/>
-          <p:nvPr/>
-        </p:nvCxnSpPr>
-        <p:spPr>
-          <a:xfrm>
-            <a:off x="365760" y="6263640"/>
-            <a:ext cx="11460175" cy="0"/>
-          </a:xfrm>
-          <a:prstGeom prst="line">
-            <a:avLst/>
-          </a:prstGeom>
-          <a:ln w="6350">
-            <a:solidFill>
-              <a:srgbClr val="23252A"/>
-            </a:solidFill>
-          </a:ln>
-        </p:spPr>
-        <p:style>
-          <a:lnRef idx="2">
-            <a:schemeClr val="accent1"/>
-          </a:lnRef>
-          <a:fillRef idx="0">
-            <a:schemeClr val="accent1"/>
-          </a:fillRef>
-          <a:effectRef idx="1">
-            <a:schemeClr val="accent1"/>
-          </a:effectRef>
-          <a:fontRef idx="minor">
-            <a:schemeClr val="tx1"/>
-          </a:fontRef>
-        </p:style>
-      </p:cxnSp>
       <p:pic>
         <p:nvPicPr>
-          <p:cNvPr id="5" name="Picture 4" descr="ssod-logo-lavender.png"/>
+          <p:cNvPr id="5" name="Picture 4" descr="ssod-wordmark.png"/>
           <p:cNvPicPr>
             <a:picLocks noChangeAspect="1"/>
           </p:cNvPicPr>
@@ -3387,8 +3411,8 @@
         </p:blipFill>
         <p:spPr>
           <a:xfrm>
-            <a:off x="11040476" y="6163056"/>
-            <a:ext cx="739739" cy="438912"/>
+            <a:off x="10953188" y="6236208"/>
+            <a:ext cx="872747" cy="566928"/>
           </a:xfrm>
           <a:prstGeom prst="rect">
             <a:avLst/>
@@ -3459,7 +3483,7 @@
                 <a:ea typeface="Pretendard Light"/>
                 <a:cs typeface="Pretendard Light"/>
               </a:rPr>
-              <a:t>    판단</a:t>
+              <a:t>    지능</a:t>
             </a:r>
           </a:p>
         </p:txBody>
@@ -3528,7 +3552,7 @@
                 <a:ea typeface="Pretendard Light"/>
                 <a:cs typeface="Pretendard Light"/>
               </a:rPr>
-              <a:t>    일</a:t>
+              <a:t>    참여</a:t>
             </a:r>
           </a:p>
         </p:txBody>
@@ -3634,7 +3658,7 @@
                 <a:ea typeface="Pretendard Light"/>
                 <a:cs typeface="Pretendard Light"/>
               </a:rPr>
-              <a:t>    데이터</a:t>
+              <a:t>    기록</a:t>
             </a:r>
           </a:p>
         </p:txBody>
@@ -3737,16 +3761,51 @@
           </a:p>
         </p:txBody>
       </p:sp>
-      <p:sp>
-        <p:nvSpPr>
-          <p:cNvPr id="3" name="Rounded Rectangle 2"/>
+      <p:cxnSp>
+        <p:nvCxnSpPr>
+          <p:cNvPr id="3" name="Connector 2"/>
+          <p:cNvCxnSpPr/>
+          <p:nvPr/>
+        </p:nvCxnSpPr>
+        <p:spPr>
+          <a:xfrm>
+            <a:off x="365760" y="6144768"/>
+            <a:ext cx="11460175" cy="0"/>
+          </a:xfrm>
+          <a:prstGeom prst="line">
+            <a:avLst/>
+          </a:prstGeom>
+          <a:ln w="6350">
+            <a:solidFill>
+              <a:srgbClr val="23252A"/>
+            </a:solidFill>
+          </a:ln>
+        </p:spPr>
+        <p:style>
+          <a:lnRef idx="2">
+            <a:schemeClr val="accent1"/>
+          </a:lnRef>
+          <a:fillRef idx="0">
+            <a:schemeClr val="accent1"/>
+          </a:fillRef>
+          <a:effectRef idx="1">
+            <a:schemeClr val="accent1"/>
+          </a:effectRef>
+          <a:fontRef idx="minor">
+            <a:schemeClr val="tx1"/>
+          </a:fontRef>
+        </p:style>
+      </p:cxnSp>
+      <p:sp>
+        <p:nvSpPr>
+          <p:cNvPr id="4" name="Rounded Rectangle 3"/>
           <p:cNvSpPr/>
           <p:nvPr/>
         </p:nvSpPr>
         <p:spPr>
           <a:xfrm>
-            <a:off x="365760" y="320040"/>
-            <a:ext cx="777240" cy="292608"/>
+            <a:off x="365760" y="6373368"/>
+            <a:ext cx="960120" cy="292608"/>
           </a:xfrm>
           <a:prstGeom prst="roundRect">
             <a:avLst>
@@ -3777,7 +3836,7 @@
           </a:fontRef>
         </p:style>
         <p:txBody>
-          <a:bodyPr rtlCol="0" anchor="ctr" lIns="73152" rIns="73152" tIns="0" bIns="0"/>
+          <a:bodyPr rtlCol="0" anchor="ctr" wrap="none" tIns="0" bIns="0"/>
           <a:lstStyle/>
           <a:p>
             <a:pPr algn="ctr"/>
@@ -3795,44 +3854,9 @@
           </a:p>
         </p:txBody>
       </p:sp>
-      <p:cxnSp>
-        <p:nvCxnSpPr>
-          <p:cNvPr id="4" name="Connector 3"/>
-          <p:cNvCxnSpPr/>
-          <p:nvPr/>
-        </p:nvCxnSpPr>
-        <p:spPr>
-          <a:xfrm>
-            <a:off x="365760" y="6263640"/>
-            <a:ext cx="11460175" cy="0"/>
-          </a:xfrm>
-          <a:prstGeom prst="line">
-            <a:avLst/>
-          </a:prstGeom>
-          <a:ln w="6350">
-            <a:solidFill>
-              <a:srgbClr val="23252A"/>
-            </a:solidFill>
-          </a:ln>
-        </p:spPr>
-        <p:style>
-          <a:lnRef idx="2">
-            <a:schemeClr val="accent1"/>
-          </a:lnRef>
-          <a:fillRef idx="0">
-            <a:schemeClr val="accent1"/>
-          </a:fillRef>
-          <a:effectRef idx="1">
-            <a:schemeClr val="accent1"/>
-          </a:effectRef>
-          <a:fontRef idx="minor">
-            <a:schemeClr val="tx1"/>
-          </a:fontRef>
-        </p:style>
-      </p:cxnSp>
       <p:pic>
         <p:nvPicPr>
-          <p:cNvPr id="5" name="Picture 4" descr="ssod-logo-lavender.png"/>
+          <p:cNvPr id="5" name="Picture 4" descr="ssod-wordmark.png"/>
           <p:cNvPicPr>
             <a:picLocks noChangeAspect="1"/>
           </p:cNvPicPr>
@@ -3846,8 +3870,8 @@
         </p:blipFill>
         <p:spPr>
           <a:xfrm>
-            <a:off x="11040476" y="6163056"/>
-            <a:ext cx="739739" cy="438912"/>
+            <a:off x="10953188" y="6236208"/>
+            <a:ext cx="872747" cy="566928"/>
           </a:xfrm>
           <a:prstGeom prst="rect">
             <a:avLst/>
@@ -4062,7 +4086,7 @@
                 <a:ea typeface="Pretendard Light"/>
                 <a:cs typeface="Pretendard Light"/>
               </a:rPr>
-              <a:t>☐  SoR — 데이터</a:t>
+              <a:t>☐  SoR — 기록</a:t>
             </a:r>
           </a:p>
           <a:p>
@@ -4080,7 +4104,7 @@
                 <a:ea typeface="Pretendard Light"/>
                 <a:cs typeface="Pretendard Light"/>
               </a:rPr>
-              <a:t>☐  SoE — 일</a:t>
+              <a:t>☐  SoE — 참여</a:t>
             </a:r>
           </a:p>
           <a:p>
@@ -4098,7 +4122,7 @@
                 <a:ea typeface="Pretendard Light"/>
                 <a:cs typeface="Pretendard Light"/>
               </a:rPr>
-              <a:t>☐  SoI — 판단</a:t>
+              <a:t>☐  SoI — 지능</a:t>
             </a:r>
           </a:p>
         </p:txBody>
@@ -4166,7 +4190,7 @@
       </p:sp>
       <p:pic>
         <p:nvPicPr>
-          <p:cNvPr id="3" name="Picture 2" descr="ssod-logo-lavender.png"/>
+          <p:cNvPr id="3" name="Picture 2" descr="ssod-wordmark.png"/>
           <p:cNvPicPr>
             <a:picLocks noChangeAspect="1"/>
           </p:cNvPicPr>
@@ -4180,8 +4204,8 @@
         </p:blipFill>
         <p:spPr>
           <a:xfrm>
-            <a:off x="10532933" y="5669280"/>
-            <a:ext cx="1155842" cy="685800"/>
+            <a:off x="5110488" y="2514600"/>
+            <a:ext cx="1970719" cy="1280160"/>
           </a:xfrm>
           <a:prstGeom prst="rect">
             <a:avLst/>
@@ -4196,8 +4220,8 @@
         </p:nvSpPr>
         <p:spPr>
           <a:xfrm>
-            <a:off x="9601200" y="5486400"/>
-            <a:ext cx="2286000" cy="365760"/>
+            <a:off x="0" y="4663440"/>
+            <a:ext cx="12191695" cy="457200"/>
           </a:xfrm>
           <a:prstGeom prst="rect">
             <a:avLst/>
@@ -4210,9 +4234,9 @@
           </a:bodyPr>
           <a:lstStyle/>
           <a:p>
-            <a:pPr algn="r"/>
-            <a:r>
-              <a:rPr sz="1600">
+            <a:pPr algn="ctr"/>
+            <a:r>
+              <a:rPr sz="1800">
                 <a:solidFill>
                   <a:srgbClr val="F7F8F8"/>
                 </a:solidFill>
@@ -4286,16 +4310,51 @@
           </a:p>
         </p:txBody>
       </p:sp>
-      <p:sp>
-        <p:nvSpPr>
-          <p:cNvPr id="3" name="Rounded Rectangle 2"/>
+      <p:cxnSp>
+        <p:nvCxnSpPr>
+          <p:cNvPr id="3" name="Connector 2"/>
+          <p:cNvCxnSpPr/>
+          <p:nvPr/>
+        </p:nvCxnSpPr>
+        <p:spPr>
+          <a:xfrm>
+            <a:off x="365760" y="6144768"/>
+            <a:ext cx="11460175" cy="0"/>
+          </a:xfrm>
+          <a:prstGeom prst="line">
+            <a:avLst/>
+          </a:prstGeom>
+          <a:ln w="6350">
+            <a:solidFill>
+              <a:srgbClr val="23252A"/>
+            </a:solidFill>
+          </a:ln>
+        </p:spPr>
+        <p:style>
+          <a:lnRef idx="2">
+            <a:schemeClr val="accent1"/>
+          </a:lnRef>
+          <a:fillRef idx="0">
+            <a:schemeClr val="accent1"/>
+          </a:fillRef>
+          <a:effectRef idx="1">
+            <a:schemeClr val="accent1"/>
+          </a:effectRef>
+          <a:fontRef idx="minor">
+            <a:schemeClr val="tx1"/>
+          </a:fontRef>
+        </p:style>
+      </p:cxnSp>
+      <p:sp>
+        <p:nvSpPr>
+          <p:cNvPr id="4" name="Rounded Rectangle 3"/>
           <p:cNvSpPr/>
           <p:nvPr/>
         </p:nvSpPr>
         <p:spPr>
           <a:xfrm>
-            <a:off x="365760" y="320040"/>
-            <a:ext cx="777240" cy="292608"/>
+            <a:off x="365760" y="6373368"/>
+            <a:ext cx="960120" cy="292608"/>
           </a:xfrm>
           <a:prstGeom prst="roundRect">
             <a:avLst>
@@ -4326,7 +4385,7 @@
           </a:fontRef>
         </p:style>
         <p:txBody>
-          <a:bodyPr rtlCol="0" anchor="ctr" lIns="73152" rIns="73152" tIns="0" bIns="0"/>
+          <a:bodyPr rtlCol="0" anchor="ctr" wrap="none" tIns="0" bIns="0"/>
           <a:lstStyle/>
           <a:p>
             <a:pPr algn="ctr"/>
@@ -4344,44 +4403,9 @@
           </a:p>
         </p:txBody>
       </p:sp>
-      <p:cxnSp>
-        <p:nvCxnSpPr>
-          <p:cNvPr id="4" name="Connector 3"/>
-          <p:cNvCxnSpPr/>
-          <p:nvPr/>
-        </p:nvCxnSpPr>
-        <p:spPr>
-          <a:xfrm>
-            <a:off x="365760" y="6263640"/>
-            <a:ext cx="11460175" cy="0"/>
-          </a:xfrm>
-          <a:prstGeom prst="line">
-            <a:avLst/>
-          </a:prstGeom>
-          <a:ln w="6350">
-            <a:solidFill>
-              <a:srgbClr val="23252A"/>
-            </a:solidFill>
-          </a:ln>
-        </p:spPr>
-        <p:style>
-          <a:lnRef idx="2">
-            <a:schemeClr val="accent1"/>
-          </a:lnRef>
-          <a:fillRef idx="0">
-            <a:schemeClr val="accent1"/>
-          </a:fillRef>
-          <a:effectRef idx="1">
-            <a:schemeClr val="accent1"/>
-          </a:effectRef>
-          <a:fontRef idx="minor">
-            <a:schemeClr val="tx1"/>
-          </a:fontRef>
-        </p:style>
-      </p:cxnSp>
       <p:pic>
         <p:nvPicPr>
-          <p:cNvPr id="5" name="Picture 4" descr="ssod-logo-lavender.png"/>
+          <p:cNvPr id="5" name="Picture 4" descr="ssod-wordmark.png"/>
           <p:cNvPicPr>
             <a:picLocks noChangeAspect="1"/>
           </p:cNvPicPr>
@@ -4395,8 +4419,8 @@
         </p:blipFill>
         <p:spPr>
           <a:xfrm>
-            <a:off x="11040476" y="6163056"/>
-            <a:ext cx="739739" cy="438912"/>
+            <a:off x="10953188" y="6236208"/>
+            <a:ext cx="872747" cy="566928"/>
           </a:xfrm>
           <a:prstGeom prst="rect">
             <a:avLst/>
@@ -4560,16 +4584,51 @@
           </a:p>
         </p:txBody>
       </p:sp>
-      <p:sp>
-        <p:nvSpPr>
-          <p:cNvPr id="3" name="Rounded Rectangle 2"/>
+      <p:cxnSp>
+        <p:nvCxnSpPr>
+          <p:cNvPr id="3" name="Connector 2"/>
+          <p:cNvCxnSpPr/>
+          <p:nvPr/>
+        </p:nvCxnSpPr>
+        <p:spPr>
+          <a:xfrm>
+            <a:off x="365760" y="6144768"/>
+            <a:ext cx="11460175" cy="0"/>
+          </a:xfrm>
+          <a:prstGeom prst="line">
+            <a:avLst/>
+          </a:prstGeom>
+          <a:ln w="6350">
+            <a:solidFill>
+              <a:srgbClr val="23252A"/>
+            </a:solidFill>
+          </a:ln>
+        </p:spPr>
+        <p:style>
+          <a:lnRef idx="2">
+            <a:schemeClr val="accent1"/>
+          </a:lnRef>
+          <a:fillRef idx="0">
+            <a:schemeClr val="accent1"/>
+          </a:fillRef>
+          <a:effectRef idx="1">
+            <a:schemeClr val="accent1"/>
+          </a:effectRef>
+          <a:fontRef idx="minor">
+            <a:schemeClr val="tx1"/>
+          </a:fontRef>
+        </p:style>
+      </p:cxnSp>
+      <p:sp>
+        <p:nvSpPr>
+          <p:cNvPr id="4" name="Rounded Rectangle 3"/>
           <p:cNvSpPr/>
           <p:nvPr/>
         </p:nvSpPr>
         <p:spPr>
           <a:xfrm>
-            <a:off x="365760" y="320040"/>
-            <a:ext cx="777240" cy="292608"/>
+            <a:off x="365760" y="6373368"/>
+            <a:ext cx="960120" cy="292608"/>
           </a:xfrm>
           <a:prstGeom prst="roundRect">
             <a:avLst>
@@ -4600,7 +4659,7 @@
           </a:fontRef>
         </p:style>
         <p:txBody>
-          <a:bodyPr rtlCol="0" anchor="ctr" lIns="73152" rIns="73152" tIns="0" bIns="0"/>
+          <a:bodyPr rtlCol="0" anchor="ctr" wrap="none" tIns="0" bIns="0"/>
           <a:lstStyle/>
           <a:p>
             <a:pPr algn="ctr"/>
@@ -4618,44 +4677,9 @@
           </a:p>
         </p:txBody>
       </p:sp>
-      <p:cxnSp>
-        <p:nvCxnSpPr>
-          <p:cNvPr id="4" name="Connector 3"/>
-          <p:cNvCxnSpPr/>
-          <p:nvPr/>
-        </p:nvCxnSpPr>
-        <p:spPr>
-          <a:xfrm>
-            <a:off x="365760" y="6263640"/>
-            <a:ext cx="11460175" cy="0"/>
-          </a:xfrm>
-          <a:prstGeom prst="line">
-            <a:avLst/>
-          </a:prstGeom>
-          <a:ln w="6350">
-            <a:solidFill>
-              <a:srgbClr val="23252A"/>
-            </a:solidFill>
-          </a:ln>
-        </p:spPr>
-        <p:style>
-          <a:lnRef idx="2">
-            <a:schemeClr val="accent1"/>
-          </a:lnRef>
-          <a:fillRef idx="0">
-            <a:schemeClr val="accent1"/>
-          </a:fillRef>
-          <a:effectRef idx="1">
-            <a:schemeClr val="accent1"/>
-          </a:effectRef>
-          <a:fontRef idx="minor">
-            <a:schemeClr val="tx1"/>
-          </a:fontRef>
-        </p:style>
-      </p:cxnSp>
       <p:pic>
         <p:nvPicPr>
-          <p:cNvPr id="5" name="Picture 4" descr="ssod-logo-lavender.png"/>
+          <p:cNvPr id="5" name="Picture 4" descr="ssod-wordmark.png"/>
           <p:cNvPicPr>
             <a:picLocks noChangeAspect="1"/>
           </p:cNvPicPr>
@@ -4669,8 +4693,8 @@
         </p:blipFill>
         <p:spPr>
           <a:xfrm>
-            <a:off x="11040476" y="6163056"/>
-            <a:ext cx="739739" cy="438912"/>
+            <a:off x="10953188" y="6236208"/>
+            <a:ext cx="872747" cy="566928"/>
           </a:xfrm>
           <a:prstGeom prst="rect">
             <a:avLst/>
@@ -4812,16 +4836,51 @@
           </a:p>
         </p:txBody>
       </p:sp>
-      <p:sp>
-        <p:nvSpPr>
-          <p:cNvPr id="3" name="Rounded Rectangle 2"/>
+      <p:cxnSp>
+        <p:nvCxnSpPr>
+          <p:cNvPr id="3" name="Connector 2"/>
+          <p:cNvCxnSpPr/>
+          <p:nvPr/>
+        </p:nvCxnSpPr>
+        <p:spPr>
+          <a:xfrm>
+            <a:off x="365760" y="6144768"/>
+            <a:ext cx="11460175" cy="0"/>
+          </a:xfrm>
+          <a:prstGeom prst="line">
+            <a:avLst/>
+          </a:prstGeom>
+          <a:ln w="6350">
+            <a:solidFill>
+              <a:srgbClr val="23252A"/>
+            </a:solidFill>
+          </a:ln>
+        </p:spPr>
+        <p:style>
+          <a:lnRef idx="2">
+            <a:schemeClr val="accent1"/>
+          </a:lnRef>
+          <a:fillRef idx="0">
+            <a:schemeClr val="accent1"/>
+          </a:fillRef>
+          <a:effectRef idx="1">
+            <a:schemeClr val="accent1"/>
+          </a:effectRef>
+          <a:fontRef idx="minor">
+            <a:schemeClr val="tx1"/>
+          </a:fontRef>
+        </p:style>
+      </p:cxnSp>
+      <p:sp>
+        <p:nvSpPr>
+          <p:cNvPr id="4" name="Rounded Rectangle 3"/>
           <p:cNvSpPr/>
           <p:nvPr/>
         </p:nvSpPr>
         <p:spPr>
           <a:xfrm>
-            <a:off x="365760" y="320040"/>
-            <a:ext cx="777240" cy="292608"/>
+            <a:off x="365760" y="6373368"/>
+            <a:ext cx="960120" cy="292608"/>
           </a:xfrm>
           <a:prstGeom prst="roundRect">
             <a:avLst>
@@ -4852,7 +4911,7 @@
           </a:fontRef>
         </p:style>
         <p:txBody>
-          <a:bodyPr rtlCol="0" anchor="ctr" lIns="73152" rIns="73152" tIns="0" bIns="0"/>
+          <a:bodyPr rtlCol="0" anchor="ctr" wrap="none" tIns="0" bIns="0"/>
           <a:lstStyle/>
           <a:p>
             <a:pPr algn="ctr"/>
@@ -4870,44 +4929,9 @@
           </a:p>
         </p:txBody>
       </p:sp>
-      <p:cxnSp>
-        <p:nvCxnSpPr>
-          <p:cNvPr id="4" name="Connector 3"/>
-          <p:cNvCxnSpPr/>
-          <p:nvPr/>
-        </p:nvCxnSpPr>
-        <p:spPr>
-          <a:xfrm>
-            <a:off x="365760" y="6263640"/>
-            <a:ext cx="11460175" cy="0"/>
-          </a:xfrm>
-          <a:prstGeom prst="line">
-            <a:avLst/>
-          </a:prstGeom>
-          <a:ln w="6350">
-            <a:solidFill>
-              <a:srgbClr val="23252A"/>
-            </a:solidFill>
-          </a:ln>
-        </p:spPr>
-        <p:style>
-          <a:lnRef idx="2">
-            <a:schemeClr val="accent1"/>
-          </a:lnRef>
-          <a:fillRef idx="0">
-            <a:schemeClr val="accent1"/>
-          </a:fillRef>
-          <a:effectRef idx="1">
-            <a:schemeClr val="accent1"/>
-          </a:effectRef>
-          <a:fontRef idx="minor">
-            <a:schemeClr val="tx1"/>
-          </a:fontRef>
-        </p:style>
-      </p:cxnSp>
       <p:pic>
         <p:nvPicPr>
-          <p:cNvPr id="5" name="Picture 4" descr="ssod-logo-lavender.png"/>
+          <p:cNvPr id="5" name="Picture 4" descr="ssod-wordmark.png"/>
           <p:cNvPicPr>
             <a:picLocks noChangeAspect="1"/>
           </p:cNvPicPr>
@@ -4921,8 +4945,8 @@
         </p:blipFill>
         <p:spPr>
           <a:xfrm>
-            <a:off x="11040476" y="6163056"/>
-            <a:ext cx="739739" cy="438912"/>
+            <a:off x="10953188" y="6236208"/>
+            <a:ext cx="872747" cy="566928"/>
           </a:xfrm>
           <a:prstGeom prst="rect">
             <a:avLst/>
@@ -4953,7 +4977,7 @@
           <a:p>
             <a:pPr algn="ctr"/>
             <a:r>
-              <a:rPr sz="16000" spc="-560">
+              <a:rPr sz="13000" spc="-455">
                 <a:solidFill>
                   <a:srgbClr val="F7F8F8"/>
                 </a:solidFill>
@@ -4961,7 +4985,7 @@
                 <a:ea typeface="Pretendard Black"/>
                 <a:cs typeface="Pretendard Black"/>
               </a:rPr>
-              <a:t>둘 다</a:t>
+              <a:t>국내 유일</a:t>
             </a:r>
           </a:p>
         </p:txBody>
@@ -5046,7 +5070,7 @@
                 <a:ea typeface="Pretendard Light"/>
                 <a:cs typeface="Pretendard Light"/>
               </a:rPr>
-              <a:t>글로벌 공식 앰버서더 — 한국에 쏘드뿐</a:t>
+              <a:t>이중 앰버서더는 국내 SSOD뿐</a:t>
             </a:r>
           </a:p>
         </p:txBody>
@@ -5112,16 +5136,51 @@
           </a:p>
         </p:txBody>
       </p:sp>
-      <p:sp>
-        <p:nvSpPr>
-          <p:cNvPr id="3" name="Rounded Rectangle 2"/>
+      <p:cxnSp>
+        <p:nvCxnSpPr>
+          <p:cNvPr id="3" name="Connector 2"/>
+          <p:cNvCxnSpPr/>
+          <p:nvPr/>
+        </p:nvCxnSpPr>
+        <p:spPr>
+          <a:xfrm>
+            <a:off x="365760" y="6144768"/>
+            <a:ext cx="11460175" cy="0"/>
+          </a:xfrm>
+          <a:prstGeom prst="line">
+            <a:avLst/>
+          </a:prstGeom>
+          <a:ln w="6350">
+            <a:solidFill>
+              <a:srgbClr val="23252A"/>
+            </a:solidFill>
+          </a:ln>
+        </p:spPr>
+        <p:style>
+          <a:lnRef idx="2">
+            <a:schemeClr val="accent1"/>
+          </a:lnRef>
+          <a:fillRef idx="0">
+            <a:schemeClr val="accent1"/>
+          </a:fillRef>
+          <a:effectRef idx="1">
+            <a:schemeClr val="accent1"/>
+          </a:effectRef>
+          <a:fontRef idx="minor">
+            <a:schemeClr val="tx1"/>
+          </a:fontRef>
+        </p:style>
+      </p:cxnSp>
+      <p:sp>
+        <p:nvSpPr>
+          <p:cNvPr id="4" name="Rounded Rectangle 3"/>
           <p:cNvSpPr/>
           <p:nvPr/>
         </p:nvSpPr>
         <p:spPr>
           <a:xfrm>
-            <a:off x="365760" y="320040"/>
-            <a:ext cx="777240" cy="292608"/>
+            <a:off x="365760" y="6373368"/>
+            <a:ext cx="960120" cy="292608"/>
           </a:xfrm>
           <a:prstGeom prst="roundRect">
             <a:avLst>
@@ -5152,7 +5211,7 @@
           </a:fontRef>
         </p:style>
         <p:txBody>
-          <a:bodyPr rtlCol="0" anchor="ctr" lIns="73152" rIns="73152" tIns="0" bIns="0"/>
+          <a:bodyPr rtlCol="0" anchor="ctr" wrap="none" tIns="0" bIns="0"/>
           <a:lstStyle/>
           <a:p>
             <a:pPr algn="ctr"/>
@@ -5170,44 +5229,9 @@
           </a:p>
         </p:txBody>
       </p:sp>
-      <p:cxnSp>
-        <p:nvCxnSpPr>
-          <p:cNvPr id="4" name="Connector 3"/>
-          <p:cNvCxnSpPr/>
-          <p:nvPr/>
-        </p:nvCxnSpPr>
-        <p:spPr>
-          <a:xfrm>
-            <a:off x="365760" y="6263640"/>
-            <a:ext cx="11460175" cy="0"/>
-          </a:xfrm>
-          <a:prstGeom prst="line">
-            <a:avLst/>
-          </a:prstGeom>
-          <a:ln w="6350">
-            <a:solidFill>
-              <a:srgbClr val="23252A"/>
-            </a:solidFill>
-          </a:ln>
-        </p:spPr>
-        <p:style>
-          <a:lnRef idx="2">
-            <a:schemeClr val="accent1"/>
-          </a:lnRef>
-          <a:fillRef idx="0">
-            <a:schemeClr val="accent1"/>
-          </a:fillRef>
-          <a:effectRef idx="1">
-            <a:schemeClr val="accent1"/>
-          </a:effectRef>
-          <a:fontRef idx="minor">
-            <a:schemeClr val="tx1"/>
-          </a:fontRef>
-        </p:style>
-      </p:cxnSp>
       <p:pic>
         <p:nvPicPr>
-          <p:cNvPr id="5" name="Picture 4" descr="ssod-logo-lavender.png"/>
+          <p:cNvPr id="5" name="Picture 4" descr="ssod-wordmark.png"/>
           <p:cNvPicPr>
             <a:picLocks noChangeAspect="1"/>
           </p:cNvPicPr>
@@ -5221,8 +5245,8 @@
         </p:blipFill>
         <p:spPr>
           <a:xfrm>
-            <a:off x="11040476" y="6163056"/>
-            <a:ext cx="739739" cy="438912"/>
+            <a:off x="10953188" y="6236208"/>
+            <a:ext cx="872747" cy="566928"/>
           </a:xfrm>
           <a:prstGeom prst="rect">
             <a:avLst/>
@@ -5386,16 +5410,51 @@
           </a:p>
         </p:txBody>
       </p:sp>
-      <p:sp>
-        <p:nvSpPr>
-          <p:cNvPr id="3" name="Rounded Rectangle 2"/>
+      <p:cxnSp>
+        <p:nvCxnSpPr>
+          <p:cNvPr id="3" name="Connector 2"/>
+          <p:cNvCxnSpPr/>
+          <p:nvPr/>
+        </p:nvCxnSpPr>
+        <p:spPr>
+          <a:xfrm>
+            <a:off x="365760" y="6144768"/>
+            <a:ext cx="11460175" cy="0"/>
+          </a:xfrm>
+          <a:prstGeom prst="line">
+            <a:avLst/>
+          </a:prstGeom>
+          <a:ln w="6350">
+            <a:solidFill>
+              <a:srgbClr val="23252A"/>
+            </a:solidFill>
+          </a:ln>
+        </p:spPr>
+        <p:style>
+          <a:lnRef idx="2">
+            <a:schemeClr val="accent1"/>
+          </a:lnRef>
+          <a:fillRef idx="0">
+            <a:schemeClr val="accent1"/>
+          </a:fillRef>
+          <a:effectRef idx="1">
+            <a:schemeClr val="accent1"/>
+          </a:effectRef>
+          <a:fontRef idx="minor">
+            <a:schemeClr val="tx1"/>
+          </a:fontRef>
+        </p:style>
+      </p:cxnSp>
+      <p:sp>
+        <p:nvSpPr>
+          <p:cNvPr id="4" name="Rounded Rectangle 3"/>
           <p:cNvSpPr/>
           <p:nvPr/>
         </p:nvSpPr>
         <p:spPr>
           <a:xfrm>
-            <a:off x="365760" y="320040"/>
-            <a:ext cx="777240" cy="292608"/>
+            <a:off x="365760" y="6373368"/>
+            <a:ext cx="960120" cy="292608"/>
           </a:xfrm>
           <a:prstGeom prst="roundRect">
             <a:avLst>
@@ -5426,7 +5485,7 @@
           </a:fontRef>
         </p:style>
         <p:txBody>
-          <a:bodyPr rtlCol="0" anchor="ctr" lIns="73152" rIns="73152" tIns="0" bIns="0"/>
+          <a:bodyPr rtlCol="0" anchor="ctr" wrap="none" tIns="0" bIns="0"/>
           <a:lstStyle/>
           <a:p>
             <a:pPr algn="ctr"/>
@@ -5444,44 +5503,9 @@
           </a:p>
         </p:txBody>
       </p:sp>
-      <p:cxnSp>
-        <p:nvCxnSpPr>
-          <p:cNvPr id="4" name="Connector 3"/>
-          <p:cNvCxnSpPr/>
-          <p:nvPr/>
-        </p:nvCxnSpPr>
-        <p:spPr>
-          <a:xfrm>
-            <a:off x="365760" y="6263640"/>
-            <a:ext cx="11460175" cy="0"/>
-          </a:xfrm>
-          <a:prstGeom prst="line">
-            <a:avLst/>
-          </a:prstGeom>
-          <a:ln w="6350">
-            <a:solidFill>
-              <a:srgbClr val="23252A"/>
-            </a:solidFill>
-          </a:ln>
-        </p:spPr>
-        <p:style>
-          <a:lnRef idx="2">
-            <a:schemeClr val="accent1"/>
-          </a:lnRef>
-          <a:fillRef idx="0">
-            <a:schemeClr val="accent1"/>
-          </a:fillRef>
-          <a:effectRef idx="1">
-            <a:schemeClr val="accent1"/>
-          </a:effectRef>
-          <a:fontRef idx="minor">
-            <a:schemeClr val="tx1"/>
-          </a:fontRef>
-        </p:style>
-      </p:cxnSp>
       <p:pic>
         <p:nvPicPr>
-          <p:cNvPr id="5" name="Picture 4" descr="ssod-logo-lavender.png"/>
+          <p:cNvPr id="5" name="Picture 4" descr="ssod-wordmark.png"/>
           <p:cNvPicPr>
             <a:picLocks noChangeAspect="1"/>
           </p:cNvPicPr>
@@ -5495,8 +5519,8 @@
         </p:blipFill>
         <p:spPr>
           <a:xfrm>
-            <a:off x="11040476" y="6163056"/>
-            <a:ext cx="739739" cy="438912"/>
+            <a:off x="10953188" y="6236208"/>
+            <a:ext cx="872747" cy="566928"/>
           </a:xfrm>
           <a:prstGeom prst="rect">
             <a:avLst/>
@@ -5638,16 +5662,51 @@
           </a:p>
         </p:txBody>
       </p:sp>
-      <p:sp>
-        <p:nvSpPr>
-          <p:cNvPr id="3" name="Rounded Rectangle 2"/>
+      <p:cxnSp>
+        <p:nvCxnSpPr>
+          <p:cNvPr id="3" name="Connector 2"/>
+          <p:cNvCxnSpPr/>
+          <p:nvPr/>
+        </p:nvCxnSpPr>
+        <p:spPr>
+          <a:xfrm>
+            <a:off x="365760" y="6144768"/>
+            <a:ext cx="11460175" cy="0"/>
+          </a:xfrm>
+          <a:prstGeom prst="line">
+            <a:avLst/>
+          </a:prstGeom>
+          <a:ln w="6350">
+            <a:solidFill>
+              <a:srgbClr val="23252A"/>
+            </a:solidFill>
+          </a:ln>
+        </p:spPr>
+        <p:style>
+          <a:lnRef idx="2">
+            <a:schemeClr val="accent1"/>
+          </a:lnRef>
+          <a:fillRef idx="0">
+            <a:schemeClr val="accent1"/>
+          </a:fillRef>
+          <a:effectRef idx="1">
+            <a:schemeClr val="accent1"/>
+          </a:effectRef>
+          <a:fontRef idx="minor">
+            <a:schemeClr val="tx1"/>
+          </a:fontRef>
+        </p:style>
+      </p:cxnSp>
+      <p:sp>
+        <p:nvSpPr>
+          <p:cNvPr id="4" name="Rounded Rectangle 3"/>
           <p:cNvSpPr/>
           <p:nvPr/>
         </p:nvSpPr>
         <p:spPr>
           <a:xfrm>
-            <a:off x="365760" y="320040"/>
-            <a:ext cx="777240" cy="292608"/>
+            <a:off x="365760" y="6373368"/>
+            <a:ext cx="960120" cy="292608"/>
           </a:xfrm>
           <a:prstGeom prst="roundRect">
             <a:avLst>
@@ -5678,7 +5737,7 @@
           </a:fontRef>
         </p:style>
         <p:txBody>
-          <a:bodyPr rtlCol="0" anchor="ctr" lIns="73152" rIns="73152" tIns="0" bIns="0"/>
+          <a:bodyPr rtlCol="0" anchor="ctr" wrap="none" tIns="0" bIns="0"/>
           <a:lstStyle/>
           <a:p>
             <a:pPr algn="ctr"/>
@@ -5696,44 +5755,9 @@
           </a:p>
         </p:txBody>
       </p:sp>
-      <p:cxnSp>
-        <p:nvCxnSpPr>
-          <p:cNvPr id="4" name="Connector 3"/>
-          <p:cNvCxnSpPr/>
-          <p:nvPr/>
-        </p:nvCxnSpPr>
-        <p:spPr>
-          <a:xfrm>
-            <a:off x="365760" y="6263640"/>
-            <a:ext cx="11460175" cy="0"/>
-          </a:xfrm>
-          <a:prstGeom prst="line">
-            <a:avLst/>
-          </a:prstGeom>
-          <a:ln w="6350">
-            <a:solidFill>
-              <a:srgbClr val="23252A"/>
-            </a:solidFill>
-          </a:ln>
-        </p:spPr>
-        <p:style>
-          <a:lnRef idx="2">
-            <a:schemeClr val="accent1"/>
-          </a:lnRef>
-          <a:fillRef idx="0">
-            <a:schemeClr val="accent1"/>
-          </a:fillRef>
-          <a:effectRef idx="1">
-            <a:schemeClr val="accent1"/>
-          </a:effectRef>
-          <a:fontRef idx="minor">
-            <a:schemeClr val="tx1"/>
-          </a:fontRef>
-        </p:style>
-      </p:cxnSp>
       <p:pic>
         <p:nvPicPr>
-          <p:cNvPr id="5" name="Picture 4" descr="ssod-logo-lavender.png"/>
+          <p:cNvPr id="5" name="Picture 4" descr="ssod-wordmark.png"/>
           <p:cNvPicPr>
             <a:picLocks noChangeAspect="1"/>
           </p:cNvPicPr>
@@ -5747,8 +5771,8 @@
         </p:blipFill>
         <p:spPr>
           <a:xfrm>
-            <a:off x="11040476" y="6163056"/>
-            <a:ext cx="739739" cy="438912"/>
+            <a:off x="10953188" y="6236208"/>
+            <a:ext cx="872747" cy="566928"/>
           </a:xfrm>
           <a:prstGeom prst="rect">
             <a:avLst/>
@@ -5763,8 +5787,8 @@
         </p:nvSpPr>
         <p:spPr>
           <a:xfrm>
-            <a:off x="0" y="1828800"/>
-            <a:ext cx="12191695" cy="2560320"/>
+            <a:off x="0" y="1463040"/>
+            <a:ext cx="12191695" cy="2377440"/>
           </a:xfrm>
           <a:prstGeom prst="rect">
             <a:avLst/>
@@ -5800,7 +5824,7 @@
         </p:nvSpPr>
         <p:spPr>
           <a:xfrm>
-            <a:off x="0" y="4206240"/>
+            <a:off x="0" y="4069080"/>
             <a:ext cx="12191695" cy="457200"/>
           </a:xfrm>
           <a:prstGeom prst="rect">
@@ -5816,7 +5840,7 @@
           <a:p>
             <a:pPr algn="ctr"/>
             <a:r>
-              <a:rPr sz="4800">
+              <a:rPr sz="4400">
                 <a:solidFill>
                   <a:srgbClr val="8A8F98"/>
                 </a:solidFill>
@@ -5824,7 +5848,7 @@
                 <a:ea typeface="Pretendard Light"/>
                 <a:cs typeface="Pretendard Light"/>
               </a:rPr>
-              <a:t>데이터</a:t>
+              <a:t>기록</a:t>
             </a:r>
           </a:p>
         </p:txBody>
@@ -5837,7 +5861,7 @@
         </p:nvSpPr>
         <p:spPr>
           <a:xfrm>
-            <a:off x="0" y="5212080"/>
+            <a:off x="0" y="4709160"/>
             <a:ext cx="12191695" cy="457200"/>
           </a:xfrm>
           <a:prstGeom prst="rect">
@@ -5855,13 +5879,50 @@
             <a:r>
               <a:rPr sz="2200">
                 <a:solidFill>
-                  <a:srgbClr val="8A8F98"/>
+                  <a:srgbClr val="F7F8F8"/>
                 </a:solidFill>
                 <a:latin typeface="Pretendard Light"/>
                 <a:ea typeface="Pretendard Light"/>
                 <a:cs typeface="Pretendard Light"/>
               </a:rPr>
-              <a:t>ERP · 고객 명단 · 매출</a:t>
+              <a:t>회사의 거래·사실이 권위 있게 적힌 자리</a:t>
+            </a:r>
+          </a:p>
+        </p:txBody>
+      </p:sp>
+      <p:sp>
+        <p:nvSpPr>
+          <p:cNvPr id="9" name="TextBox 8"/>
+          <p:cNvSpPr txBox="1"/>
+          <p:nvPr/>
+        </p:nvSpPr>
+        <p:spPr>
+          <a:xfrm>
+            <a:off x="0" y="5349240"/>
+            <a:ext cx="12191695" cy="457200"/>
+          </a:xfrm>
+          <a:prstGeom prst="rect">
+            <a:avLst/>
+          </a:prstGeom>
+          <a:noFill/>
+        </p:spPr>
+        <p:txBody>
+          <a:bodyPr wrap="none">
+            <a:spAutoFit/>
+          </a:bodyPr>
+          <a:lstStyle/>
+          <a:p>
+            <a:pPr algn="ctr"/>
+            <a:r>
+              <a:rPr sz="1800">
+                <a:solidFill>
+                  <a:srgbClr val="8A8F98"/>
+                </a:solidFill>
+                <a:latin typeface="Pretendard Light"/>
+                <a:ea typeface="Pretendard Light"/>
+                <a:cs typeface="Pretendard Light"/>
+              </a:rPr>
+              <a:t>ERP · CRM · 매출</a:t>
             </a:r>
           </a:p>
         </p:txBody>
@@ -5927,16 +5988,51 @@
           </a:p>
         </p:txBody>
       </p:sp>
-      <p:sp>
-        <p:nvSpPr>
-          <p:cNvPr id="3" name="Rounded Rectangle 2"/>
+      <p:cxnSp>
+        <p:nvCxnSpPr>
+          <p:cNvPr id="3" name="Connector 2"/>
+          <p:cNvCxnSpPr/>
+          <p:nvPr/>
+        </p:nvCxnSpPr>
+        <p:spPr>
+          <a:xfrm>
+            <a:off x="365760" y="6144768"/>
+            <a:ext cx="11460175" cy="0"/>
+          </a:xfrm>
+          <a:prstGeom prst="line">
+            <a:avLst/>
+          </a:prstGeom>
+          <a:ln w="6350">
+            <a:solidFill>
+              <a:srgbClr val="23252A"/>
+            </a:solidFill>
+          </a:ln>
+        </p:spPr>
+        <p:style>
+          <a:lnRef idx="2">
+            <a:schemeClr val="accent1"/>
+          </a:lnRef>
+          <a:fillRef idx="0">
+            <a:schemeClr val="accent1"/>
+          </a:fillRef>
+          <a:effectRef idx="1">
+            <a:schemeClr val="accent1"/>
+          </a:effectRef>
+          <a:fontRef idx="minor">
+            <a:schemeClr val="tx1"/>
+          </a:fontRef>
+        </p:style>
+      </p:cxnSp>
+      <p:sp>
+        <p:nvSpPr>
+          <p:cNvPr id="4" name="Rounded Rectangle 3"/>
           <p:cNvSpPr/>
           <p:nvPr/>
         </p:nvSpPr>
         <p:spPr>
           <a:xfrm>
-            <a:off x="365760" y="320040"/>
-            <a:ext cx="777240" cy="292608"/>
+            <a:off x="365760" y="6373368"/>
+            <a:ext cx="960120" cy="292608"/>
           </a:xfrm>
           <a:prstGeom prst="roundRect">
             <a:avLst>
@@ -5967,7 +6063,7 @@
           </a:fontRef>
         </p:style>
         <p:txBody>
-          <a:bodyPr rtlCol="0" anchor="ctr" lIns="73152" rIns="73152" tIns="0" bIns="0"/>
+          <a:bodyPr rtlCol="0" anchor="ctr" wrap="none" tIns="0" bIns="0"/>
           <a:lstStyle/>
           <a:p>
             <a:pPr algn="ctr"/>
@@ -5985,44 +6081,9 @@
           </a:p>
         </p:txBody>
       </p:sp>
-      <p:cxnSp>
-        <p:nvCxnSpPr>
-          <p:cNvPr id="4" name="Connector 3"/>
-          <p:cNvCxnSpPr/>
-          <p:nvPr/>
-        </p:nvCxnSpPr>
-        <p:spPr>
-          <a:xfrm>
-            <a:off x="365760" y="6263640"/>
-            <a:ext cx="11460175" cy="0"/>
-          </a:xfrm>
-          <a:prstGeom prst="line">
-            <a:avLst/>
-          </a:prstGeom>
-          <a:ln w="6350">
-            <a:solidFill>
-              <a:srgbClr val="23252A"/>
-            </a:solidFill>
-          </a:ln>
-        </p:spPr>
-        <p:style>
-          <a:lnRef idx="2">
-            <a:schemeClr val="accent1"/>
-          </a:lnRef>
-          <a:fillRef idx="0">
-            <a:schemeClr val="accent1"/>
-          </a:fillRef>
-          <a:effectRef idx="1">
-            <a:schemeClr val="accent1"/>
-          </a:effectRef>
-          <a:fontRef idx="minor">
-            <a:schemeClr val="tx1"/>
-          </a:fontRef>
-        </p:style>
-      </p:cxnSp>
       <p:pic>
         <p:nvPicPr>
-          <p:cNvPr id="5" name="Picture 4" descr="ssod-logo-lavender.png"/>
+          <p:cNvPr id="5" name="Picture 4" descr="ssod-wordmark.png"/>
           <p:cNvPicPr>
             <a:picLocks noChangeAspect="1"/>
           </p:cNvPicPr>
@@ -6036,8 +6097,8 @@
         </p:blipFill>
         <p:spPr>
           <a:xfrm>
-            <a:off x="11040476" y="6163056"/>
-            <a:ext cx="739739" cy="438912"/>
+            <a:off x="10953188" y="6236208"/>
+            <a:ext cx="872747" cy="566928"/>
           </a:xfrm>
           <a:prstGeom prst="rect">
             <a:avLst/>
@@ -6052,8 +6113,8 @@
         </p:nvSpPr>
         <p:spPr>
           <a:xfrm>
-            <a:off x="0" y="1828800"/>
-            <a:ext cx="12191695" cy="2560320"/>
+            <a:off x="0" y="1463040"/>
+            <a:ext cx="12191695" cy="2377440"/>
           </a:xfrm>
           <a:prstGeom prst="rect">
             <a:avLst/>
@@ -6089,7 +6150,7 @@
         </p:nvSpPr>
         <p:spPr>
           <a:xfrm>
-            <a:off x="0" y="4206240"/>
+            <a:off x="0" y="4069080"/>
             <a:ext cx="12191695" cy="457200"/>
           </a:xfrm>
           <a:prstGeom prst="rect">
@@ -6105,7 +6166,7 @@
           <a:p>
             <a:pPr algn="ctr"/>
             <a:r>
-              <a:rPr sz="4800">
+              <a:rPr sz="4400">
                 <a:solidFill>
                   <a:srgbClr val="8A8F98"/>
                 </a:solidFill>
@@ -6113,7 +6174,7 @@
                 <a:ea typeface="Pretendard Light"/>
                 <a:cs typeface="Pretendard Light"/>
               </a:rPr>
-              <a:t>일</a:t>
+              <a:t>참여</a:t>
             </a:r>
           </a:p>
         </p:txBody>
@@ -6126,7 +6187,7 @@
         </p:nvSpPr>
         <p:spPr>
           <a:xfrm>
-            <a:off x="0" y="5212080"/>
+            <a:off x="0" y="4709160"/>
             <a:ext cx="12191695" cy="457200"/>
           </a:xfrm>
           <a:prstGeom prst="rect">
@@ -6144,13 +6205,50 @@
             <a:r>
               <a:rPr sz="2200">
                 <a:solidFill>
-                  <a:srgbClr val="8A8F98"/>
+                  <a:srgbClr val="F7F8F8"/>
                 </a:solidFill>
                 <a:latin typeface="Pretendard Light"/>
                 <a:ea typeface="Pretendard Light"/>
                 <a:cs typeface="Pretendard Light"/>
               </a:rPr>
-              <a:t>카톡 · 노션 · 결재</a:t>
+              <a:t>사람의 상호작용·협업이 일어나는 자리</a:t>
+            </a:r>
+          </a:p>
+        </p:txBody>
+      </p:sp>
+      <p:sp>
+        <p:nvSpPr>
+          <p:cNvPr id="9" name="TextBox 8"/>
+          <p:cNvSpPr txBox="1"/>
+          <p:nvPr/>
+        </p:nvSpPr>
+        <p:spPr>
+          <a:xfrm>
+            <a:off x="0" y="5349240"/>
+            <a:ext cx="12191695" cy="457200"/>
+          </a:xfrm>
+          <a:prstGeom prst="rect">
+            <a:avLst/>
+          </a:prstGeom>
+          <a:noFill/>
+        </p:spPr>
+        <p:txBody>
+          <a:bodyPr wrap="none">
+            <a:spAutoFit/>
+          </a:bodyPr>
+          <a:lstStyle/>
+          <a:p>
+            <a:pPr algn="ctr"/>
+            <a:r>
+              <a:rPr sz="1800">
+                <a:solidFill>
+                  <a:srgbClr val="8A8F98"/>
+                </a:solidFill>
+                <a:latin typeface="Pretendard Light"/>
+                <a:ea typeface="Pretendard Light"/>
+                <a:cs typeface="Pretendard Light"/>
+              </a:rPr>
+              <a:t>카톡 · 노션 · 메일</a:t>
             </a:r>
           </a:p>
         </p:txBody>
@@ -6216,16 +6314,51 @@
           </a:p>
         </p:txBody>
       </p:sp>
-      <p:sp>
-        <p:nvSpPr>
-          <p:cNvPr id="3" name="Rounded Rectangle 2"/>
+      <p:cxnSp>
+        <p:nvCxnSpPr>
+          <p:cNvPr id="3" name="Connector 2"/>
+          <p:cNvCxnSpPr/>
+          <p:nvPr/>
+        </p:nvCxnSpPr>
+        <p:spPr>
+          <a:xfrm>
+            <a:off x="365760" y="6144768"/>
+            <a:ext cx="11460175" cy="0"/>
+          </a:xfrm>
+          <a:prstGeom prst="line">
+            <a:avLst/>
+          </a:prstGeom>
+          <a:ln w="6350">
+            <a:solidFill>
+              <a:srgbClr val="23252A"/>
+            </a:solidFill>
+          </a:ln>
+        </p:spPr>
+        <p:style>
+          <a:lnRef idx="2">
+            <a:schemeClr val="accent1"/>
+          </a:lnRef>
+          <a:fillRef idx="0">
+            <a:schemeClr val="accent1"/>
+          </a:fillRef>
+          <a:effectRef idx="1">
+            <a:schemeClr val="accent1"/>
+          </a:effectRef>
+          <a:fontRef idx="minor">
+            <a:schemeClr val="tx1"/>
+          </a:fontRef>
+        </p:style>
+      </p:cxnSp>
+      <p:sp>
+        <p:nvSpPr>
+          <p:cNvPr id="4" name="Rounded Rectangle 3"/>
           <p:cNvSpPr/>
           <p:nvPr/>
         </p:nvSpPr>
         <p:spPr>
           <a:xfrm>
-            <a:off x="365760" y="320040"/>
-            <a:ext cx="777240" cy="292608"/>
+            <a:off x="365760" y="6373368"/>
+            <a:ext cx="960120" cy="292608"/>
           </a:xfrm>
           <a:prstGeom prst="roundRect">
             <a:avLst>
@@ -6256,7 +6389,7 @@
           </a:fontRef>
         </p:style>
         <p:txBody>
-          <a:bodyPr rtlCol="0" anchor="ctr" lIns="73152" rIns="73152" tIns="0" bIns="0"/>
+          <a:bodyPr rtlCol="0" anchor="ctr" wrap="none" tIns="0" bIns="0"/>
           <a:lstStyle/>
           <a:p>
             <a:pPr algn="ctr"/>
@@ -6274,44 +6407,9 @@
           </a:p>
         </p:txBody>
       </p:sp>
-      <p:cxnSp>
-        <p:nvCxnSpPr>
-          <p:cNvPr id="4" name="Connector 3"/>
-          <p:cNvCxnSpPr/>
-          <p:nvPr/>
-        </p:nvCxnSpPr>
-        <p:spPr>
-          <a:xfrm>
-            <a:off x="365760" y="6263640"/>
-            <a:ext cx="11460175" cy="0"/>
-          </a:xfrm>
-          <a:prstGeom prst="line">
-            <a:avLst/>
-          </a:prstGeom>
-          <a:ln w="6350">
-            <a:solidFill>
-              <a:srgbClr val="23252A"/>
-            </a:solidFill>
-          </a:ln>
-        </p:spPr>
-        <p:style>
-          <a:lnRef idx="2">
-            <a:schemeClr val="accent1"/>
-          </a:lnRef>
-          <a:fillRef idx="0">
-            <a:schemeClr val="accent1"/>
-          </a:fillRef>
-          <a:effectRef idx="1">
-            <a:schemeClr val="accent1"/>
-          </a:effectRef>
-          <a:fontRef idx="minor">
-            <a:schemeClr val="tx1"/>
-          </a:fontRef>
-        </p:style>
-      </p:cxnSp>
       <p:pic>
         <p:nvPicPr>
-          <p:cNvPr id="5" name="Picture 4" descr="ssod-logo-lavender.png"/>
+          <p:cNvPr id="5" name="Picture 4" descr="ssod-wordmark.png"/>
           <p:cNvPicPr>
             <a:picLocks noChangeAspect="1"/>
           </p:cNvPicPr>
@@ -6325,8 +6423,8 @@
         </p:blipFill>
         <p:spPr>
           <a:xfrm>
-            <a:off x="11040476" y="6163056"/>
-            <a:ext cx="739739" cy="438912"/>
+            <a:off x="10953188" y="6236208"/>
+            <a:ext cx="872747" cy="566928"/>
           </a:xfrm>
           <a:prstGeom prst="rect">
             <a:avLst/>
@@ -6341,8 +6439,8 @@
         </p:nvSpPr>
         <p:spPr>
           <a:xfrm>
-            <a:off x="0" y="1828800"/>
-            <a:ext cx="12191695" cy="2560320"/>
+            <a:off x="0" y="1463040"/>
+            <a:ext cx="12191695" cy="2377440"/>
           </a:xfrm>
           <a:prstGeom prst="rect">
             <a:avLst/>
@@ -6378,7 +6476,7 @@
         </p:nvSpPr>
         <p:spPr>
           <a:xfrm>
-            <a:off x="0" y="4206240"/>
+            <a:off x="0" y="4069080"/>
             <a:ext cx="12191695" cy="457200"/>
           </a:xfrm>
           <a:prstGeom prst="rect">
@@ -6394,7 +6492,7 @@
           <a:p>
             <a:pPr algn="ctr"/>
             <a:r>
-              <a:rPr sz="4800">
+              <a:rPr sz="4400">
                 <a:solidFill>
                   <a:srgbClr val="8A8F98"/>
                 </a:solidFill>
@@ -6402,7 +6500,7 @@
                 <a:ea typeface="Pretendard Light"/>
                 <a:cs typeface="Pretendard Light"/>
               </a:rPr>
-              <a:t>판단</a:t>
+              <a:t>지능</a:t>
             </a:r>
           </a:p>
         </p:txBody>
@@ -6415,7 +6513,7 @@
         </p:nvSpPr>
         <p:spPr>
           <a:xfrm>
-            <a:off x="0" y="5212080"/>
+            <a:off x="0" y="4709160"/>
             <a:ext cx="12191695" cy="457200"/>
           </a:xfrm>
           <a:prstGeom prst="rect">
@@ -6433,13 +6531,50 @@
             <a:r>
               <a:rPr sz="2200">
                 <a:solidFill>
-                  <a:srgbClr val="8A8F98"/>
+                  <a:srgbClr val="F7F8F8"/>
                 </a:solidFill>
                 <a:latin typeface="Pretendard Light"/>
                 <a:ea typeface="Pretendard Light"/>
                 <a:cs typeface="Pretendard Light"/>
               </a:rPr>
-              <a:t>사장님 · 대시보드 · AI</a:t>
+              <a:t>여러 기록을 합쳐 AI가 결정을 만드는 자리</a:t>
+            </a:r>
+          </a:p>
+        </p:txBody>
+      </p:sp>
+      <p:sp>
+        <p:nvSpPr>
+          <p:cNvPr id="9" name="TextBox 8"/>
+          <p:cNvSpPr txBox="1"/>
+          <p:nvPr/>
+        </p:nvSpPr>
+        <p:spPr>
+          <a:xfrm>
+            <a:off x="0" y="5349240"/>
+            <a:ext cx="12191695" cy="457200"/>
+          </a:xfrm>
+          <a:prstGeom prst="rect">
+            <a:avLst/>
+          </a:prstGeom>
+          <a:noFill/>
+        </p:spPr>
+        <p:txBody>
+          <a:bodyPr wrap="none">
+            <a:spAutoFit/>
+          </a:bodyPr>
+          <a:lstStyle/>
+          <a:p>
+            <a:pPr algn="ctr"/>
+            <a:r>
+              <a:rPr sz="1800">
+                <a:solidFill>
+                  <a:srgbClr val="8A8F98"/>
+                </a:solidFill>
+                <a:latin typeface="Pretendard Light"/>
+                <a:ea typeface="Pretendard Light"/>
+                <a:cs typeface="Pretendard Light"/>
+              </a:rPr>
+              <a:t>BI · 대시보드 · AI</a:t>
             </a:r>
           </a:p>
         </p:txBody>

</xml_diff>

<commit_message>
WIP(bni-v10): expand to 14 slides — brand wall s6 + s1 geometric BG + pyramid reorder
- Add s6 brand wall (16 partners, 4×4 grid, homepage ClientLogoSection 톤)
  - luminance-based white invert + PIL bbox crop helpers
  - SVG BG rect strip for negative logos (Adobe Illustrator exports)
- Reorder pyramid → s7 (DX·AX → 전체 그림 → SoR/SoE/SoI 정의)
- Redesign s11 +AI (좌측 피라미드 silhouette + 우측 mega punch)
- s1 강화: 4-corner cut mark + lead-in mono + 라벤더 hairline + meta + geometric grid BG
- SoI 어휘: 데이터→데이터·시니어 노하우·사장님 영업 비결
- Builder slide_no 인자화 (slot 삽입 단순화)
- TOTAL_SLIDES 13→14, 모든 page chip 자동 NN/14

Co-Authored-By: Claude Opus 4.7 (1M context) <noreply@anthropic.com>
</commit_message>
<xml_diff>
--- a/lectures/03_sor_framework/BNI_SoR_v10.pptx
+++ b/lectures/03_sor_framework/BNI_SoR_v10.pptx
@@ -18,6 +18,7 @@
     <p:sldId id="266" r:id="rId17"/>
     <p:sldId id="267" r:id="rId18"/>
     <p:sldId id="268" r:id="rId19"/>
+    <p:sldId id="269" r:id="rId20"/>
   </p:sldIdLst>
   <p:sldSz cx="12191695" cy="6858000" type="screen4x3"/>
   <p:notesSz cx="6858000" cy="9144000"/>
@@ -3143,15 +3144,356 @@
           </a:p>
         </p:txBody>
       </p:sp>
-      <p:sp>
-        <p:nvSpPr>
-          <p:cNvPr id="3" name="TextBox 2"/>
+      <p:pic>
+        <p:nvPicPr>
+          <p:cNvPr id="3" name="Picture 2" descr="s1_bg_pattern.png"/>
+          <p:cNvPicPr>
+            <a:picLocks noChangeAspect="1"/>
+          </p:cNvPicPr>
+          <p:nvPr/>
+        </p:nvPicPr>
+        <p:blipFill>
+          <a:blip r:embed="rId2"/>
+          <a:stretch>
+            <a:fillRect/>
+          </a:stretch>
+        </p:blipFill>
+        <p:spPr>
+          <a:xfrm>
+            <a:off x="0" y="0"/>
+            <a:ext cx="12191695" cy="6858000"/>
+          </a:xfrm>
+          <a:prstGeom prst="rect">
+            <a:avLst/>
+          </a:prstGeom>
+        </p:spPr>
+      </p:pic>
+      <p:cxnSp>
+        <p:nvCxnSpPr>
+          <p:cNvPr id="4" name="Connector 3"/>
+          <p:cNvCxnSpPr/>
+          <p:nvPr/>
+        </p:nvCxnSpPr>
+        <p:spPr>
+          <a:xfrm>
+            <a:off x="411480" y="411480"/>
+            <a:ext cx="256032" cy="0"/>
+          </a:xfrm>
+          <a:prstGeom prst="line">
+            <a:avLst/>
+          </a:prstGeom>
+          <a:ln w="9525">
+            <a:solidFill>
+              <a:srgbClr val="62666D"/>
+            </a:solidFill>
+          </a:ln>
+        </p:spPr>
+        <p:style>
+          <a:lnRef idx="2">
+            <a:schemeClr val="accent1"/>
+          </a:lnRef>
+          <a:fillRef idx="0">
+            <a:schemeClr val="accent1"/>
+          </a:fillRef>
+          <a:effectRef idx="1">
+            <a:schemeClr val="accent1"/>
+          </a:effectRef>
+          <a:fontRef idx="minor">
+            <a:schemeClr val="tx1"/>
+          </a:fontRef>
+        </p:style>
+      </p:cxnSp>
+      <p:cxnSp>
+        <p:nvCxnSpPr>
+          <p:cNvPr id="5" name="Connector 4"/>
+          <p:cNvCxnSpPr/>
+          <p:nvPr/>
+        </p:nvCxnSpPr>
+        <p:spPr>
+          <a:xfrm>
+            <a:off x="411480" y="411480"/>
+            <a:ext cx="0" cy="256032"/>
+          </a:xfrm>
+          <a:prstGeom prst="line">
+            <a:avLst/>
+          </a:prstGeom>
+          <a:ln w="9525">
+            <a:solidFill>
+              <a:srgbClr val="62666D"/>
+            </a:solidFill>
+          </a:ln>
+        </p:spPr>
+        <p:style>
+          <a:lnRef idx="2">
+            <a:schemeClr val="accent1"/>
+          </a:lnRef>
+          <a:fillRef idx="0">
+            <a:schemeClr val="accent1"/>
+          </a:fillRef>
+          <a:effectRef idx="1">
+            <a:schemeClr val="accent1"/>
+          </a:effectRef>
+          <a:fontRef idx="minor">
+            <a:schemeClr val="tx1"/>
+          </a:fontRef>
+        </p:style>
+      </p:cxnSp>
+      <p:cxnSp>
+        <p:nvCxnSpPr>
+          <p:cNvPr id="6" name="Connector 5"/>
+          <p:cNvCxnSpPr/>
+          <p:nvPr/>
+        </p:nvCxnSpPr>
+        <p:spPr>
+          <a:xfrm flipH="1">
+            <a:off x="11524183" y="411480"/>
+            <a:ext cx="256032" cy="0"/>
+          </a:xfrm>
+          <a:prstGeom prst="line">
+            <a:avLst/>
+          </a:prstGeom>
+          <a:ln w="9525">
+            <a:solidFill>
+              <a:srgbClr val="62666D"/>
+            </a:solidFill>
+          </a:ln>
+        </p:spPr>
+        <p:style>
+          <a:lnRef idx="2">
+            <a:schemeClr val="accent1"/>
+          </a:lnRef>
+          <a:fillRef idx="0">
+            <a:schemeClr val="accent1"/>
+          </a:fillRef>
+          <a:effectRef idx="1">
+            <a:schemeClr val="accent1"/>
+          </a:effectRef>
+          <a:fontRef idx="minor">
+            <a:schemeClr val="tx1"/>
+          </a:fontRef>
+        </p:style>
+      </p:cxnSp>
+      <p:cxnSp>
+        <p:nvCxnSpPr>
+          <p:cNvPr id="7" name="Connector 6"/>
+          <p:cNvCxnSpPr/>
+          <p:nvPr/>
+        </p:nvCxnSpPr>
+        <p:spPr>
+          <a:xfrm>
+            <a:off x="11780215" y="411480"/>
+            <a:ext cx="0" cy="256032"/>
+          </a:xfrm>
+          <a:prstGeom prst="line">
+            <a:avLst/>
+          </a:prstGeom>
+          <a:ln w="9525">
+            <a:solidFill>
+              <a:srgbClr val="62666D"/>
+            </a:solidFill>
+          </a:ln>
+        </p:spPr>
+        <p:style>
+          <a:lnRef idx="2">
+            <a:schemeClr val="accent1"/>
+          </a:lnRef>
+          <a:fillRef idx="0">
+            <a:schemeClr val="accent1"/>
+          </a:fillRef>
+          <a:effectRef idx="1">
+            <a:schemeClr val="accent1"/>
+          </a:effectRef>
+          <a:fontRef idx="minor">
+            <a:schemeClr val="tx1"/>
+          </a:fontRef>
+        </p:style>
+      </p:cxnSp>
+      <p:cxnSp>
+        <p:nvCxnSpPr>
+          <p:cNvPr id="8" name="Connector 7"/>
+          <p:cNvCxnSpPr/>
+          <p:nvPr/>
+        </p:nvCxnSpPr>
+        <p:spPr>
+          <a:xfrm>
+            <a:off x="411480" y="6446520"/>
+            <a:ext cx="256032" cy="0"/>
+          </a:xfrm>
+          <a:prstGeom prst="line">
+            <a:avLst/>
+          </a:prstGeom>
+          <a:ln w="9525">
+            <a:solidFill>
+              <a:srgbClr val="62666D"/>
+            </a:solidFill>
+          </a:ln>
+        </p:spPr>
+        <p:style>
+          <a:lnRef idx="2">
+            <a:schemeClr val="accent1"/>
+          </a:lnRef>
+          <a:fillRef idx="0">
+            <a:schemeClr val="accent1"/>
+          </a:fillRef>
+          <a:effectRef idx="1">
+            <a:schemeClr val="accent1"/>
+          </a:effectRef>
+          <a:fontRef idx="minor">
+            <a:schemeClr val="tx1"/>
+          </a:fontRef>
+        </p:style>
+      </p:cxnSp>
+      <p:cxnSp>
+        <p:nvCxnSpPr>
+          <p:cNvPr id="9" name="Connector 8"/>
+          <p:cNvCxnSpPr/>
+          <p:nvPr/>
+        </p:nvCxnSpPr>
+        <p:spPr>
+          <a:xfrm flipV="1">
+            <a:off x="411480" y="6190488"/>
+            <a:ext cx="0" cy="256032"/>
+          </a:xfrm>
+          <a:prstGeom prst="line">
+            <a:avLst/>
+          </a:prstGeom>
+          <a:ln w="9525">
+            <a:solidFill>
+              <a:srgbClr val="62666D"/>
+            </a:solidFill>
+          </a:ln>
+        </p:spPr>
+        <p:style>
+          <a:lnRef idx="2">
+            <a:schemeClr val="accent1"/>
+          </a:lnRef>
+          <a:fillRef idx="0">
+            <a:schemeClr val="accent1"/>
+          </a:fillRef>
+          <a:effectRef idx="1">
+            <a:schemeClr val="accent1"/>
+          </a:effectRef>
+          <a:fontRef idx="minor">
+            <a:schemeClr val="tx1"/>
+          </a:fontRef>
+        </p:style>
+      </p:cxnSp>
+      <p:cxnSp>
+        <p:nvCxnSpPr>
+          <p:cNvPr id="10" name="Connector 9"/>
+          <p:cNvCxnSpPr/>
+          <p:nvPr/>
+        </p:nvCxnSpPr>
+        <p:spPr>
+          <a:xfrm flipH="1">
+            <a:off x="11524183" y="6446520"/>
+            <a:ext cx="256032" cy="0"/>
+          </a:xfrm>
+          <a:prstGeom prst="line">
+            <a:avLst/>
+          </a:prstGeom>
+          <a:ln w="9525">
+            <a:solidFill>
+              <a:srgbClr val="62666D"/>
+            </a:solidFill>
+          </a:ln>
+        </p:spPr>
+        <p:style>
+          <a:lnRef idx="2">
+            <a:schemeClr val="accent1"/>
+          </a:lnRef>
+          <a:fillRef idx="0">
+            <a:schemeClr val="accent1"/>
+          </a:fillRef>
+          <a:effectRef idx="1">
+            <a:schemeClr val="accent1"/>
+          </a:effectRef>
+          <a:fontRef idx="minor">
+            <a:schemeClr val="tx1"/>
+          </a:fontRef>
+        </p:style>
+      </p:cxnSp>
+      <p:cxnSp>
+        <p:nvCxnSpPr>
+          <p:cNvPr id="11" name="Connector 10"/>
+          <p:cNvCxnSpPr/>
+          <p:nvPr/>
+        </p:nvCxnSpPr>
+        <p:spPr>
+          <a:xfrm flipV="1">
+            <a:off x="11780215" y="6190488"/>
+            <a:ext cx="0" cy="256032"/>
+          </a:xfrm>
+          <a:prstGeom prst="line">
+            <a:avLst/>
+          </a:prstGeom>
+          <a:ln w="9525">
+            <a:solidFill>
+              <a:srgbClr val="62666D"/>
+            </a:solidFill>
+          </a:ln>
+        </p:spPr>
+        <p:style>
+          <a:lnRef idx="2">
+            <a:schemeClr val="accent1"/>
+          </a:lnRef>
+          <a:fillRef idx="0">
+            <a:schemeClr val="accent1"/>
+          </a:fillRef>
+          <a:effectRef idx="1">
+            <a:schemeClr val="accent1"/>
+          </a:effectRef>
+          <a:fontRef idx="minor">
+            <a:schemeClr val="tx1"/>
+          </a:fontRef>
+        </p:style>
+      </p:cxnSp>
+      <p:sp>
+        <p:nvSpPr>
+          <p:cNvPr id="12" name="TextBox 11"/>
           <p:cNvSpPr txBox="1"/>
           <p:nvPr/>
         </p:nvSpPr>
         <p:spPr>
           <a:xfrm>
-            <a:off x="0" y="2194560"/>
+            <a:off x="0" y="1737360"/>
+            <a:ext cx="12191695" cy="365760"/>
+          </a:xfrm>
+          <a:prstGeom prst="rect">
+            <a:avLst/>
+          </a:prstGeom>
+          <a:noFill/>
+        </p:spPr>
+        <p:txBody>
+          <a:bodyPr wrap="none">
+            <a:spAutoFit/>
+          </a:bodyPr>
+          <a:lstStyle/>
+          <a:p>
+            <a:pPr algn="ctr"/>
+            <a:r>
+              <a:rPr sz="1100" spc="242">
+                <a:solidFill>
+                  <a:srgbClr val="62666D"/>
+                </a:solidFill>
+                <a:latin typeface="SF Mono"/>
+                <a:ea typeface="SF Mono"/>
+                <a:cs typeface="SF Mono"/>
+              </a:rPr>
+              <a:t>03  ·  SOR FRAMEWORK</a:t>
+            </a:r>
+          </a:p>
+        </p:txBody>
+      </p:sp>
+      <p:sp>
+        <p:nvSpPr>
+          <p:cNvPr id="13" name="TextBox 12"/>
+          <p:cNvSpPr txBox="1"/>
+          <p:nvPr/>
+        </p:nvSpPr>
+        <p:spPr>
+          <a:xfrm>
+            <a:off x="0" y="2331720"/>
             <a:ext cx="12191695" cy="457200"/>
           </a:xfrm>
           <a:prstGeom prst="rect">
@@ -3182,13 +3524,13 @@
       </p:sp>
       <p:sp>
         <p:nvSpPr>
-          <p:cNvPr id="4" name="TextBox 3"/>
+          <p:cNvPr id="14" name="TextBox 13"/>
           <p:cNvSpPr txBox="1"/>
           <p:nvPr/>
         </p:nvSpPr>
         <p:spPr>
           <a:xfrm>
-            <a:off x="0" y="2788920"/>
+            <a:off x="0" y="2926080"/>
             <a:ext cx="12191695" cy="1463040"/>
           </a:xfrm>
           <a:prstGeom prst="rect">
@@ -3217,23 +3559,58 @@
           </a:p>
         </p:txBody>
       </p:sp>
+      <p:cxnSp>
+        <p:nvCxnSpPr>
+          <p:cNvPr id="15" name="Connector 14"/>
+          <p:cNvCxnSpPr/>
+          <p:nvPr/>
+        </p:nvCxnSpPr>
+        <p:spPr>
+          <a:xfrm>
+            <a:off x="5684367.5" y="4617720"/>
+            <a:ext cx="822960.0" cy="0"/>
+          </a:xfrm>
+          <a:prstGeom prst="line">
+            <a:avLst/>
+          </a:prstGeom>
+          <a:ln w="19050">
+            <a:solidFill>
+              <a:srgbClr val="5E6AD2"/>
+            </a:solidFill>
+          </a:ln>
+        </p:spPr>
+        <p:style>
+          <a:lnRef idx="2">
+            <a:schemeClr val="accent1"/>
+          </a:lnRef>
+          <a:fillRef idx="0">
+            <a:schemeClr val="accent1"/>
+          </a:fillRef>
+          <a:effectRef idx="1">
+            <a:schemeClr val="accent1"/>
+          </a:effectRef>
+          <a:fontRef idx="minor">
+            <a:schemeClr val="tx1"/>
+          </a:fontRef>
+        </p:style>
+      </p:cxnSp>
       <p:pic>
         <p:nvPicPr>
-          <p:cNvPr id="5" name="Picture 4" descr="ssod-wordmark.png"/>
+          <p:cNvPr id="16" name="Picture 15" descr="ssod-wordmark.png"/>
           <p:cNvPicPr>
             <a:picLocks noChangeAspect="1"/>
           </p:cNvPicPr>
           <p:nvPr/>
         </p:nvPicPr>
         <p:blipFill>
-          <a:blip r:embed="rId2"/>
+          <a:blip r:embed="rId3"/>
           <a:stretch>
             <a:fillRect/>
           </a:stretch>
         </p:blipFill>
         <p:spPr>
           <a:xfrm>
-            <a:off x="5603168" y="4846320"/>
+            <a:off x="5603168" y="5074920"/>
             <a:ext cx="985359" cy="640080"/>
           </a:xfrm>
           <a:prstGeom prst="rect">
@@ -3241,6 +3618,43 @@
           </a:prstGeom>
         </p:spPr>
       </p:pic>
+      <p:sp>
+        <p:nvSpPr>
+          <p:cNvPr id="17" name="TextBox 16"/>
+          <p:cNvSpPr txBox="1"/>
+          <p:nvPr/>
+        </p:nvSpPr>
+        <p:spPr>
+          <a:xfrm>
+            <a:off x="0" y="5989320"/>
+            <a:ext cx="12191695" cy="365760"/>
+          </a:xfrm>
+          <a:prstGeom prst="rect">
+            <a:avLst/>
+          </a:prstGeom>
+          <a:noFill/>
+        </p:spPr>
+        <p:txBody>
+          <a:bodyPr wrap="none">
+            <a:spAutoFit/>
+          </a:bodyPr>
+          <a:lstStyle/>
+          <a:p>
+            <a:pPr algn="ctr"/>
+            <a:r>
+              <a:rPr sz="1000" spc="180">
+                <a:solidFill>
+                  <a:srgbClr val="62666D"/>
+                </a:solidFill>
+                <a:latin typeface="SF Mono"/>
+                <a:ea typeface="SF Mono"/>
+                <a:cs typeface="SF Mono"/>
+              </a:rPr>
+              <a:t>BNI K-CHAPTER   ·   2026.05.27   ·   김지명</a:t>
+            </a:r>
+          </a:p>
+        </p:txBody>
+      </p:sp>
     </p:spTree>
   </p:cSld>
   <p:clrMapOvr>
@@ -3390,7 +3804,7 @@
                 <a:ea typeface="SF Mono"/>
                 <a:cs typeface="SF Mono"/>
               </a:rPr>
-              <a:t>10 / 13</a:t>
+              <a:t>10 / 14</a:t>
             </a:r>
           </a:p>
         </p:txBody>
@@ -3421,119 +3835,29 @@
       </p:pic>
       <p:sp>
         <p:nvSpPr>
-          <p:cNvPr id="6" name="Rounded Rectangle 5"/>
-          <p:cNvSpPr/>
-          <p:nvPr/>
-        </p:nvSpPr>
-        <p:spPr>
-          <a:xfrm>
-            <a:off x="3352647" y="1234440"/>
-            <a:ext cx="5486400" cy="1051560"/>
-          </a:xfrm>
-          <a:prstGeom prst="roundRect">
-            <a:avLst>
-              <a:gd name="adj" fmla="val 10000"/>
-            </a:avLst>
-          </a:prstGeom>
-          <a:solidFill>
-            <a:srgbClr val="0F1011"/>
-          </a:solidFill>
-          <a:ln w="12700">
-            <a:solidFill>
-              <a:srgbClr val="23252A"/>
-            </a:solidFill>
-          </a:ln>
-        </p:spPr>
-        <p:style>
-          <a:lnRef idx="1">
-            <a:schemeClr val="accent1"/>
-          </a:lnRef>
-          <a:fillRef idx="3">
-            <a:schemeClr val="accent1"/>
-          </a:fillRef>
-          <a:effectRef idx="2">
-            <a:schemeClr val="accent1"/>
-          </a:effectRef>
-          <a:fontRef idx="minor">
-            <a:schemeClr val="lt1"/>
-          </a:fontRef>
-        </p:style>
-        <p:txBody>
-          <a:bodyPr rtlCol="0" anchor="ctr" lIns="365760" rIns="365760"/>
+          <p:cNvPr id="6" name="TextBox 5"/>
+          <p:cNvSpPr txBox="1"/>
+          <p:nvPr/>
+        </p:nvSpPr>
+        <p:spPr>
+          <a:xfrm>
+            <a:off x="0" y="1463040"/>
+            <a:ext cx="12191695" cy="2377440"/>
+          </a:xfrm>
+          <a:prstGeom prst="rect">
+            <a:avLst/>
+          </a:prstGeom>
+          <a:noFill/>
+        </p:spPr>
+        <p:txBody>
+          <a:bodyPr wrap="none" lIns="0" rIns="0" tIns="0" bIns="0" anchor="ctr">
+            <a:spAutoFit/>
+          </a:bodyPr>
           <a:lstStyle/>
           <a:p>
             <a:pPr algn="ctr"/>
             <a:r>
-              <a:rPr sz="5400">
-                <a:solidFill>
-                  <a:srgbClr val="F7F8F8"/>
-                </a:solidFill>
-                <a:latin typeface="Pretendard Black"/>
-                <a:ea typeface="Pretendard Black"/>
-                <a:cs typeface="Pretendard Black"/>
-              </a:rPr>
-              <a:t>SoI</a:t>
-            </a:r>
-            <a:r>
-              <a:rPr sz="2800">
-                <a:solidFill>
-                  <a:srgbClr val="8A8F98"/>
-                </a:solidFill>
-                <a:latin typeface="Pretendard Light"/>
-                <a:ea typeface="Pretendard Light"/>
-                <a:cs typeface="Pretendard Light"/>
-              </a:rPr>
-              <a:t>    지능</a:t>
-            </a:r>
-          </a:p>
-        </p:txBody>
-      </p:sp>
-      <p:sp>
-        <p:nvSpPr>
-          <p:cNvPr id="7" name="Rounded Rectangle 6"/>
-          <p:cNvSpPr/>
-          <p:nvPr/>
-        </p:nvSpPr>
-        <p:spPr>
-          <a:xfrm>
-            <a:off x="3352647" y="2697480"/>
-            <a:ext cx="5486400" cy="1051560"/>
-          </a:xfrm>
-          <a:prstGeom prst="roundRect">
-            <a:avLst>
-              <a:gd name="adj" fmla="val 10000"/>
-            </a:avLst>
-          </a:prstGeom>
-          <a:solidFill>
-            <a:srgbClr val="0F1011"/>
-          </a:solidFill>
-          <a:ln w="12700">
-            <a:solidFill>
-              <a:srgbClr val="23252A"/>
-            </a:solidFill>
-          </a:ln>
-        </p:spPr>
-        <p:style>
-          <a:lnRef idx="1">
-            <a:schemeClr val="accent1"/>
-          </a:lnRef>
-          <a:fillRef idx="3">
-            <a:schemeClr val="accent1"/>
-          </a:fillRef>
-          <a:effectRef idx="2">
-            <a:schemeClr val="accent1"/>
-          </a:effectRef>
-          <a:fontRef idx="minor">
-            <a:schemeClr val="lt1"/>
-          </a:fontRef>
-        </p:style>
-        <p:txBody>
-          <a:bodyPr rtlCol="0" anchor="ctr" lIns="365760" rIns="365760"/>
-          <a:lstStyle/>
-          <a:p>
-            <a:pPr algn="ctr"/>
-            <a:r>
-              <a:rPr sz="5400">
+              <a:rPr sz="20000" spc="-700">
                 <a:solidFill>
                   <a:srgbClr val="F7F8F8"/>
                 </a:solidFill>
@@ -3543,8 +3867,34 @@
               </a:rPr>
               <a:t>SoE</a:t>
             </a:r>
-            <a:r>
-              <a:rPr sz="2800">
+          </a:p>
+        </p:txBody>
+      </p:sp>
+      <p:sp>
+        <p:nvSpPr>
+          <p:cNvPr id="7" name="TextBox 6"/>
+          <p:cNvSpPr txBox="1"/>
+          <p:nvPr/>
+        </p:nvSpPr>
+        <p:spPr>
+          <a:xfrm>
+            <a:off x="0" y="4069080"/>
+            <a:ext cx="12191695" cy="457200"/>
+          </a:xfrm>
+          <a:prstGeom prst="rect">
+            <a:avLst/>
+          </a:prstGeom>
+          <a:noFill/>
+        </p:spPr>
+        <p:txBody>
+          <a:bodyPr wrap="none">
+            <a:spAutoFit/>
+          </a:bodyPr>
+          <a:lstStyle/>
+          <a:p>
+            <a:pPr algn="ctr"/>
+            <a:r>
+              <a:rPr sz="4400">
                 <a:solidFill>
                   <a:srgbClr val="8A8F98"/>
                 </a:solidFill>
@@ -3552,7 +3902,7 @@
                 <a:ea typeface="Pretendard Light"/>
                 <a:cs typeface="Pretendard Light"/>
               </a:rPr>
-              <a:t>    참여</a:t>
+              <a:t>참여</a:t>
             </a:r>
           </a:p>
         </p:txBody>
@@ -3565,8 +3915,8 @@
         </p:nvSpPr>
         <p:spPr>
           <a:xfrm>
-            <a:off x="3352647" y="2331720"/>
-            <a:ext cx="5486400" cy="320040"/>
+            <a:off x="0" y="4709160"/>
+            <a:ext cx="12191695" cy="457200"/>
           </a:xfrm>
           <a:prstGeom prst="rect">
             <a:avLst/>
@@ -3581,76 +3931,44 @@
           <a:p>
             <a:pPr algn="ctr"/>
             <a:r>
-              <a:rPr sz="2800">
-                <a:solidFill>
-                  <a:srgbClr val="5E6AD2"/>
-                </a:solidFill>
-                <a:latin typeface="Pretendard Black"/>
-                <a:ea typeface="Pretendard Black"/>
-                <a:cs typeface="Pretendard Black"/>
-              </a:rPr>
-              <a:t>↑</a:t>
-            </a:r>
-          </a:p>
-        </p:txBody>
-      </p:sp>
-      <p:sp>
-        <p:nvSpPr>
-          <p:cNvPr id="9" name="Rounded Rectangle 8"/>
-          <p:cNvSpPr/>
-          <p:nvPr/>
-        </p:nvSpPr>
-        <p:spPr>
-          <a:xfrm>
-            <a:off x="3352647" y="4160520"/>
-            <a:ext cx="5486400" cy="1051560"/>
-          </a:xfrm>
-          <a:prstGeom prst="roundRect">
-            <a:avLst>
-              <a:gd name="adj" fmla="val 10000"/>
-            </a:avLst>
-          </a:prstGeom>
-          <a:solidFill>
-            <a:srgbClr val="0F1011"/>
-          </a:solidFill>
-          <a:ln w="12700">
-            <a:solidFill>
-              <a:srgbClr val="23252A"/>
-            </a:solidFill>
-          </a:ln>
-        </p:spPr>
-        <p:style>
-          <a:lnRef idx="1">
-            <a:schemeClr val="accent1"/>
-          </a:lnRef>
-          <a:fillRef idx="3">
-            <a:schemeClr val="accent1"/>
-          </a:fillRef>
-          <a:effectRef idx="2">
-            <a:schemeClr val="accent1"/>
-          </a:effectRef>
-          <a:fontRef idx="minor">
-            <a:schemeClr val="lt1"/>
-          </a:fontRef>
-        </p:style>
-        <p:txBody>
-          <a:bodyPr rtlCol="0" anchor="ctr" lIns="365760" rIns="365760"/>
-          <a:lstStyle/>
-          <a:p>
-            <a:pPr algn="ctr"/>
-            <a:r>
-              <a:rPr sz="5400">
+              <a:rPr sz="2200">
                 <a:solidFill>
                   <a:srgbClr val="F7F8F8"/>
                 </a:solidFill>
-                <a:latin typeface="Pretendard Black"/>
-                <a:ea typeface="Pretendard Black"/>
-                <a:cs typeface="Pretendard Black"/>
+                <a:latin typeface="Pretendard Light"/>
+                <a:ea typeface="Pretendard Light"/>
+                <a:cs typeface="Pretendard Light"/>
               </a:rPr>
-              <a:t>SoR</a:t>
-            </a:r>
-            <a:r>
-              <a:rPr sz="2800">
+              <a:t>사람의 상호작용·협업이 일어나는 자리</a:t>
+            </a:r>
+          </a:p>
+        </p:txBody>
+      </p:sp>
+      <p:sp>
+        <p:nvSpPr>
+          <p:cNvPr id="9" name="TextBox 8"/>
+          <p:cNvSpPr txBox="1"/>
+          <p:nvPr/>
+        </p:nvSpPr>
+        <p:spPr>
+          <a:xfrm>
+            <a:off x="0" y="5349240"/>
+            <a:ext cx="12191695" cy="457200"/>
+          </a:xfrm>
+          <a:prstGeom prst="rect">
+            <a:avLst/>
+          </a:prstGeom>
+          <a:noFill/>
+        </p:spPr>
+        <p:txBody>
+          <a:bodyPr wrap="none">
+            <a:spAutoFit/>
+          </a:bodyPr>
+          <a:lstStyle/>
+          <a:p>
+            <a:pPr algn="ctr"/>
+            <a:r>
+              <a:rPr sz="1800">
                 <a:solidFill>
                   <a:srgbClr val="8A8F98"/>
                 </a:solidFill>
@@ -3658,44 +3976,7 @@
                 <a:ea typeface="Pretendard Light"/>
                 <a:cs typeface="Pretendard Light"/>
               </a:rPr>
-              <a:t>    기록</a:t>
-            </a:r>
-          </a:p>
-        </p:txBody>
-      </p:sp>
-      <p:sp>
-        <p:nvSpPr>
-          <p:cNvPr id="10" name="TextBox 9"/>
-          <p:cNvSpPr txBox="1"/>
-          <p:nvPr/>
-        </p:nvSpPr>
-        <p:spPr>
-          <a:xfrm>
-            <a:off x="3352647" y="3794760"/>
-            <a:ext cx="5486400" cy="320040"/>
-          </a:xfrm>
-          <a:prstGeom prst="rect">
-            <a:avLst/>
-          </a:prstGeom>
-          <a:noFill/>
-        </p:spPr>
-        <p:txBody>
-          <a:bodyPr wrap="none">
-            <a:spAutoFit/>
-          </a:bodyPr>
-          <a:lstStyle/>
-          <a:p>
-            <a:pPr algn="ctr"/>
-            <a:r>
-              <a:rPr sz="2800">
-                <a:solidFill>
-                  <a:srgbClr val="5E6AD2"/>
-                </a:solidFill>
-                <a:latin typeface="Pretendard Black"/>
-                <a:ea typeface="Pretendard Black"/>
-                <a:cs typeface="Pretendard Black"/>
-              </a:rPr>
-              <a:t>↑</a:t>
+              <a:t>카톡 · 노션 · 메일</a:t>
             </a:r>
           </a:p>
         </p:txBody>
@@ -3849,7 +4130,7 @@
                 <a:ea typeface="SF Mono"/>
                 <a:cs typeface="SF Mono"/>
               </a:rPr>
-              <a:t>11 / 13</a:t>
+              <a:t>11 / 14</a:t>
             </a:r>
           </a:p>
         </p:txBody>
@@ -3886,7 +4167,44 @@
         </p:nvSpPr>
         <p:spPr>
           <a:xfrm>
-            <a:off x="0" y="1828800"/>
+            <a:off x="0" y="1463040"/>
+            <a:ext cx="12191695" cy="2377440"/>
+          </a:xfrm>
+          <a:prstGeom prst="rect">
+            <a:avLst/>
+          </a:prstGeom>
+          <a:noFill/>
+        </p:spPr>
+        <p:txBody>
+          <a:bodyPr wrap="none" lIns="0" rIns="0" tIns="0" bIns="0" anchor="ctr">
+            <a:spAutoFit/>
+          </a:bodyPr>
+          <a:lstStyle/>
+          <a:p>
+            <a:pPr algn="ctr"/>
+            <a:r>
+              <a:rPr sz="20000" spc="-700">
+                <a:solidFill>
+                  <a:srgbClr val="F7F8F8"/>
+                </a:solidFill>
+                <a:latin typeface="Pretendard Black"/>
+                <a:ea typeface="Pretendard Black"/>
+                <a:cs typeface="Pretendard Black"/>
+              </a:rPr>
+              <a:t>SoI</a:t>
+            </a:r>
+          </a:p>
+        </p:txBody>
+      </p:sp>
+      <p:sp>
+        <p:nvSpPr>
+          <p:cNvPr id="7" name="TextBox 6"/>
+          <p:cNvSpPr txBox="1"/>
+          <p:nvPr/>
+        </p:nvSpPr>
+        <p:spPr>
+          <a:xfrm>
+            <a:off x="0" y="4069080"/>
             <a:ext cx="12191695" cy="457200"/>
           </a:xfrm>
           <a:prstGeom prst="rect">
@@ -3902,7 +4220,7 @@
           <a:p>
             <a:pPr algn="ctr"/>
             <a:r>
-              <a:rPr sz="2800">
+              <a:rPr sz="4400">
                 <a:solidFill>
                   <a:srgbClr val="8A8F98"/>
                 </a:solidFill>
@@ -3910,21 +4228,21 @@
                 <a:ea typeface="Pretendard Light"/>
                 <a:cs typeface="Pretendard Light"/>
               </a:rPr>
-              <a:t>그 위에</a:t>
-            </a:r>
-          </a:p>
-        </p:txBody>
-      </p:sp>
-      <p:sp>
-        <p:nvSpPr>
-          <p:cNvPr id="7" name="TextBox 6"/>
+              <a:t>지능</a:t>
+            </a:r>
+          </a:p>
+        </p:txBody>
+      </p:sp>
+      <p:sp>
+        <p:nvSpPr>
+          <p:cNvPr id="8" name="TextBox 7"/>
           <p:cNvSpPr txBox="1"/>
           <p:nvPr/>
         </p:nvSpPr>
         <p:spPr>
           <a:xfrm>
-            <a:off x="0" y="2743200"/>
-            <a:ext cx="12191695" cy="2743200"/>
+            <a:off x="0" y="4709160"/>
+            <a:ext cx="12191695" cy="457200"/>
           </a:xfrm>
           <a:prstGeom prst="rect">
             <a:avLst/>
@@ -3932,22 +4250,59 @@
           <a:noFill/>
         </p:spPr>
         <p:txBody>
-          <a:bodyPr wrap="none" lIns="0" rIns="0" tIns="0" bIns="0" anchor="ctr">
+          <a:bodyPr wrap="none">
             <a:spAutoFit/>
           </a:bodyPr>
           <a:lstStyle/>
           <a:p>
             <a:pPr algn="ctr"/>
             <a:r>
-              <a:rPr sz="24000" spc="-840">
+              <a:rPr sz="2200">
                 <a:solidFill>
                   <a:srgbClr val="F7F8F8"/>
                 </a:solidFill>
-                <a:latin typeface="Pretendard Black"/>
-                <a:ea typeface="Pretendard Black"/>
-                <a:cs typeface="Pretendard Black"/>
+                <a:latin typeface="Pretendard Light"/>
+                <a:ea typeface="Pretendard Light"/>
+                <a:cs typeface="Pretendard Light"/>
               </a:rPr>
-              <a:t>+ AI</a:t>
+              <a:t>여러 데이터를 합쳐 데이터를 만드는 자리</a:t>
+            </a:r>
+          </a:p>
+        </p:txBody>
+      </p:sp>
+      <p:sp>
+        <p:nvSpPr>
+          <p:cNvPr id="9" name="TextBox 8"/>
+          <p:cNvSpPr txBox="1"/>
+          <p:nvPr/>
+        </p:nvSpPr>
+        <p:spPr>
+          <a:xfrm>
+            <a:off x="0" y="5349240"/>
+            <a:ext cx="12191695" cy="457200"/>
+          </a:xfrm>
+          <a:prstGeom prst="rect">
+            <a:avLst/>
+          </a:prstGeom>
+          <a:noFill/>
+        </p:spPr>
+        <p:txBody>
+          <a:bodyPr wrap="none">
+            <a:spAutoFit/>
+          </a:bodyPr>
+          <a:lstStyle/>
+          <a:p>
+            <a:pPr algn="ctr"/>
+            <a:r>
+              <a:rPr sz="1800">
+                <a:solidFill>
+                  <a:srgbClr val="8A8F98"/>
+                </a:solidFill>
+                <a:latin typeface="Pretendard Light"/>
+                <a:ea typeface="Pretendard Light"/>
+                <a:cs typeface="Pretendard Light"/>
+              </a:rPr>
+              <a:t>시니어의 노하우 · 사장님의 영업 비결 등</a:t>
             </a:r>
           </a:p>
         </p:txBody>
@@ -4013,16 +4368,194 @@
           </a:p>
         </p:txBody>
       </p:sp>
-      <p:sp>
-        <p:nvSpPr>
-          <p:cNvPr id="3" name="TextBox 2"/>
+      <p:cxnSp>
+        <p:nvCxnSpPr>
+          <p:cNvPr id="3" name="Connector 2"/>
+          <p:cNvCxnSpPr/>
+          <p:nvPr/>
+        </p:nvCxnSpPr>
+        <p:spPr>
+          <a:xfrm>
+            <a:off x="365760" y="6144768"/>
+            <a:ext cx="11460175" cy="0"/>
+          </a:xfrm>
+          <a:prstGeom prst="line">
+            <a:avLst/>
+          </a:prstGeom>
+          <a:ln w="6350">
+            <a:solidFill>
+              <a:srgbClr val="23252A"/>
+            </a:solidFill>
+          </a:ln>
+        </p:spPr>
+        <p:style>
+          <a:lnRef idx="2">
+            <a:schemeClr val="accent1"/>
+          </a:lnRef>
+          <a:fillRef idx="0">
+            <a:schemeClr val="accent1"/>
+          </a:fillRef>
+          <a:effectRef idx="1">
+            <a:schemeClr val="accent1"/>
+          </a:effectRef>
+          <a:fontRef idx="minor">
+            <a:schemeClr val="tx1"/>
+          </a:fontRef>
+        </p:style>
+      </p:cxnSp>
+      <p:sp>
+        <p:nvSpPr>
+          <p:cNvPr id="4" name="Rounded Rectangle 3"/>
+          <p:cNvSpPr/>
+          <p:nvPr/>
+        </p:nvSpPr>
+        <p:spPr>
+          <a:xfrm>
+            <a:off x="365760" y="6373368"/>
+            <a:ext cx="960120" cy="292608"/>
+          </a:xfrm>
+          <a:prstGeom prst="roundRect">
+            <a:avLst>
+              <a:gd name="adj" fmla="val 50000"/>
+            </a:avLst>
+          </a:prstGeom>
+          <a:solidFill>
+            <a:srgbClr val="0F1011"/>
+          </a:solidFill>
+          <a:ln w="9525">
+            <a:solidFill>
+              <a:srgbClr val="23252A"/>
+            </a:solidFill>
+          </a:ln>
+        </p:spPr>
+        <p:style>
+          <a:lnRef idx="1">
+            <a:schemeClr val="accent1"/>
+          </a:lnRef>
+          <a:fillRef idx="3">
+            <a:schemeClr val="accent1"/>
+          </a:fillRef>
+          <a:effectRef idx="2">
+            <a:schemeClr val="accent1"/>
+          </a:effectRef>
+          <a:fontRef idx="minor">
+            <a:schemeClr val="lt1"/>
+          </a:fontRef>
+        </p:style>
+        <p:txBody>
+          <a:bodyPr rtlCol="0" anchor="ctr" wrap="none" tIns="0" bIns="0"/>
+          <a:lstStyle/>
+          <a:p>
+            <a:pPr algn="ctr"/>
+            <a:r>
+              <a:rPr sz="1000" spc="40">
+                <a:solidFill>
+                  <a:srgbClr val="8A8F98"/>
+                </a:solidFill>
+                <a:latin typeface="SF Mono"/>
+                <a:ea typeface="SF Mono"/>
+                <a:cs typeface="SF Mono"/>
+              </a:rPr>
+              <a:t>12 / 14</a:t>
+            </a:r>
+          </a:p>
+        </p:txBody>
+      </p:sp>
+      <p:pic>
+        <p:nvPicPr>
+          <p:cNvPr id="5" name="Picture 4" descr="ssod-wordmark.png"/>
+          <p:cNvPicPr>
+            <a:picLocks noChangeAspect="1"/>
+          </p:cNvPicPr>
+          <p:nvPr/>
+        </p:nvPicPr>
+        <p:blipFill>
+          <a:blip r:embed="rId2"/>
+          <a:stretch>
+            <a:fillRect/>
+          </a:stretch>
+        </p:blipFill>
+        <p:spPr>
+          <a:xfrm>
+            <a:off x="10953188" y="6236208"/>
+            <a:ext cx="872747" cy="566928"/>
+          </a:xfrm>
+          <a:prstGeom prst="rect">
+            <a:avLst/>
+          </a:prstGeom>
+        </p:spPr>
+      </p:pic>
+      <p:pic>
+        <p:nvPicPr>
+          <p:cNvPr id="6" name="Picture 5" descr="s10_pyramid.png"/>
+          <p:cNvPicPr>
+            <a:picLocks noChangeAspect="1"/>
+          </p:cNvPicPr>
+          <p:nvPr/>
+        </p:nvPicPr>
+        <p:blipFill>
+          <a:blip r:embed="rId3"/>
+          <a:stretch>
+            <a:fillRect/>
+          </a:stretch>
+        </p:blipFill>
+        <p:spPr>
+          <a:xfrm>
+            <a:off x="640080" y="1371600"/>
+            <a:ext cx="3657600" cy="3657600"/>
+          </a:xfrm>
+          <a:prstGeom prst="rect">
+            <a:avLst/>
+          </a:prstGeom>
+        </p:spPr>
+      </p:pic>
+      <p:sp>
+        <p:nvSpPr>
+          <p:cNvPr id="7" name="TextBox 6"/>
           <p:cNvSpPr txBox="1"/>
           <p:nvPr/>
         </p:nvSpPr>
         <p:spPr>
           <a:xfrm>
-            <a:off x="0" y="1371600"/>
-            <a:ext cx="12191695" cy="1188720"/>
+            <a:off x="4754880" y="1828800"/>
+            <a:ext cx="6979615" cy="548640"/>
+          </a:xfrm>
+          <a:prstGeom prst="rect">
+            <a:avLst/>
+          </a:prstGeom>
+          <a:noFill/>
+        </p:spPr>
+        <p:txBody>
+          <a:bodyPr wrap="none">
+            <a:spAutoFit/>
+          </a:bodyPr>
+          <a:lstStyle/>
+          <a:p>
+            <a:pPr algn="ctr"/>
+            <a:r>
+              <a:rPr sz="3200">
+                <a:solidFill>
+                  <a:srgbClr val="8A8F98"/>
+                </a:solidFill>
+                <a:latin typeface="Pretendard Light"/>
+                <a:ea typeface="Pretendard Light"/>
+                <a:cs typeface="Pretendard Light"/>
+              </a:rPr>
+              <a:t>그 위에</a:t>
+            </a:r>
+          </a:p>
+        </p:txBody>
+      </p:sp>
+      <p:sp>
+        <p:nvSpPr>
+          <p:cNvPr id="8" name="TextBox 7"/>
+          <p:cNvSpPr txBox="1"/>
+          <p:nvPr/>
+        </p:nvSpPr>
+        <p:spPr>
+          <a:xfrm>
+            <a:off x="4754880" y="2606040"/>
+            <a:ext cx="6979615" cy="3017520"/>
           </a:xfrm>
           <a:prstGeom prst="rect">
             <a:avLst/>
@@ -4037,7 +4570,7 @@
           <a:p>
             <a:pPr algn="ctr"/>
             <a:r>
-              <a:rPr sz="9600" spc="-336">
+              <a:rPr sz="22000" spc="-770">
                 <a:solidFill>
                   <a:srgbClr val="F7F8F8"/>
                 </a:solidFill>
@@ -4045,84 +4578,7 @@
                 <a:ea typeface="Pretendard Black"/>
                 <a:cs typeface="Pretendard Black"/>
               </a:rPr>
-              <a:t>우리 회사는?</a:t>
-            </a:r>
-          </a:p>
-        </p:txBody>
-      </p:sp>
-      <p:sp>
-        <p:nvSpPr>
-          <p:cNvPr id="4" name="TextBox 3"/>
-          <p:cNvSpPr txBox="1"/>
-          <p:nvPr/>
-        </p:nvSpPr>
-        <p:spPr>
-          <a:xfrm>
-            <a:off x="0" y="3383280"/>
-            <a:ext cx="12191695" cy="2743200"/>
-          </a:xfrm>
-          <a:prstGeom prst="rect">
-            <a:avLst/>
-          </a:prstGeom>
-          <a:noFill/>
-        </p:spPr>
-        <p:txBody>
-          <a:bodyPr wrap="none" anchor="t">
-            <a:spAutoFit/>
-          </a:bodyPr>
-          <a:lstStyle/>
-          <a:p>
-            <a:pPr algn="ctr">
-              <a:spcAft>
-                <a:spcPts val="1600"/>
-              </a:spcAft>
-            </a:pPr>
-            <a:r>
-              <a:rPr sz="3600">
-                <a:solidFill>
-                  <a:srgbClr val="8A8F98"/>
-                </a:solidFill>
-                <a:latin typeface="Pretendard Light"/>
-                <a:ea typeface="Pretendard Light"/>
-                <a:cs typeface="Pretendard Light"/>
-              </a:rPr>
-              <a:t>☐  SoR — 기록</a:t>
-            </a:r>
-          </a:p>
-          <a:p>
-            <a:pPr algn="ctr">
-              <a:spcAft>
-                <a:spcPts val="1600"/>
-              </a:spcAft>
-            </a:pPr>
-            <a:r>
-              <a:rPr sz="3600">
-                <a:solidFill>
-                  <a:srgbClr val="8A8F98"/>
-                </a:solidFill>
-                <a:latin typeface="Pretendard Light"/>
-                <a:ea typeface="Pretendard Light"/>
-                <a:cs typeface="Pretendard Light"/>
-              </a:rPr>
-              <a:t>☐  SoE — 참여</a:t>
-            </a:r>
-          </a:p>
-          <a:p>
-            <a:pPr algn="ctr">
-              <a:spcAft>
-                <a:spcPts val="1600"/>
-              </a:spcAft>
-            </a:pPr>
-            <a:r>
-              <a:rPr sz="3600">
-                <a:solidFill>
-                  <a:srgbClr val="8A8F98"/>
-                </a:solidFill>
-                <a:latin typeface="Pretendard Light"/>
-                <a:ea typeface="Pretendard Light"/>
-                <a:cs typeface="Pretendard Light"/>
-              </a:rPr>
-              <a:t>☐  SoI — 지능</a:t>
+              <a:t>+ AI</a:t>
             </a:r>
           </a:p>
         </p:txBody>
@@ -4188,6 +4644,181 @@
           </a:p>
         </p:txBody>
       </p:sp>
+      <p:sp>
+        <p:nvSpPr>
+          <p:cNvPr id="3" name="TextBox 2"/>
+          <p:cNvSpPr txBox="1"/>
+          <p:nvPr/>
+        </p:nvSpPr>
+        <p:spPr>
+          <a:xfrm>
+            <a:off x="0" y="1371600"/>
+            <a:ext cx="12191695" cy="1188720"/>
+          </a:xfrm>
+          <a:prstGeom prst="rect">
+            <a:avLst/>
+          </a:prstGeom>
+          <a:noFill/>
+        </p:spPr>
+        <p:txBody>
+          <a:bodyPr wrap="none" lIns="0" rIns="0" tIns="0" bIns="0" anchor="ctr">
+            <a:spAutoFit/>
+          </a:bodyPr>
+          <a:lstStyle/>
+          <a:p>
+            <a:pPr algn="ctr"/>
+            <a:r>
+              <a:rPr sz="9600" spc="-336">
+                <a:solidFill>
+                  <a:srgbClr val="F7F8F8"/>
+                </a:solidFill>
+                <a:latin typeface="Pretendard Black"/>
+                <a:ea typeface="Pretendard Black"/>
+                <a:cs typeface="Pretendard Black"/>
+              </a:rPr>
+              <a:t>우리 회사는?</a:t>
+            </a:r>
+          </a:p>
+        </p:txBody>
+      </p:sp>
+      <p:sp>
+        <p:nvSpPr>
+          <p:cNvPr id="4" name="TextBox 3"/>
+          <p:cNvSpPr txBox="1"/>
+          <p:nvPr/>
+        </p:nvSpPr>
+        <p:spPr>
+          <a:xfrm>
+            <a:off x="0" y="3383280"/>
+            <a:ext cx="12191695" cy="2743200"/>
+          </a:xfrm>
+          <a:prstGeom prst="rect">
+            <a:avLst/>
+          </a:prstGeom>
+          <a:noFill/>
+        </p:spPr>
+        <p:txBody>
+          <a:bodyPr wrap="none" anchor="t">
+            <a:spAutoFit/>
+          </a:bodyPr>
+          <a:lstStyle/>
+          <a:p>
+            <a:pPr algn="ctr">
+              <a:spcAft>
+                <a:spcPts val="1600"/>
+              </a:spcAft>
+            </a:pPr>
+            <a:r>
+              <a:rPr sz="3600">
+                <a:solidFill>
+                  <a:srgbClr val="8A8F98"/>
+                </a:solidFill>
+                <a:latin typeface="Pretendard Light"/>
+                <a:ea typeface="Pretendard Light"/>
+                <a:cs typeface="Pretendard Light"/>
+              </a:rPr>
+              <a:t>☐  SoR — 기록</a:t>
+            </a:r>
+          </a:p>
+          <a:p>
+            <a:pPr algn="ctr">
+              <a:spcAft>
+                <a:spcPts val="1600"/>
+              </a:spcAft>
+            </a:pPr>
+            <a:r>
+              <a:rPr sz="3600">
+                <a:solidFill>
+                  <a:srgbClr val="8A8F98"/>
+                </a:solidFill>
+                <a:latin typeface="Pretendard Light"/>
+                <a:ea typeface="Pretendard Light"/>
+                <a:cs typeface="Pretendard Light"/>
+              </a:rPr>
+              <a:t>☐  SoE — 참여</a:t>
+            </a:r>
+          </a:p>
+          <a:p>
+            <a:pPr algn="ctr">
+              <a:spcAft>
+                <a:spcPts val="1600"/>
+              </a:spcAft>
+            </a:pPr>
+            <a:r>
+              <a:rPr sz="3600">
+                <a:solidFill>
+                  <a:srgbClr val="8A8F98"/>
+                </a:solidFill>
+                <a:latin typeface="Pretendard Light"/>
+                <a:ea typeface="Pretendard Light"/>
+                <a:cs typeface="Pretendard Light"/>
+              </a:rPr>
+              <a:t>☐  SoI — 지능</a:t>
+            </a:r>
+          </a:p>
+        </p:txBody>
+      </p:sp>
+    </p:spTree>
+  </p:cSld>
+  <p:clrMapOvr>
+    <a:masterClrMapping/>
+  </p:clrMapOvr>
+</p:sld>
+</file>
+
+<file path=ppt/slides/slide14.xml><?xml version="1.0" encoding="utf-8"?>
+<p:sld xmlns:a="http://schemas.openxmlformats.org/drawingml/2006/main" xmlns:p="http://schemas.openxmlformats.org/presentationml/2006/main" xmlns:r="http://schemas.openxmlformats.org/officeDocument/2006/relationships">
+  <p:cSld>
+    <p:spTree>
+      <p:nvGrpSpPr>
+        <p:cNvPr id="1" name=""/>
+        <p:cNvGrpSpPr/>
+        <p:nvPr/>
+      </p:nvGrpSpPr>
+      <p:grpSpPr/>
+      <p:sp>
+        <p:nvSpPr>
+          <p:cNvPr id="2" name="Rectangle 1"/>
+          <p:cNvSpPr/>
+          <p:nvPr/>
+        </p:nvSpPr>
+        <p:spPr>
+          <a:xfrm>
+            <a:off x="0" y="0"/>
+            <a:ext cx="12191695" cy="6858000"/>
+          </a:xfrm>
+          <a:prstGeom prst="rect">
+            <a:avLst/>
+          </a:prstGeom>
+          <a:solidFill>
+            <a:srgbClr val="010102"/>
+          </a:solidFill>
+          <a:ln>
+            <a:noFill/>
+          </a:ln>
+        </p:spPr>
+        <p:style>
+          <a:lnRef idx="1">
+            <a:schemeClr val="accent1"/>
+          </a:lnRef>
+          <a:fillRef idx="3">
+            <a:schemeClr val="accent1"/>
+          </a:fillRef>
+          <a:effectRef idx="2">
+            <a:schemeClr val="accent1"/>
+          </a:effectRef>
+          <a:fontRef idx="minor">
+            <a:schemeClr val="lt1"/>
+          </a:fontRef>
+        </p:style>
+        <p:txBody>
+          <a:bodyPr rtlCol="0" anchor="ctr"/>
+          <a:lstStyle/>
+          <a:p>
+            <a:pPr algn="ctr"/>
+          </a:p>
+        </p:txBody>
+      </p:sp>
       <p:pic>
         <p:nvPicPr>
           <p:cNvPr id="3" name="Picture 2" descr="ssod-wordmark.png"/>
@@ -4398,7 +5029,7 @@
                 <a:ea typeface="SF Mono"/>
                 <a:cs typeface="SF Mono"/>
               </a:rPr>
-              <a:t>02 / 13</a:t>
+              <a:t>02 / 14</a:t>
             </a:r>
           </a:p>
         </p:txBody>
@@ -4672,7 +5303,7 @@
                 <a:ea typeface="SF Mono"/>
                 <a:cs typeface="SF Mono"/>
               </a:rPr>
-              <a:t>03 / 13</a:t>
+              <a:t>03 / 14</a:t>
             </a:r>
           </a:p>
         </p:txBody>
@@ -4924,7 +5555,7 @@
                 <a:ea typeface="SF Mono"/>
                 <a:cs typeface="SF Mono"/>
               </a:rPr>
-              <a:t>04 / 13</a:t>
+              <a:t>04 / 14</a:t>
             </a:r>
           </a:p>
         </p:txBody>
@@ -5224,7 +5855,7 @@
                 <a:ea typeface="SF Mono"/>
                 <a:cs typeface="SF Mono"/>
               </a:rPr>
-              <a:t>05 / 13</a:t>
+              <a:t>05 / 14</a:t>
             </a:r>
           </a:p>
         </p:txBody>
@@ -5498,7 +6129,7 @@
                 <a:ea typeface="SF Mono"/>
                 <a:cs typeface="SF Mono"/>
               </a:rPr>
-              <a:t>06 / 13</a:t>
+              <a:t>06 / 14</a:t>
             </a:r>
           </a:p>
         </p:txBody>
@@ -5535,45 +6166,8 @@
         </p:nvSpPr>
         <p:spPr>
           <a:xfrm>
-            <a:off x="0" y="2011680"/>
-            <a:ext cx="12191695" cy="2560320"/>
-          </a:xfrm>
-          <a:prstGeom prst="rect">
-            <a:avLst/>
-          </a:prstGeom>
-          <a:noFill/>
-        </p:spPr>
-        <p:txBody>
-          <a:bodyPr wrap="none" lIns="0" rIns="0" tIns="0" bIns="0" anchor="ctr">
-            <a:spAutoFit/>
-          </a:bodyPr>
-          <a:lstStyle/>
-          <a:p>
-            <a:pPr algn="ctr"/>
-            <a:r>
-              <a:rPr sz="20000" spc="-700">
-                <a:solidFill>
-                  <a:srgbClr val="F7F8F8"/>
-                </a:solidFill>
-                <a:latin typeface="Pretendard Black"/>
-                <a:ea typeface="Pretendard Black"/>
-                <a:cs typeface="Pretendard Black"/>
-              </a:rPr>
-              <a:t>DX · AX</a:t>
-            </a:r>
-          </a:p>
-        </p:txBody>
-      </p:sp>
-      <p:sp>
-        <p:nvSpPr>
-          <p:cNvPr id="7" name="TextBox 6"/>
-          <p:cNvSpPr txBox="1"/>
-          <p:nvPr/>
-        </p:nvSpPr>
-        <p:spPr>
-          <a:xfrm>
-            <a:off x="0" y="4937760"/>
-            <a:ext cx="12191695" cy="457200"/>
+            <a:off x="0" y="960120"/>
+            <a:ext cx="12191695" cy="365760"/>
           </a:xfrm>
           <a:prstGeom prst="rect">
             <a:avLst/>
@@ -5588,19 +6182,403 @@
           <a:p>
             <a:pPr algn="ctr"/>
             <a:r>
-              <a:rPr sz="2200">
+              <a:rPr sz="1100" spc="242">
                 <a:solidFill>
-                  <a:srgbClr val="8A8F98"/>
+                  <a:srgbClr val="62666D"/>
                 </a:solidFill>
-                <a:latin typeface="Pretendard Light"/>
-                <a:ea typeface="Pretendard Light"/>
-                <a:cs typeface="Pretendard Light"/>
+                <a:latin typeface="SF Mono"/>
+                <a:ea typeface="SF Mono"/>
+                <a:cs typeface="SF Mono"/>
               </a:rPr>
-              <a:t>Digital Transformation · AI Transformation</a:t>
-            </a:r>
-          </a:p>
-        </p:txBody>
-      </p:sp>
+              <a:t>TRUSTED BY</a:t>
+            </a:r>
+          </a:p>
+        </p:txBody>
+      </p:sp>
+      <p:pic>
+        <p:nvPicPr>
+          <p:cNvPr id="7" name="Picture 6" descr="standard-energy.png"/>
+          <p:cNvPicPr>
+            <a:picLocks noChangeAspect="1"/>
+          </p:cNvPicPr>
+          <p:nvPr/>
+        </p:nvPicPr>
+        <p:blipFill>
+          <a:blip r:embed="rId3"/>
+          <a:stretch>
+            <a:fillRect/>
+          </a:stretch>
+        </p:blipFill>
+        <p:spPr>
+          <a:xfrm>
+            <a:off x="853736" y="2105176"/>
+            <a:ext cx="2163410" cy="98757"/>
+          </a:xfrm>
+          <a:prstGeom prst="rect">
+            <a:avLst/>
+          </a:prstGeom>
+        </p:spPr>
+      </p:pic>
+      <p:pic>
+        <p:nvPicPr>
+          <p:cNvPr id="8" name="Picture 7" descr="photoism.png"/>
+          <p:cNvPicPr>
+            <a:picLocks noChangeAspect="1"/>
+          </p:cNvPicPr>
+          <p:nvPr/>
+        </p:nvPicPr>
+        <p:blipFill>
+          <a:blip r:embed="rId4"/>
+          <a:stretch>
+            <a:fillRect/>
+          </a:stretch>
+        </p:blipFill>
+        <p:spPr>
+          <a:xfrm>
+            <a:off x="3627340" y="1936853"/>
+            <a:ext cx="2163410" cy="435403"/>
+          </a:xfrm>
+          <a:prstGeom prst="rect">
+            <a:avLst/>
+          </a:prstGeom>
+        </p:spPr>
+      </p:pic>
+      <p:pic>
+        <p:nvPicPr>
+          <p:cNvPr id="9" name="Picture 8" descr="anjeong.png"/>
+          <p:cNvPicPr>
+            <a:picLocks noChangeAspect="1"/>
+          </p:cNvPicPr>
+          <p:nvPr/>
+        </p:nvPicPr>
+        <p:blipFill>
+          <a:blip r:embed="rId5"/>
+          <a:stretch>
+            <a:fillRect/>
+          </a:stretch>
+        </p:blipFill>
+        <p:spPr>
+          <a:xfrm>
+            <a:off x="6400944" y="1849580"/>
+            <a:ext cx="2163410" cy="609948"/>
+          </a:xfrm>
+          <a:prstGeom prst="rect">
+            <a:avLst/>
+          </a:prstGeom>
+        </p:spPr>
+      </p:pic>
+      <p:pic>
+        <p:nvPicPr>
+          <p:cNvPr id="10" name="Picture 9" descr="모멘텀HR.png"/>
+          <p:cNvPicPr>
+            <a:picLocks noChangeAspect="1"/>
+          </p:cNvPicPr>
+          <p:nvPr/>
+        </p:nvPicPr>
+        <p:blipFill>
+          <a:blip r:embed="rId6"/>
+          <a:stretch>
+            <a:fillRect/>
+          </a:stretch>
+        </p:blipFill>
+        <p:spPr>
+          <a:xfrm>
+            <a:off x="9174547" y="1884880"/>
+            <a:ext cx="2163410" cy="539348"/>
+          </a:xfrm>
+          <a:prstGeom prst="rect">
+            <a:avLst/>
+          </a:prstGeom>
+        </p:spPr>
+      </p:pic>
+      <p:pic>
+        <p:nvPicPr>
+          <p:cNvPr id="11" name="Picture 10" descr="sonicsleep.png"/>
+          <p:cNvPicPr>
+            <a:picLocks noChangeAspect="1"/>
+          </p:cNvPicPr>
+          <p:nvPr/>
+        </p:nvPicPr>
+        <p:blipFill>
+          <a:blip r:embed="rId7"/>
+          <a:stretch>
+            <a:fillRect/>
+          </a:stretch>
+        </p:blipFill>
+        <p:spPr>
+          <a:xfrm>
+            <a:off x="853736" y="2978371"/>
+            <a:ext cx="2163410" cy="569787"/>
+          </a:xfrm>
+          <a:prstGeom prst="rect">
+            <a:avLst/>
+          </a:prstGeom>
+        </p:spPr>
+      </p:pic>
+      <p:pic>
+        <p:nvPicPr>
+          <p:cNvPr id="12" name="Picture 11" descr="romer.png"/>
+          <p:cNvPicPr>
+            <a:picLocks noChangeAspect="1"/>
+          </p:cNvPicPr>
+          <p:nvPr/>
+        </p:nvPicPr>
+        <p:blipFill>
+          <a:blip r:embed="rId8"/>
+          <a:stretch>
+            <a:fillRect/>
+          </a:stretch>
+        </p:blipFill>
+        <p:spPr>
+          <a:xfrm>
+            <a:off x="3627340" y="3033267"/>
+            <a:ext cx="2163410" cy="459994"/>
+          </a:xfrm>
+          <a:prstGeom prst="rect">
+            <a:avLst/>
+          </a:prstGeom>
+        </p:spPr>
+      </p:pic>
+      <p:pic>
+        <p:nvPicPr>
+          <p:cNvPr id="13" name="Picture 12" descr="ssalssalssal.png"/>
+          <p:cNvPicPr>
+            <a:picLocks noChangeAspect="1"/>
+          </p:cNvPicPr>
+          <p:nvPr/>
+        </p:nvPicPr>
+        <p:blipFill>
+          <a:blip r:embed="rId9"/>
+          <a:stretch>
+            <a:fillRect/>
+          </a:stretch>
+        </p:blipFill>
+        <p:spPr>
+          <a:xfrm>
+            <a:off x="7043496" y="2902934"/>
+            <a:ext cx="878306" cy="720661"/>
+          </a:xfrm>
+          <a:prstGeom prst="rect">
+            <a:avLst/>
+          </a:prstGeom>
+        </p:spPr>
+      </p:pic>
+      <p:pic>
+        <p:nvPicPr>
+          <p:cNvPr id="14" name="Picture 13" descr="지산손해사정법인.png"/>
+          <p:cNvPicPr>
+            <a:picLocks noChangeAspect="1"/>
+          </p:cNvPicPr>
+          <p:nvPr/>
+        </p:nvPicPr>
+        <p:blipFill>
+          <a:blip r:embed="rId10"/>
+          <a:stretch>
+            <a:fillRect/>
+          </a:stretch>
+        </p:blipFill>
+        <p:spPr>
+          <a:xfrm>
+            <a:off x="9174547" y="3063217"/>
+            <a:ext cx="2163410" cy="400095"/>
+          </a:xfrm>
+          <a:prstGeom prst="rect">
+            <a:avLst/>
+          </a:prstGeom>
+        </p:spPr>
+      </p:pic>
+      <p:pic>
+        <p:nvPicPr>
+          <p:cNvPr id="15" name="Picture 14" descr="deeplogic.png"/>
+          <p:cNvPicPr>
+            <a:picLocks noChangeAspect="1"/>
+          </p:cNvPicPr>
+          <p:nvPr/>
+        </p:nvPicPr>
+        <p:blipFill>
+          <a:blip r:embed="rId11"/>
+          <a:stretch>
+            <a:fillRect/>
+          </a:stretch>
+        </p:blipFill>
+        <p:spPr>
+          <a:xfrm>
+            <a:off x="853736" y="4216752"/>
+            <a:ext cx="2163410" cy="310444"/>
+          </a:xfrm>
+          <a:prstGeom prst="rect">
+            <a:avLst/>
+          </a:prstGeom>
+        </p:spPr>
+      </p:pic>
+      <p:pic>
+        <p:nvPicPr>
+          <p:cNvPr id="16" name="Picture 15" descr="gamdong.png"/>
+          <p:cNvPicPr>
+            <a:picLocks noChangeAspect="1"/>
+          </p:cNvPicPr>
+          <p:nvPr/>
+        </p:nvPicPr>
+        <p:blipFill>
+          <a:blip r:embed="rId12"/>
+          <a:stretch>
+            <a:fillRect/>
+          </a:stretch>
+        </p:blipFill>
+        <p:spPr>
+          <a:xfrm>
+            <a:off x="3627340" y="4035911"/>
+            <a:ext cx="2163410" cy="672127"/>
+          </a:xfrm>
+          <a:prstGeom prst="rect">
+            <a:avLst/>
+          </a:prstGeom>
+        </p:spPr>
+      </p:pic>
+      <p:pic>
+        <p:nvPicPr>
+          <p:cNvPr id="17" name="Picture 16" descr="ddoksori.png"/>
+          <p:cNvPicPr>
+            <a:picLocks noChangeAspect="1"/>
+          </p:cNvPicPr>
+          <p:nvPr/>
+        </p:nvPicPr>
+        <p:blipFill>
+          <a:blip r:embed="rId13"/>
+          <a:stretch>
+            <a:fillRect/>
+          </a:stretch>
+        </p:blipFill>
+        <p:spPr>
+          <a:xfrm>
+            <a:off x="6491739" y="4011644"/>
+            <a:ext cx="1981819" cy="720661"/>
+          </a:xfrm>
+          <a:prstGeom prst="rect">
+            <a:avLst/>
+          </a:prstGeom>
+        </p:spPr>
+      </p:pic>
+      <p:pic>
+        <p:nvPicPr>
+          <p:cNvPr id="18" name="Picture 17" descr="쿠메푸드.png"/>
+          <p:cNvPicPr>
+            <a:picLocks noChangeAspect="1"/>
+          </p:cNvPicPr>
+          <p:nvPr/>
+        </p:nvPicPr>
+        <p:blipFill>
+          <a:blip r:embed="rId14"/>
+          <a:stretch>
+            <a:fillRect/>
+          </a:stretch>
+        </p:blipFill>
+        <p:spPr>
+          <a:xfrm>
+            <a:off x="9868939" y="4011644"/>
+            <a:ext cx="774628" cy="720661"/>
+          </a:xfrm>
+          <a:prstGeom prst="rect">
+            <a:avLst/>
+          </a:prstGeom>
+        </p:spPr>
+      </p:pic>
+      <p:pic>
+        <p:nvPicPr>
+          <p:cNvPr id="19" name="Picture 18" descr="cupora.png"/>
+          <p:cNvPicPr>
+            <a:picLocks noChangeAspect="1"/>
+          </p:cNvPicPr>
+          <p:nvPr/>
+        </p:nvPicPr>
+        <p:blipFill>
+          <a:blip r:embed="rId15"/>
+          <a:stretch>
+            <a:fillRect/>
+          </a:stretch>
+        </p:blipFill>
+        <p:spPr>
+          <a:xfrm>
+            <a:off x="1099474" y="5120354"/>
+            <a:ext cx="1671934" cy="720661"/>
+          </a:xfrm>
+          <a:prstGeom prst="rect">
+            <a:avLst/>
+          </a:prstGeom>
+        </p:spPr>
+      </p:pic>
+      <p:pic>
+        <p:nvPicPr>
+          <p:cNvPr id="20" name="Picture 19" descr="스튜디오에디.png"/>
+          <p:cNvPicPr>
+            <a:picLocks noChangeAspect="1"/>
+          </p:cNvPicPr>
+          <p:nvPr/>
+        </p:nvPicPr>
+        <p:blipFill>
+          <a:blip r:embed="rId16"/>
+          <a:stretch>
+            <a:fillRect/>
+          </a:stretch>
+        </p:blipFill>
+        <p:spPr>
+          <a:xfrm>
+            <a:off x="4215635" y="5120354"/>
+            <a:ext cx="986819" cy="720661"/>
+          </a:xfrm>
+          <a:prstGeom prst="rect">
+            <a:avLst/>
+          </a:prstGeom>
+        </p:spPr>
+      </p:pic>
+      <p:pic>
+        <p:nvPicPr>
+          <p:cNvPr id="21" name="Picture 20" descr="핏틀리.png"/>
+          <p:cNvPicPr>
+            <a:picLocks noChangeAspect="1"/>
+          </p:cNvPicPr>
+          <p:nvPr/>
+        </p:nvPicPr>
+        <p:blipFill>
+          <a:blip r:embed="rId17"/>
+          <a:stretch>
+            <a:fillRect/>
+          </a:stretch>
+        </p:blipFill>
+        <p:spPr>
+          <a:xfrm>
+            <a:off x="6400944" y="5303105"/>
+            <a:ext cx="2163410" cy="355159"/>
+          </a:xfrm>
+          <a:prstGeom prst="rect">
+            <a:avLst/>
+          </a:prstGeom>
+        </p:spPr>
+      </p:pic>
+      <p:pic>
+        <p:nvPicPr>
+          <p:cNvPr id="22" name="Picture 21" descr="뉴레드.png"/>
+          <p:cNvPicPr>
+            <a:picLocks noChangeAspect="1"/>
+          </p:cNvPicPr>
+          <p:nvPr/>
+        </p:nvPicPr>
+        <p:blipFill>
+          <a:blip r:embed="rId18"/>
+          <a:stretch>
+            <a:fillRect/>
+          </a:stretch>
+        </p:blipFill>
+        <p:spPr>
+          <a:xfrm>
+            <a:off x="9598612" y="5120354"/>
+            <a:ext cx="1315281" cy="720661"/>
+          </a:xfrm>
+          <a:prstGeom prst="rect">
+            <a:avLst/>
+          </a:prstGeom>
+        </p:spPr>
+      </p:pic>
     </p:spTree>
   </p:cSld>
   <p:clrMapOvr>
@@ -5750,7 +6728,7 @@
                 <a:ea typeface="SF Mono"/>
                 <a:cs typeface="SF Mono"/>
               </a:rPr>
-              <a:t>07 / 13</a:t>
+              <a:t>07 / 14</a:t>
             </a:r>
           </a:p>
         </p:txBody>
@@ -5787,8 +6765,8 @@
         </p:nvSpPr>
         <p:spPr>
           <a:xfrm>
-            <a:off x="0" y="1463040"/>
-            <a:ext cx="12191695" cy="2377440"/>
+            <a:off x="0" y="2011680"/>
+            <a:ext cx="12191695" cy="2560320"/>
           </a:xfrm>
           <a:prstGeom prst="rect">
             <a:avLst/>
@@ -5811,7 +6789,7 @@
                 <a:ea typeface="Pretendard Black"/>
                 <a:cs typeface="Pretendard Black"/>
               </a:rPr>
-              <a:t>SoR</a:t>
+              <a:t>DX · AX</a:t>
             </a:r>
           </a:p>
         </p:txBody>
@@ -5824,7 +6802,7 @@
         </p:nvSpPr>
         <p:spPr>
           <a:xfrm>
-            <a:off x="0" y="4069080"/>
+            <a:off x="0" y="4937760"/>
             <a:ext cx="12191695" cy="457200"/>
           </a:xfrm>
           <a:prstGeom prst="rect">
@@ -5840,7 +6818,7 @@
           <a:p>
             <a:pPr algn="ctr"/>
             <a:r>
-              <a:rPr sz="4400">
+              <a:rPr sz="2200">
                 <a:solidFill>
                   <a:srgbClr val="8A8F98"/>
                 </a:solidFill>
@@ -5848,81 +6826,7 @@
                 <a:ea typeface="Pretendard Light"/>
                 <a:cs typeface="Pretendard Light"/>
               </a:rPr>
-              <a:t>기록</a:t>
-            </a:r>
-          </a:p>
-        </p:txBody>
-      </p:sp>
-      <p:sp>
-        <p:nvSpPr>
-          <p:cNvPr id="8" name="TextBox 7"/>
-          <p:cNvSpPr txBox="1"/>
-          <p:nvPr/>
-        </p:nvSpPr>
-        <p:spPr>
-          <a:xfrm>
-            <a:off x="0" y="4709160"/>
-            <a:ext cx="12191695" cy="457200"/>
-          </a:xfrm>
-          <a:prstGeom prst="rect">
-            <a:avLst/>
-          </a:prstGeom>
-          <a:noFill/>
-        </p:spPr>
-        <p:txBody>
-          <a:bodyPr wrap="none">
-            <a:spAutoFit/>
-          </a:bodyPr>
-          <a:lstStyle/>
-          <a:p>
-            <a:pPr algn="ctr"/>
-            <a:r>
-              <a:rPr sz="2200">
-                <a:solidFill>
-                  <a:srgbClr val="F7F8F8"/>
-                </a:solidFill>
-                <a:latin typeface="Pretendard Light"/>
-                <a:ea typeface="Pretendard Light"/>
-                <a:cs typeface="Pretendard Light"/>
-              </a:rPr>
-              <a:t>회사의 거래·사실이 권위 있게 적힌 자리</a:t>
-            </a:r>
-          </a:p>
-        </p:txBody>
-      </p:sp>
-      <p:sp>
-        <p:nvSpPr>
-          <p:cNvPr id="9" name="TextBox 8"/>
-          <p:cNvSpPr txBox="1"/>
-          <p:nvPr/>
-        </p:nvSpPr>
-        <p:spPr>
-          <a:xfrm>
-            <a:off x="0" y="5349240"/>
-            <a:ext cx="12191695" cy="457200"/>
-          </a:xfrm>
-          <a:prstGeom prst="rect">
-            <a:avLst/>
-          </a:prstGeom>
-          <a:noFill/>
-        </p:spPr>
-        <p:txBody>
-          <a:bodyPr wrap="none">
-            <a:spAutoFit/>
-          </a:bodyPr>
-          <a:lstStyle/>
-          <a:p>
-            <a:pPr algn="ctr"/>
-            <a:r>
-              <a:rPr sz="1800">
-                <a:solidFill>
-                  <a:srgbClr val="8A8F98"/>
-                </a:solidFill>
-                <a:latin typeface="Pretendard Light"/>
-                <a:ea typeface="Pretendard Light"/>
-                <a:cs typeface="Pretendard Light"/>
-              </a:rPr>
-              <a:t>ERP · CRM · 매출</a:t>
+              <a:t>Digital Transformation · AI Transformation</a:t>
             </a:r>
           </a:p>
         </p:txBody>
@@ -6076,7 +6980,7 @@
                 <a:ea typeface="SF Mono"/>
                 <a:cs typeface="SF Mono"/>
               </a:rPr>
-              <a:t>08 / 13</a:t>
+              <a:t>08 / 14</a:t>
             </a:r>
           </a:p>
         </p:txBody>
@@ -6105,16 +7009,40 @@
           </a:prstGeom>
         </p:spPr>
       </p:pic>
-      <p:sp>
-        <p:nvSpPr>
-          <p:cNvPr id="6" name="TextBox 5"/>
+      <p:pic>
+        <p:nvPicPr>
+          <p:cNvPr id="6" name="Picture 5" descr="s10_pyramid.png"/>
+          <p:cNvPicPr>
+            <a:picLocks noChangeAspect="1"/>
+          </p:cNvPicPr>
+          <p:nvPr/>
+        </p:nvPicPr>
+        <p:blipFill>
+          <a:blip r:embed="rId3"/>
+          <a:stretch>
+            <a:fillRect/>
+          </a:stretch>
+        </p:blipFill>
+        <p:spPr>
+          <a:xfrm>
+            <a:off x="640080" y="868680"/>
+            <a:ext cx="4572000" cy="4572000"/>
+          </a:xfrm>
+          <a:prstGeom prst="rect">
+            <a:avLst/>
+          </a:prstGeom>
+        </p:spPr>
+      </p:pic>
+      <p:sp>
+        <p:nvSpPr>
+          <p:cNvPr id="7" name="TextBox 6"/>
           <p:cNvSpPr txBox="1"/>
           <p:nvPr/>
         </p:nvSpPr>
         <p:spPr>
           <a:xfrm>
-            <a:off x="0" y="1463040"/>
-            <a:ext cx="12191695" cy="2377440"/>
+            <a:off x="5943600" y="1432560"/>
+            <a:ext cx="5760720" cy="1005840"/>
           </a:xfrm>
           <a:prstGeom prst="rect">
             <a:avLst/>
@@ -6122,14 +7050,98 @@
           <a:noFill/>
         </p:spPr>
         <p:txBody>
-          <a:bodyPr wrap="none" lIns="0" rIns="0" tIns="0" bIns="0" anchor="ctr">
+          <a:bodyPr wrap="square" lIns="0" rIns="0" tIns="0" bIns="0" anchor="ctr">
             <a:spAutoFit/>
           </a:bodyPr>
           <a:lstStyle/>
           <a:p>
-            <a:pPr algn="ctr"/>
-            <a:r>
-              <a:rPr sz="20000" spc="-700">
+            <a:pPr algn="l"/>
+            <a:r>
+              <a:rPr sz="1100" spc="242">
+                <a:solidFill>
+                  <a:srgbClr val="62666D"/>
+                </a:solidFill>
+                <a:latin typeface="SF Mono"/>
+                <a:ea typeface="SF Mono"/>
+                <a:cs typeface="SF Mono"/>
+              </a:rPr>
+              <a:t>LAYER 03</a:t>
+            </a:r>
+          </a:p>
+          <a:p>
+            <a:pPr algn="l">
+              <a:spcBef>
+                <a:spcPts val="600"/>
+              </a:spcBef>
+            </a:pPr>
+            <a:r>
+              <a:rPr sz="4800" spc="-168">
+                <a:solidFill>
+                  <a:srgbClr val="F7F8F8"/>
+                </a:solidFill>
+                <a:latin typeface="Pretendard Black"/>
+                <a:ea typeface="Pretendard Black"/>
+                <a:cs typeface="Pretendard Black"/>
+              </a:rPr>
+              <a:t>SoI</a:t>
+            </a:r>
+            <a:r>
+              <a:rPr sz="2400">
+                <a:solidFill>
+                  <a:srgbClr val="8A8F98"/>
+                </a:solidFill>
+                <a:latin typeface="Pretendard Light"/>
+                <a:ea typeface="Pretendard Light"/>
+                <a:cs typeface="Pretendard Light"/>
+              </a:rPr>
+              <a:t>   지능</a:t>
+            </a:r>
+          </a:p>
+        </p:txBody>
+      </p:sp>
+      <p:sp>
+        <p:nvSpPr>
+          <p:cNvPr id="8" name="TextBox 7"/>
+          <p:cNvSpPr txBox="1"/>
+          <p:nvPr/>
+        </p:nvSpPr>
+        <p:spPr>
+          <a:xfrm>
+            <a:off x="5943600" y="2651760"/>
+            <a:ext cx="5760720" cy="1005840"/>
+          </a:xfrm>
+          <a:prstGeom prst="rect">
+            <a:avLst/>
+          </a:prstGeom>
+          <a:noFill/>
+        </p:spPr>
+        <p:txBody>
+          <a:bodyPr wrap="square" lIns="0" rIns="0" tIns="0" bIns="0" anchor="ctr">
+            <a:spAutoFit/>
+          </a:bodyPr>
+          <a:lstStyle/>
+          <a:p>
+            <a:pPr algn="l"/>
+            <a:r>
+              <a:rPr sz="1100" spc="242">
+                <a:solidFill>
+                  <a:srgbClr val="62666D"/>
+                </a:solidFill>
+                <a:latin typeface="SF Mono"/>
+                <a:ea typeface="SF Mono"/>
+                <a:cs typeface="SF Mono"/>
+              </a:rPr>
+              <a:t>LAYER 02</a:t>
+            </a:r>
+          </a:p>
+          <a:p>
+            <a:pPr algn="l">
+              <a:spcBef>
+                <a:spcPts val="600"/>
+              </a:spcBef>
+            </a:pPr>
+            <a:r>
+              <a:rPr sz="4800" spc="-168">
                 <a:solidFill>
                   <a:srgbClr val="F7F8F8"/>
                 </a:solidFill>
@@ -6139,34 +7151,8 @@
               </a:rPr>
               <a:t>SoE</a:t>
             </a:r>
-          </a:p>
-        </p:txBody>
-      </p:sp>
-      <p:sp>
-        <p:nvSpPr>
-          <p:cNvPr id="7" name="TextBox 6"/>
-          <p:cNvSpPr txBox="1"/>
-          <p:nvPr/>
-        </p:nvSpPr>
-        <p:spPr>
-          <a:xfrm>
-            <a:off x="0" y="4069080"/>
-            <a:ext cx="12191695" cy="457200"/>
-          </a:xfrm>
-          <a:prstGeom prst="rect">
-            <a:avLst/>
-          </a:prstGeom>
-          <a:noFill/>
-        </p:spPr>
-        <p:txBody>
-          <a:bodyPr wrap="none">
-            <a:spAutoFit/>
-          </a:bodyPr>
-          <a:lstStyle/>
-          <a:p>
-            <a:pPr algn="ctr"/>
-            <a:r>
-              <a:rPr sz="4400">
+            <a:r>
+              <a:rPr sz="2400">
                 <a:solidFill>
                   <a:srgbClr val="8A8F98"/>
                 </a:solidFill>
@@ -6174,21 +7160,21 @@
                 <a:ea typeface="Pretendard Light"/>
                 <a:cs typeface="Pretendard Light"/>
               </a:rPr>
-              <a:t>참여</a:t>
-            </a:r>
-          </a:p>
-        </p:txBody>
-      </p:sp>
-      <p:sp>
-        <p:nvSpPr>
-          <p:cNvPr id="8" name="TextBox 7"/>
+              <a:t>   참여</a:t>
+            </a:r>
+          </a:p>
+        </p:txBody>
+      </p:sp>
+      <p:sp>
+        <p:nvSpPr>
+          <p:cNvPr id="9" name="TextBox 8"/>
           <p:cNvSpPr txBox="1"/>
           <p:nvPr/>
         </p:nvSpPr>
         <p:spPr>
           <a:xfrm>
-            <a:off x="0" y="4709160"/>
-            <a:ext cx="12191695" cy="457200"/>
+            <a:off x="5943600" y="3870960"/>
+            <a:ext cx="5760720" cy="1005840"/>
           </a:xfrm>
           <a:prstGeom prst="rect">
             <a:avLst/>
@@ -6196,51 +7182,43 @@
           <a:noFill/>
         </p:spPr>
         <p:txBody>
-          <a:bodyPr wrap="none">
+          <a:bodyPr wrap="square" lIns="0" rIns="0" tIns="0" bIns="0" anchor="ctr">
             <a:spAutoFit/>
           </a:bodyPr>
           <a:lstStyle/>
           <a:p>
-            <a:pPr algn="ctr"/>
-            <a:r>
-              <a:rPr sz="2200">
+            <a:pPr algn="l"/>
+            <a:r>
+              <a:rPr sz="1100" spc="242">
+                <a:solidFill>
+                  <a:srgbClr val="62666D"/>
+                </a:solidFill>
+                <a:latin typeface="SF Mono"/>
+                <a:ea typeface="SF Mono"/>
+                <a:cs typeface="SF Mono"/>
+              </a:rPr>
+              <a:t>LAYER 01</a:t>
+            </a:r>
+          </a:p>
+          <a:p>
+            <a:pPr algn="l">
+              <a:spcBef>
+                <a:spcPts val="600"/>
+              </a:spcBef>
+            </a:pPr>
+            <a:r>
+              <a:rPr sz="4800" spc="-168">
                 <a:solidFill>
                   <a:srgbClr val="F7F8F8"/>
                 </a:solidFill>
-                <a:latin typeface="Pretendard Light"/>
-                <a:ea typeface="Pretendard Light"/>
-                <a:cs typeface="Pretendard Light"/>
+                <a:latin typeface="Pretendard Black"/>
+                <a:ea typeface="Pretendard Black"/>
+                <a:cs typeface="Pretendard Black"/>
               </a:rPr>
-              <a:t>사람의 상호작용·협업이 일어나는 자리</a:t>
-            </a:r>
-          </a:p>
-        </p:txBody>
-      </p:sp>
-      <p:sp>
-        <p:nvSpPr>
-          <p:cNvPr id="9" name="TextBox 8"/>
-          <p:cNvSpPr txBox="1"/>
-          <p:nvPr/>
-        </p:nvSpPr>
-        <p:spPr>
-          <a:xfrm>
-            <a:off x="0" y="5349240"/>
-            <a:ext cx="12191695" cy="457200"/>
-          </a:xfrm>
-          <a:prstGeom prst="rect">
-            <a:avLst/>
-          </a:prstGeom>
-          <a:noFill/>
-        </p:spPr>
-        <p:txBody>
-          <a:bodyPr wrap="none">
-            <a:spAutoFit/>
-          </a:bodyPr>
-          <a:lstStyle/>
-          <a:p>
-            <a:pPr algn="ctr"/>
-            <a:r>
-              <a:rPr sz="1800">
+              <a:t>SoR</a:t>
+            </a:r>
+            <a:r>
+              <a:rPr sz="2400">
                 <a:solidFill>
                   <a:srgbClr val="8A8F98"/>
                 </a:solidFill>
@@ -6248,7 +7226,7 @@
                 <a:ea typeface="Pretendard Light"/>
                 <a:cs typeface="Pretendard Light"/>
               </a:rPr>
-              <a:t>카톡 · 노션 · 메일</a:t>
+              <a:t>   기록</a:t>
             </a:r>
           </a:p>
         </p:txBody>
@@ -6402,7 +7380,7 @@
                 <a:ea typeface="SF Mono"/>
                 <a:cs typeface="SF Mono"/>
               </a:rPr>
-              <a:t>09 / 13</a:t>
+              <a:t>09 / 14</a:t>
             </a:r>
           </a:p>
         </p:txBody>
@@ -6463,7 +7441,7 @@
                 <a:ea typeface="Pretendard Black"/>
                 <a:cs typeface="Pretendard Black"/>
               </a:rPr>
-              <a:t>SoI</a:t>
+              <a:t>SoR</a:t>
             </a:r>
           </a:p>
         </p:txBody>
@@ -6500,7 +7478,7 @@
                 <a:ea typeface="Pretendard Light"/>
                 <a:cs typeface="Pretendard Light"/>
               </a:rPr>
-              <a:t>지능</a:t>
+              <a:t>기록</a:t>
             </a:r>
           </a:p>
         </p:txBody>
@@ -6537,7 +7515,7 @@
                 <a:ea typeface="Pretendard Light"/>
                 <a:cs typeface="Pretendard Light"/>
               </a:rPr>
-              <a:t>여러 기록을 합쳐 AI가 결정을 만드는 자리</a:t>
+              <a:t>회사의 거래·사실이 권위 있게 적힌 자리</a:t>
             </a:r>
           </a:p>
         </p:txBody>
@@ -6574,7 +7552,7 @@
                 <a:ea typeface="Pretendard Light"/>
                 <a:cs typeface="Pretendard Light"/>
               </a:rPr>
-              <a:t>BI · 대시보드 · AI</a:t>
+              <a:t>ERP · CRM · 매출</a:t>
             </a:r>
           </a:p>
         </p:txBody>

</xml_diff>